<commit_message>
update to course project.
</commit_message>
<xml_diff>
--- a/docs/lecture_slides/Week 1/Week1_Lecture1_Slides_1_10_2024.pptx
+++ b/docs/lecture_slides/Week 1/Week1_Lecture1_Slides_1_10_2024.pptx
@@ -6,6 +6,7 @@
   </p:sldMasterIdLst>
   <p:sldIdLst>
     <p:sldId id="258" r:id="rId2"/>
+    <p:sldId id="286" r:id="rId19"/>
     <p:sldId id="285" r:id="rId3"/>
     <p:sldId id="257" r:id="rId4"/>
     <p:sldId id="261" r:id="rId5"/>
@@ -6683,28 +6684,22 @@
       </p:sp>
       <p:pic>
         <p:nvPicPr>
-          <p:cNvPr id="6" name="Picture 5">
-            <a:extLst>
-              <a:ext uri="{FF2B5EF4-FFF2-40B4-BE49-F238E27FC236}">
-                <a16:creationId xmlns:a16="http://schemas.microsoft.com/office/drawing/2014/main" id="{73D86D3A-48E0-89C8-3640-B33F0F02AF96}"/>
-              </a:ext>
-            </a:extLst>
-          </p:cNvPr>
+          <p:cNvPr id="10" name="Picture 9" descr="job_pie.png"/>
           <p:cNvPicPr>
             <a:picLocks noChangeAspect="1"/>
           </p:cNvPicPr>
           <p:nvPr/>
         </p:nvPicPr>
         <p:blipFill>
-          <a:blip r:embed="rId5"/>
+          <a:blip r:embed="rId6"/>
           <a:stretch>
             <a:fillRect/>
           </a:stretch>
         </p:blipFill>
         <p:spPr>
           <a:xfrm>
-            <a:off x="7467600" y="1323704"/>
-            <a:ext cx="4200525" cy="3102324"/>
+            <a:off x="7470648" y="1325880"/>
+            <a:ext cx="4197096" cy="3099791"/>
           </a:xfrm>
           <a:prstGeom prst="rect">
             <a:avLst/>
@@ -6826,63 +6821,14 @@
                 </a:solidFill>
                 <a:latin typeface="Calibri" panose="020F0502020204030204"/>
               </a:rPr>
-              <a:t>In the stormtrooper example data</a:t>
-            </a:r>
-            <a:r>
-              <a:rPr kumimoji="0" lang="it-IT" sz="2000" b="0" i="0" u="none" strike="noStrike" kern="1200" cap="none" spc="0" normalizeH="0" baseline="0" noProof="0" dirty="0">
-                <a:ln>
-                  <a:noFill/>
-                </a:ln>
-                <a:solidFill>
-                  <a:prstClr val="black"/>
-                </a:solidFill>
-                <a:effectLst/>
-                <a:uLnTx/>
-                <a:uFillTx/>
-                <a:latin typeface="Calibri" panose="020F0502020204030204"/>
-                <a:ea typeface="+mn-ea"/>
-                <a:cs typeface="+mn-cs"/>
-              </a:rPr>
-              <a:t>, which variable(s) are </a:t>
-            </a:r>
-            <a:r>
-              <a:rPr lang="it-IT" sz="2000" dirty="0">
-                <a:solidFill>
-                  <a:prstClr val="black"/>
-                </a:solidFill>
-                <a:latin typeface="Calibri" panose="020F0502020204030204"/>
-              </a:rPr>
-              <a:t>qualitative nominal and which are qualitative ordinal</a:t>
-            </a:r>
-            <a:r>
-              <a:rPr kumimoji="0" lang="it-IT" sz="2000" b="0" i="0" u="none" strike="noStrike" kern="1200" cap="none" spc="0" normalizeH="0" baseline="0" noProof="0" dirty="0">
-                <a:ln>
-                  <a:noFill/>
-                </a:ln>
-                <a:solidFill>
-                  <a:prstClr val="black"/>
-                </a:solidFill>
-                <a:effectLst/>
-                <a:uLnTx/>
-                <a:uFillTx/>
-                <a:latin typeface="Calibri" panose="020F0502020204030204"/>
-                <a:ea typeface="+mn-ea"/>
-                <a:cs typeface="+mn-cs"/>
-              </a:rPr>
-              <a:t>?</a:t>
+              <a:t>In the bank marketing example data, which variable(s) are qualitative nominal and which are qualitative ordinal?</a:t>
             </a:r>
           </a:p>
         </p:txBody>
       </p:sp>
       <p:pic>
         <p:nvPicPr>
-          <p:cNvPr id="7" name="Picture 6">
-            <a:extLst>
-              <a:ext uri="{FF2B5EF4-FFF2-40B4-BE49-F238E27FC236}">
-                <a16:creationId xmlns:a16="http://schemas.microsoft.com/office/drawing/2014/main" id="{601CAD31-57A4-CBBF-9639-97A3E77506B5}"/>
-              </a:ext>
-            </a:extLst>
-          </p:cNvPr>
+          <p:cNvPr id="11" name="Picture 10" descr="image.png"/>
           <p:cNvPicPr>
             <a:picLocks noChangeAspect="1"/>
           </p:cNvPicPr>
@@ -6896,8 +6842,8 @@
         </p:blipFill>
         <p:spPr>
           <a:xfrm>
-            <a:off x="4793382" y="1609724"/>
-            <a:ext cx="7175376" cy="5000625"/>
+            <a:off x="4846320" y="1554480"/>
+            <a:ext cx="7040880" cy="4437221"/>
           </a:xfrm>
           <a:prstGeom prst="rect">
             <a:avLst/>
@@ -6938,7 +6884,7 @@
                   <a:srgbClr val="FF0000"/>
                 </a:solidFill>
               </a:rPr>
-              <a:t>Qualitative nominal: ID Number, Duty Posting</a:t>
+              <a:t>Qualitative nominal: Client ID, Job, Subscribed</a:t>
             </a:r>
           </a:p>
         </p:txBody>
@@ -6977,7 +6923,46 @@
                   <a:srgbClr val="FF0000"/>
                 </a:solidFill>
               </a:rPr>
-              <a:t>Qualitative ordinal: Rank</a:t>
+              <a:t>Qualitative ordinal: Education</a:t>
+            </a:r>
+          </a:p>
+        </p:txBody>
+      </p:sp>
+      <p:sp>
+        <p:nvSpPr>
+          <p:cNvPr id="12" name="TextBox 11"/>
+          <p:cNvSpPr txBox="1"/>
+          <p:nvPr/>
+        </p:nvSpPr>
+        <p:spPr>
+          <a:xfrm>
+            <a:off x="429768" y="6309360"/>
+            <a:ext cx="11338560" cy="274320"/>
+          </a:xfrm>
+          <a:prstGeom prst="rect">
+            <a:avLst/>
+          </a:prstGeom>
+          <a:noFill/>
+        </p:spPr>
+        <p:txBody>
+          <a:bodyPr wrap="square" lIns="0" rIns="0" tIns="0" bIns="0" anchor="t">
+            <a:spAutoFit/>
+          </a:bodyPr>
+          <a:lstStyle/>
+          <a:p>
+            <a:pPr algn="l">
+              <a:spcAft>
+                <a:spcPts val="0"/>
+              </a:spcAft>
+            </a:pPr>
+            <a:r>
+              <a:rPr sz="1000" b="0">
+                <a:solidFill>
+                  <a:srgbClr val="595959"/>
+                </a:solidFill>
+                <a:latin typeface="Calibri"/>
+              </a:rPr>
+              <a:t>Data structure adapted from Moro, Rita, and Cortez (2014), Bank Marketing, UCI Machine Learning Repository; the 20 records shown are simulated.</a:t>
             </a:r>
           </a:p>
         </p:txBody>
@@ -8157,63 +8142,14 @@
                 </a:solidFill>
                 <a:latin typeface="Calibri" panose="020F0502020204030204"/>
               </a:rPr>
-              <a:t>In the stormtrooper example data</a:t>
-            </a:r>
-            <a:r>
-              <a:rPr kumimoji="0" lang="it-IT" sz="2000" b="0" i="0" u="none" strike="noStrike" kern="1200" cap="none" spc="0" normalizeH="0" baseline="0" noProof="0" dirty="0">
-                <a:ln>
-                  <a:noFill/>
-                </a:ln>
-                <a:solidFill>
-                  <a:prstClr val="black"/>
-                </a:solidFill>
-                <a:effectLst/>
-                <a:uLnTx/>
-                <a:uFillTx/>
-                <a:latin typeface="Calibri" panose="020F0502020204030204"/>
-                <a:ea typeface="+mn-ea"/>
-                <a:cs typeface="+mn-cs"/>
-              </a:rPr>
-              <a:t>, which variable(s) are </a:t>
-            </a:r>
-            <a:r>
-              <a:rPr lang="it-IT" sz="2000" dirty="0">
-                <a:solidFill>
-                  <a:prstClr val="black"/>
-                </a:solidFill>
-                <a:latin typeface="Calibri" panose="020F0502020204030204"/>
-              </a:rPr>
-              <a:t>quantitative discrete and which are quantitative continous</a:t>
-            </a:r>
-            <a:r>
-              <a:rPr kumimoji="0" lang="it-IT" sz="2000" b="0" i="0" u="none" strike="noStrike" kern="1200" cap="none" spc="0" normalizeH="0" baseline="0" noProof="0" dirty="0">
-                <a:ln>
-                  <a:noFill/>
-                </a:ln>
-                <a:solidFill>
-                  <a:prstClr val="black"/>
-                </a:solidFill>
-                <a:effectLst/>
-                <a:uLnTx/>
-                <a:uFillTx/>
-                <a:latin typeface="Calibri" panose="020F0502020204030204"/>
-                <a:ea typeface="+mn-ea"/>
-                <a:cs typeface="+mn-cs"/>
-              </a:rPr>
-              <a:t>?</a:t>
+              <a:t>In the bank marketing example data, which variable(s) are quantitative discrete and which are quantitative continuous?</a:t>
             </a:r>
           </a:p>
         </p:txBody>
       </p:sp>
       <p:pic>
         <p:nvPicPr>
-          <p:cNvPr id="7" name="Picture 6">
-            <a:extLst>
-              <a:ext uri="{FF2B5EF4-FFF2-40B4-BE49-F238E27FC236}">
-                <a16:creationId xmlns:a16="http://schemas.microsoft.com/office/drawing/2014/main" id="{0177E576-A1D3-4747-DFD9-398F78F382BC}"/>
-              </a:ext>
-            </a:extLst>
-          </p:cNvPr>
+          <p:cNvPr id="11" name="Picture 10" descr="image.png"/>
           <p:cNvPicPr>
             <a:picLocks noChangeAspect="1"/>
           </p:cNvPicPr>
@@ -8227,8 +8163,8 @@
         </p:blipFill>
         <p:spPr>
           <a:xfrm>
-            <a:off x="4535809" y="1381126"/>
-            <a:ext cx="7514527" cy="5236984"/>
+            <a:off x="4846320" y="1554480"/>
+            <a:ext cx="7040880" cy="4437221"/>
           </a:xfrm>
           <a:prstGeom prst="rect">
             <a:avLst/>
@@ -8308,7 +8244,46 @@
                   <a:srgbClr val="FF0000"/>
                 </a:solidFill>
               </a:rPr>
-              <a:t>Quantitative continuous: Height, Blaster Accuracy</a:t>
+              <a:t>Quantitative continuous: Balance, Call Length</a:t>
+            </a:r>
+          </a:p>
+        </p:txBody>
+      </p:sp>
+      <p:sp>
+        <p:nvSpPr>
+          <p:cNvPr id="12" name="TextBox 11"/>
+          <p:cNvSpPr txBox="1"/>
+          <p:nvPr/>
+        </p:nvSpPr>
+        <p:spPr>
+          <a:xfrm>
+            <a:off x="429768" y="6309360"/>
+            <a:ext cx="11338560" cy="274320"/>
+          </a:xfrm>
+          <a:prstGeom prst="rect">
+            <a:avLst/>
+          </a:prstGeom>
+          <a:noFill/>
+        </p:spPr>
+        <p:txBody>
+          <a:bodyPr wrap="square" lIns="0" rIns="0" tIns="0" bIns="0" anchor="t">
+            <a:spAutoFit/>
+          </a:bodyPr>
+          <a:lstStyle/>
+          <a:p>
+            <a:pPr algn="l">
+              <a:spcAft>
+                <a:spcPts val="0"/>
+              </a:spcAft>
+            </a:pPr>
+            <a:r>
+              <a:rPr sz="1000" b="0">
+                <a:solidFill>
+                  <a:srgbClr val="595959"/>
+                </a:solidFill>
+                <a:latin typeface="Calibri"/>
+              </a:rPr>
+              <a:t>Data structure adapted from Moro, Rita, and Cortez (2014), Bank Marketing, UCI Machine Learning Repository; the 20 records shown are simulated.</a:t>
             </a:r>
           </a:p>
         </p:txBody>
@@ -8447,6 +8422,1450 @@
       <p:bldP spid="5" grpId="0"/>
     </p:bldLst>
   </p:timing>
+</p:sld>
+</file>
+
+<file path=ppt/slides/slide14.xml><?xml version="1.0" encoding="utf-8"?>
+<p:sld xmlns:a="http://schemas.openxmlformats.org/drawingml/2006/main" xmlns:p="http://schemas.openxmlformats.org/presentationml/2006/main" xmlns:r="http://schemas.openxmlformats.org/officeDocument/2006/relationships">
+  <p:cSld>
+    <p:spTree>
+      <p:nvGrpSpPr>
+        <p:cNvPr id="1" name=""/>
+        <p:cNvGrpSpPr/>
+        <p:nvPr/>
+      </p:nvGrpSpPr>
+      <p:grpSpPr/>
+      <p:sp>
+        <p:nvSpPr>
+          <p:cNvPr id="2" name="Title 1"/>
+          <p:cNvSpPr>
+            <a:spLocks noGrp="1"/>
+          </p:cNvSpPr>
+          <p:nvPr>
+            <p:ph type="title"/>
+          </p:nvPr>
+        </p:nvSpPr>
+        <p:spPr>
+          <a:xfrm>
+            <a:off x="457200" y="182880"/>
+            <a:ext cx="11338560" cy="914400"/>
+          </a:xfrm>
+        </p:spPr>
+        <p:txBody>
+          <a:bodyPr/>
+          <a:lstStyle/>
+          <a:p>
+            <a:r>
+              <a:rPr sz="4000">
+                <a:solidFill>
+                  <a:srgbClr val="000000"/>
+                </a:solidFill>
+                <a:latin typeface="Calibri Light"/>
+              </a:rPr>
+              <a:t>Where does statistics come from?</a:t>
+            </a:r>
+          </a:p>
+        </p:txBody>
+      </p:sp>
+      <p:sp>
+        <p:nvSpPr>
+          <p:cNvPr id="3" name="TextBox 2"/>
+          <p:cNvSpPr txBox="1"/>
+          <p:nvPr/>
+        </p:nvSpPr>
+        <p:spPr>
+          <a:xfrm>
+            <a:off x="457200" y="1170432"/>
+            <a:ext cx="11292840" cy="411480"/>
+          </a:xfrm>
+          <a:prstGeom prst="rect">
+            <a:avLst/>
+          </a:prstGeom>
+          <a:noFill/>
+        </p:spPr>
+        <p:txBody>
+          <a:bodyPr wrap="square" lIns="0" rIns="0" tIns="0" bIns="0" anchor="t">
+            <a:spAutoFit/>
+          </a:bodyPr>
+          <a:lstStyle/>
+          <a:p>
+            <a:pPr algn="l">
+              <a:spcAft>
+                <a:spcPts val="0"/>
+              </a:spcAft>
+            </a:pPr>
+            <a:r>
+              <a:rPr sz="1600" b="0">
+                <a:solidFill>
+                  <a:srgbClr val="333333"/>
+                </a:solidFill>
+                <a:latin typeface="Calibri"/>
+              </a:rPr>
+              <a:t>Statistics began as bookkeeping about people — counting births, deaths, and taxpayers so that a state could describe itself.</a:t>
+            </a:r>
+          </a:p>
+        </p:txBody>
+      </p:sp>
+      <p:sp>
+        <p:nvSpPr>
+          <p:cNvPr id="4" name="Rectangle 3"/>
+          <p:cNvSpPr/>
+          <p:nvPr/>
+        </p:nvSpPr>
+        <p:spPr>
+          <a:xfrm>
+            <a:off x="457200" y="3893515"/>
+            <a:ext cx="11277295" cy="40233"/>
+          </a:xfrm>
+          <a:prstGeom prst="rect">
+            <a:avLst/>
+          </a:prstGeom>
+          <a:solidFill>
+            <a:srgbClr val="4472C4"/>
+          </a:solidFill>
+          <a:ln>
+            <a:noFill/>
+          </a:ln>
+          <a:effectLst/>
+        </p:spPr>
+        <p:style>
+          <a:lnRef idx="1">
+            <a:schemeClr val="accent1"/>
+          </a:lnRef>
+          <a:fillRef idx="3">
+            <a:schemeClr val="accent1"/>
+          </a:fillRef>
+          <a:effectRef idx="2">
+            <a:schemeClr val="accent1"/>
+          </a:effectRef>
+          <a:fontRef idx="minor">
+            <a:schemeClr val="lt1"/>
+          </a:fontRef>
+        </p:style>
+        <p:txBody>
+          <a:bodyPr rtlCol="0" anchor="ctr" wrap="square"/>
+          <a:lstStyle/>
+          <a:p>
+            <a:pPr algn="ctr"/>
+          </a:p>
+        </p:txBody>
+      </p:sp>
+      <p:sp>
+        <p:nvSpPr>
+          <p:cNvPr id="5" name="Rectangle 4"/>
+          <p:cNvSpPr/>
+          <p:nvPr/>
+        </p:nvSpPr>
+        <p:spPr>
+          <a:xfrm>
+            <a:off x="1590141" y="3529584"/>
+            <a:ext cx="20116" cy="384048"/>
+          </a:xfrm>
+          <a:prstGeom prst="rect">
+            <a:avLst/>
+          </a:prstGeom>
+          <a:solidFill>
+            <a:srgbClr val="4472C4"/>
+          </a:solidFill>
+          <a:ln>
+            <a:noFill/>
+          </a:ln>
+          <a:effectLst/>
+        </p:spPr>
+        <p:style>
+          <a:lnRef idx="1">
+            <a:schemeClr val="accent1"/>
+          </a:lnRef>
+          <a:fillRef idx="3">
+            <a:schemeClr val="accent1"/>
+          </a:fillRef>
+          <a:effectRef idx="2">
+            <a:schemeClr val="accent1"/>
+          </a:effectRef>
+          <a:fontRef idx="minor">
+            <a:schemeClr val="lt1"/>
+          </a:fontRef>
+        </p:style>
+        <p:txBody>
+          <a:bodyPr rtlCol="0" anchor="ctr" wrap="square"/>
+          <a:lstStyle/>
+          <a:p>
+            <a:pPr algn="ctr"/>
+          </a:p>
+        </p:txBody>
+      </p:sp>
+      <p:sp>
+        <p:nvSpPr>
+          <p:cNvPr id="6" name="Oval 5"/>
+          <p:cNvSpPr/>
+          <p:nvPr/>
+        </p:nvSpPr>
+        <p:spPr>
+          <a:xfrm>
+            <a:off x="1522476" y="3835908"/>
+            <a:ext cx="155448" cy="155448"/>
+          </a:xfrm>
+          <a:prstGeom prst="ellipse">
+            <a:avLst/>
+          </a:prstGeom>
+          <a:solidFill>
+            <a:srgbClr val="FFFFFF"/>
+          </a:solidFill>
+          <a:ln w="25400">
+            <a:solidFill>
+              <a:srgbClr val="4472C4"/>
+            </a:solidFill>
+          </a:ln>
+          <a:effectLst/>
+        </p:spPr>
+        <p:style>
+          <a:lnRef idx="1">
+            <a:schemeClr val="accent1"/>
+          </a:lnRef>
+          <a:fillRef idx="3">
+            <a:schemeClr val="accent1"/>
+          </a:fillRef>
+          <a:effectRef idx="2">
+            <a:schemeClr val="accent1"/>
+          </a:effectRef>
+          <a:fontRef idx="minor">
+            <a:schemeClr val="lt1"/>
+          </a:fontRef>
+        </p:style>
+        <p:txBody>
+          <a:bodyPr rtlCol="0" anchor="ctr" wrap="square"/>
+          <a:lstStyle/>
+          <a:p>
+            <a:pPr algn="ctr"/>
+          </a:p>
+        </p:txBody>
+      </p:sp>
+      <p:sp>
+        <p:nvSpPr>
+          <p:cNvPr id="7" name="Rectangle 6"/>
+          <p:cNvSpPr/>
+          <p:nvPr/>
+        </p:nvSpPr>
+        <p:spPr>
+          <a:xfrm>
+            <a:off x="457200" y="2231136"/>
+            <a:ext cx="2286000" cy="1298448"/>
+          </a:xfrm>
+          <a:prstGeom prst="rect">
+            <a:avLst/>
+          </a:prstGeom>
+          <a:solidFill>
+            <a:srgbClr val="EDF2FA"/>
+          </a:solidFill>
+          <a:ln>
+            <a:noFill/>
+          </a:ln>
+          <a:effectLst/>
+        </p:spPr>
+        <p:style>
+          <a:lnRef idx="1">
+            <a:schemeClr val="accent1"/>
+          </a:lnRef>
+          <a:fillRef idx="3">
+            <a:schemeClr val="accent1"/>
+          </a:fillRef>
+          <a:effectRef idx="2">
+            <a:schemeClr val="accent1"/>
+          </a:effectRef>
+          <a:fontRef idx="minor">
+            <a:schemeClr val="lt1"/>
+          </a:fontRef>
+        </p:style>
+        <p:txBody>
+          <a:bodyPr rtlCol="0" anchor="t" wrap="square" lIns="100584" rIns="100584" tIns="73152" bIns="73152"/>
+          <a:lstStyle/>
+          <a:p>
+            <a:pPr algn="l">
+              <a:spcAft>
+                <a:spcPts val="300"/>
+              </a:spcAft>
+            </a:pPr>
+            <a:r>
+              <a:rPr sz="1700" b="1">
+                <a:solidFill>
+                  <a:srgbClr val="4472C4"/>
+                </a:solidFill>
+                <a:latin typeface="Calibri"/>
+              </a:rPr>
+              <a:t>1662</a:t>
+            </a:r>
+          </a:p>
+          <a:p>
+            <a:pPr algn="l"/>
+            <a:r>
+              <a:rPr sz="1050">
+                <a:solidFill>
+                  <a:srgbClr val="262626"/>
+                </a:solidFill>
+                <a:latin typeface="Calibri"/>
+              </a:rPr>
+              <a:t>John Graunt studies London's Bills of Mortality — the first life table built from real data.</a:t>
+            </a:r>
+          </a:p>
+        </p:txBody>
+      </p:sp>
+      <p:sp>
+        <p:nvSpPr>
+          <p:cNvPr id="8" name="Rectangle 7"/>
+          <p:cNvSpPr/>
+          <p:nvPr/>
+        </p:nvSpPr>
+        <p:spPr>
+          <a:xfrm>
+            <a:off x="2874612" y="3913632"/>
+            <a:ext cx="20116" cy="384048"/>
+          </a:xfrm>
+          <a:prstGeom prst="rect">
+            <a:avLst/>
+          </a:prstGeom>
+          <a:solidFill>
+            <a:srgbClr val="4472C4"/>
+          </a:solidFill>
+          <a:ln>
+            <a:noFill/>
+          </a:ln>
+          <a:effectLst/>
+        </p:spPr>
+        <p:style>
+          <a:lnRef idx="1">
+            <a:schemeClr val="accent1"/>
+          </a:lnRef>
+          <a:fillRef idx="3">
+            <a:schemeClr val="accent1"/>
+          </a:fillRef>
+          <a:effectRef idx="2">
+            <a:schemeClr val="accent1"/>
+          </a:effectRef>
+          <a:fontRef idx="minor">
+            <a:schemeClr val="lt1"/>
+          </a:fontRef>
+        </p:style>
+        <p:txBody>
+          <a:bodyPr rtlCol="0" anchor="ctr" wrap="square"/>
+          <a:lstStyle/>
+          <a:p>
+            <a:pPr algn="ctr"/>
+          </a:p>
+        </p:txBody>
+      </p:sp>
+      <p:sp>
+        <p:nvSpPr>
+          <p:cNvPr id="9" name="Oval 8"/>
+          <p:cNvSpPr/>
+          <p:nvPr/>
+        </p:nvSpPr>
+        <p:spPr>
+          <a:xfrm>
+            <a:off x="2806946" y="3835908"/>
+            <a:ext cx="155448" cy="155448"/>
+          </a:xfrm>
+          <a:prstGeom prst="ellipse">
+            <a:avLst/>
+          </a:prstGeom>
+          <a:solidFill>
+            <a:srgbClr val="FFFFFF"/>
+          </a:solidFill>
+          <a:ln w="25400">
+            <a:solidFill>
+              <a:srgbClr val="4472C4"/>
+            </a:solidFill>
+          </a:ln>
+          <a:effectLst/>
+        </p:spPr>
+        <p:style>
+          <a:lnRef idx="1">
+            <a:schemeClr val="accent1"/>
+          </a:lnRef>
+          <a:fillRef idx="3">
+            <a:schemeClr val="accent1"/>
+          </a:fillRef>
+          <a:effectRef idx="2">
+            <a:schemeClr val="accent1"/>
+          </a:effectRef>
+          <a:fontRef idx="minor">
+            <a:schemeClr val="lt1"/>
+          </a:fontRef>
+        </p:style>
+        <p:txBody>
+          <a:bodyPr rtlCol="0" anchor="ctr" wrap="square"/>
+          <a:lstStyle/>
+          <a:p>
+            <a:pPr algn="ctr"/>
+          </a:p>
+        </p:txBody>
+      </p:sp>
+      <p:sp>
+        <p:nvSpPr>
+          <p:cNvPr id="10" name="Rectangle 9"/>
+          <p:cNvSpPr/>
+          <p:nvPr/>
+        </p:nvSpPr>
+        <p:spPr>
+          <a:xfrm>
+            <a:off x="1741670" y="4297680"/>
+            <a:ext cx="2286000" cy="1298448"/>
+          </a:xfrm>
+          <a:prstGeom prst="rect">
+            <a:avLst/>
+          </a:prstGeom>
+          <a:solidFill>
+            <a:srgbClr val="EDF2FA"/>
+          </a:solidFill>
+          <a:ln>
+            <a:noFill/>
+          </a:ln>
+          <a:effectLst/>
+        </p:spPr>
+        <p:style>
+          <a:lnRef idx="1">
+            <a:schemeClr val="accent1"/>
+          </a:lnRef>
+          <a:fillRef idx="3">
+            <a:schemeClr val="accent1"/>
+          </a:fillRef>
+          <a:effectRef idx="2">
+            <a:schemeClr val="accent1"/>
+          </a:effectRef>
+          <a:fontRef idx="minor">
+            <a:schemeClr val="lt1"/>
+          </a:fontRef>
+        </p:style>
+        <p:txBody>
+          <a:bodyPr rtlCol="0" anchor="t" wrap="square" lIns="100584" rIns="100584" tIns="73152" bIns="73152"/>
+          <a:lstStyle/>
+          <a:p>
+            <a:pPr algn="l">
+              <a:spcAft>
+                <a:spcPts val="300"/>
+              </a:spcAft>
+            </a:pPr>
+            <a:r>
+              <a:rPr sz="1700" b="1">
+                <a:solidFill>
+                  <a:srgbClr val="4472C4"/>
+                </a:solidFill>
+                <a:latin typeface="Calibri"/>
+              </a:rPr>
+              <a:t>1693</a:t>
+            </a:r>
+          </a:p>
+          <a:p>
+            <a:pPr algn="l"/>
+            <a:r>
+              <a:rPr sz="1050">
+                <a:solidFill>
+                  <a:srgbClr val="262626"/>
+                </a:solidFill>
+                <a:latin typeface="Calibri"/>
+              </a:rPr>
+              <a:t>Edmond Halley's Breslau life table makes it possible to price life annuities.</a:t>
+            </a:r>
+          </a:p>
+        </p:txBody>
+      </p:sp>
+      <p:sp>
+        <p:nvSpPr>
+          <p:cNvPr id="11" name="Rectangle 10"/>
+          <p:cNvSpPr/>
+          <p:nvPr/>
+        </p:nvSpPr>
+        <p:spPr>
+          <a:xfrm>
+            <a:off x="4159083" y="3529584"/>
+            <a:ext cx="20116" cy="384048"/>
+          </a:xfrm>
+          <a:prstGeom prst="rect">
+            <a:avLst/>
+          </a:prstGeom>
+          <a:solidFill>
+            <a:srgbClr val="4472C4"/>
+          </a:solidFill>
+          <a:ln>
+            <a:noFill/>
+          </a:ln>
+          <a:effectLst/>
+        </p:spPr>
+        <p:style>
+          <a:lnRef idx="1">
+            <a:schemeClr val="accent1"/>
+          </a:lnRef>
+          <a:fillRef idx="3">
+            <a:schemeClr val="accent1"/>
+          </a:fillRef>
+          <a:effectRef idx="2">
+            <a:schemeClr val="accent1"/>
+          </a:effectRef>
+          <a:fontRef idx="minor">
+            <a:schemeClr val="lt1"/>
+          </a:fontRef>
+        </p:style>
+        <p:txBody>
+          <a:bodyPr rtlCol="0" anchor="ctr" wrap="square"/>
+          <a:lstStyle/>
+          <a:p>
+            <a:pPr algn="ctr"/>
+          </a:p>
+        </p:txBody>
+      </p:sp>
+      <p:sp>
+        <p:nvSpPr>
+          <p:cNvPr id="12" name="Oval 11"/>
+          <p:cNvSpPr/>
+          <p:nvPr/>
+        </p:nvSpPr>
+        <p:spPr>
+          <a:xfrm>
+            <a:off x="4091417" y="3835908"/>
+            <a:ext cx="155448" cy="155448"/>
+          </a:xfrm>
+          <a:prstGeom prst="ellipse">
+            <a:avLst/>
+          </a:prstGeom>
+          <a:solidFill>
+            <a:srgbClr val="FFFFFF"/>
+          </a:solidFill>
+          <a:ln w="25400">
+            <a:solidFill>
+              <a:srgbClr val="4472C4"/>
+            </a:solidFill>
+          </a:ln>
+          <a:effectLst/>
+        </p:spPr>
+        <p:style>
+          <a:lnRef idx="1">
+            <a:schemeClr val="accent1"/>
+          </a:lnRef>
+          <a:fillRef idx="3">
+            <a:schemeClr val="accent1"/>
+          </a:fillRef>
+          <a:effectRef idx="2">
+            <a:schemeClr val="accent1"/>
+          </a:effectRef>
+          <a:fontRef idx="minor">
+            <a:schemeClr val="lt1"/>
+          </a:fontRef>
+        </p:style>
+        <p:txBody>
+          <a:bodyPr rtlCol="0" anchor="ctr" wrap="square"/>
+          <a:lstStyle/>
+          <a:p>
+            <a:pPr algn="ctr"/>
+          </a:p>
+        </p:txBody>
+      </p:sp>
+      <p:sp>
+        <p:nvSpPr>
+          <p:cNvPr id="13" name="Rectangle 12"/>
+          <p:cNvSpPr/>
+          <p:nvPr/>
+        </p:nvSpPr>
+        <p:spPr>
+          <a:xfrm>
+            <a:off x="3026141" y="2231136"/>
+            <a:ext cx="2286000" cy="1298448"/>
+          </a:xfrm>
+          <a:prstGeom prst="rect">
+            <a:avLst/>
+          </a:prstGeom>
+          <a:solidFill>
+            <a:srgbClr val="EDF2FA"/>
+          </a:solidFill>
+          <a:ln>
+            <a:noFill/>
+          </a:ln>
+          <a:effectLst/>
+        </p:spPr>
+        <p:style>
+          <a:lnRef idx="1">
+            <a:schemeClr val="accent1"/>
+          </a:lnRef>
+          <a:fillRef idx="3">
+            <a:schemeClr val="accent1"/>
+          </a:fillRef>
+          <a:effectRef idx="2">
+            <a:schemeClr val="accent1"/>
+          </a:effectRef>
+          <a:fontRef idx="minor">
+            <a:schemeClr val="lt1"/>
+          </a:fontRef>
+        </p:style>
+        <p:txBody>
+          <a:bodyPr rtlCol="0" anchor="t" wrap="square" lIns="100584" rIns="100584" tIns="73152" bIns="73152"/>
+          <a:lstStyle/>
+          <a:p>
+            <a:pPr algn="l">
+              <a:spcAft>
+                <a:spcPts val="300"/>
+              </a:spcAft>
+            </a:pPr>
+            <a:r>
+              <a:rPr sz="1700" b="1">
+                <a:solidFill>
+                  <a:srgbClr val="4472C4"/>
+                </a:solidFill>
+                <a:latin typeface="Calibri"/>
+              </a:rPr>
+              <a:t>1749</a:t>
+            </a:r>
+          </a:p>
+          <a:p>
+            <a:pPr algn="l"/>
+            <a:r>
+              <a:rPr sz="1050">
+                <a:solidFill>
+                  <a:srgbClr val="262626"/>
+                </a:solidFill>
+                <a:latin typeface="Calibri"/>
+              </a:rPr>
+              <a:t>Gottfried Achenwall coins “Statistik” — literally the science of the state.</a:t>
+            </a:r>
+          </a:p>
+        </p:txBody>
+      </p:sp>
+      <p:sp>
+        <p:nvSpPr>
+          <p:cNvPr id="14" name="Rectangle 13"/>
+          <p:cNvSpPr/>
+          <p:nvPr/>
+        </p:nvSpPr>
+        <p:spPr>
+          <a:xfrm>
+            <a:off x="5443553" y="3913632"/>
+            <a:ext cx="20116" cy="384048"/>
+          </a:xfrm>
+          <a:prstGeom prst="rect">
+            <a:avLst/>
+          </a:prstGeom>
+          <a:solidFill>
+            <a:srgbClr val="4472C4"/>
+          </a:solidFill>
+          <a:ln>
+            <a:noFill/>
+          </a:ln>
+          <a:effectLst/>
+        </p:spPr>
+        <p:style>
+          <a:lnRef idx="1">
+            <a:schemeClr val="accent1"/>
+          </a:lnRef>
+          <a:fillRef idx="3">
+            <a:schemeClr val="accent1"/>
+          </a:fillRef>
+          <a:effectRef idx="2">
+            <a:schemeClr val="accent1"/>
+          </a:effectRef>
+          <a:fontRef idx="minor">
+            <a:schemeClr val="lt1"/>
+          </a:fontRef>
+        </p:style>
+        <p:txBody>
+          <a:bodyPr rtlCol="0" anchor="ctr" wrap="square"/>
+          <a:lstStyle/>
+          <a:p>
+            <a:pPr algn="ctr"/>
+          </a:p>
+        </p:txBody>
+      </p:sp>
+      <p:sp>
+        <p:nvSpPr>
+          <p:cNvPr id="15" name="Oval 14"/>
+          <p:cNvSpPr/>
+          <p:nvPr/>
+        </p:nvSpPr>
+        <p:spPr>
+          <a:xfrm>
+            <a:off x="5375888" y="3835908"/>
+            <a:ext cx="155448" cy="155448"/>
+          </a:xfrm>
+          <a:prstGeom prst="ellipse">
+            <a:avLst/>
+          </a:prstGeom>
+          <a:solidFill>
+            <a:srgbClr val="FFFFFF"/>
+          </a:solidFill>
+          <a:ln w="25400">
+            <a:solidFill>
+              <a:srgbClr val="4472C4"/>
+            </a:solidFill>
+          </a:ln>
+          <a:effectLst/>
+        </p:spPr>
+        <p:style>
+          <a:lnRef idx="1">
+            <a:schemeClr val="accent1"/>
+          </a:lnRef>
+          <a:fillRef idx="3">
+            <a:schemeClr val="accent1"/>
+          </a:fillRef>
+          <a:effectRef idx="2">
+            <a:schemeClr val="accent1"/>
+          </a:effectRef>
+          <a:fontRef idx="minor">
+            <a:schemeClr val="lt1"/>
+          </a:fontRef>
+        </p:style>
+        <p:txBody>
+          <a:bodyPr rtlCol="0" anchor="ctr" wrap="square"/>
+          <a:lstStyle/>
+          <a:p>
+            <a:pPr algn="ctr"/>
+          </a:p>
+        </p:txBody>
+      </p:sp>
+      <p:sp>
+        <p:nvSpPr>
+          <p:cNvPr id="16" name="Rectangle 15"/>
+          <p:cNvSpPr/>
+          <p:nvPr/>
+        </p:nvSpPr>
+        <p:spPr>
+          <a:xfrm>
+            <a:off x="4310612" y="4297680"/>
+            <a:ext cx="2286000" cy="1298448"/>
+          </a:xfrm>
+          <a:prstGeom prst="rect">
+            <a:avLst/>
+          </a:prstGeom>
+          <a:solidFill>
+            <a:srgbClr val="EDF2FA"/>
+          </a:solidFill>
+          <a:ln>
+            <a:noFill/>
+          </a:ln>
+          <a:effectLst/>
+        </p:spPr>
+        <p:style>
+          <a:lnRef idx="1">
+            <a:schemeClr val="accent1"/>
+          </a:lnRef>
+          <a:fillRef idx="3">
+            <a:schemeClr val="accent1"/>
+          </a:fillRef>
+          <a:effectRef idx="2">
+            <a:schemeClr val="accent1"/>
+          </a:effectRef>
+          <a:fontRef idx="minor">
+            <a:schemeClr val="lt1"/>
+          </a:fontRef>
+        </p:style>
+        <p:txBody>
+          <a:bodyPr rtlCol="0" anchor="t" wrap="square" lIns="100584" rIns="100584" tIns="73152" bIns="73152"/>
+          <a:lstStyle/>
+          <a:p>
+            <a:pPr algn="l">
+              <a:spcAft>
+                <a:spcPts val="300"/>
+              </a:spcAft>
+            </a:pPr>
+            <a:r>
+              <a:rPr sz="1700" b="1">
+                <a:solidFill>
+                  <a:srgbClr val="4472C4"/>
+                </a:solidFill>
+                <a:latin typeface="Calibri"/>
+              </a:rPr>
+              <a:t>1790</a:t>
+            </a:r>
+          </a:p>
+          <a:p>
+            <a:pPr algn="l"/>
+            <a:r>
+              <a:rPr sz="1050">
+                <a:solidFill>
+                  <a:srgbClr val="262626"/>
+                </a:solidFill>
+                <a:latin typeface="Calibri"/>
+              </a:rPr>
+              <a:t>The first U.S. census counts the population. Great Britain follows in 1801.</a:t>
+            </a:r>
+          </a:p>
+        </p:txBody>
+      </p:sp>
+      <p:sp>
+        <p:nvSpPr>
+          <p:cNvPr id="17" name="Rectangle 16"/>
+          <p:cNvSpPr/>
+          <p:nvPr/>
+        </p:nvSpPr>
+        <p:spPr>
+          <a:xfrm>
+            <a:off x="6728024" y="3529584"/>
+            <a:ext cx="20116" cy="384048"/>
+          </a:xfrm>
+          <a:prstGeom prst="rect">
+            <a:avLst/>
+          </a:prstGeom>
+          <a:solidFill>
+            <a:srgbClr val="4472C4"/>
+          </a:solidFill>
+          <a:ln>
+            <a:noFill/>
+          </a:ln>
+          <a:effectLst/>
+        </p:spPr>
+        <p:style>
+          <a:lnRef idx="1">
+            <a:schemeClr val="accent1"/>
+          </a:lnRef>
+          <a:fillRef idx="3">
+            <a:schemeClr val="accent1"/>
+          </a:fillRef>
+          <a:effectRef idx="2">
+            <a:schemeClr val="accent1"/>
+          </a:effectRef>
+          <a:fontRef idx="minor">
+            <a:schemeClr val="lt1"/>
+          </a:fontRef>
+        </p:style>
+        <p:txBody>
+          <a:bodyPr rtlCol="0" anchor="ctr" wrap="square"/>
+          <a:lstStyle/>
+          <a:p>
+            <a:pPr algn="ctr"/>
+          </a:p>
+        </p:txBody>
+      </p:sp>
+      <p:sp>
+        <p:nvSpPr>
+          <p:cNvPr id="18" name="Oval 17"/>
+          <p:cNvSpPr/>
+          <p:nvPr/>
+        </p:nvSpPr>
+        <p:spPr>
+          <a:xfrm>
+            <a:off x="6660358" y="3835908"/>
+            <a:ext cx="155448" cy="155448"/>
+          </a:xfrm>
+          <a:prstGeom prst="ellipse">
+            <a:avLst/>
+          </a:prstGeom>
+          <a:solidFill>
+            <a:srgbClr val="FFFFFF"/>
+          </a:solidFill>
+          <a:ln w="25400">
+            <a:solidFill>
+              <a:srgbClr val="4472C4"/>
+            </a:solidFill>
+          </a:ln>
+          <a:effectLst/>
+        </p:spPr>
+        <p:style>
+          <a:lnRef idx="1">
+            <a:schemeClr val="accent1"/>
+          </a:lnRef>
+          <a:fillRef idx="3">
+            <a:schemeClr val="accent1"/>
+          </a:fillRef>
+          <a:effectRef idx="2">
+            <a:schemeClr val="accent1"/>
+          </a:effectRef>
+          <a:fontRef idx="minor">
+            <a:schemeClr val="lt1"/>
+          </a:fontRef>
+        </p:style>
+        <p:txBody>
+          <a:bodyPr rtlCol="0" anchor="ctr" wrap="square"/>
+          <a:lstStyle/>
+          <a:p>
+            <a:pPr algn="ctr"/>
+          </a:p>
+        </p:txBody>
+      </p:sp>
+      <p:sp>
+        <p:nvSpPr>
+          <p:cNvPr id="19" name="Rectangle 18"/>
+          <p:cNvSpPr/>
+          <p:nvPr/>
+        </p:nvSpPr>
+        <p:spPr>
+          <a:xfrm>
+            <a:off x="5595082" y="2231136"/>
+            <a:ext cx="2286000" cy="1298448"/>
+          </a:xfrm>
+          <a:prstGeom prst="rect">
+            <a:avLst/>
+          </a:prstGeom>
+          <a:solidFill>
+            <a:srgbClr val="EDF2FA"/>
+          </a:solidFill>
+          <a:ln>
+            <a:noFill/>
+          </a:ln>
+          <a:effectLst/>
+        </p:spPr>
+        <p:style>
+          <a:lnRef idx="1">
+            <a:schemeClr val="accent1"/>
+          </a:lnRef>
+          <a:fillRef idx="3">
+            <a:schemeClr val="accent1"/>
+          </a:fillRef>
+          <a:effectRef idx="2">
+            <a:schemeClr val="accent1"/>
+          </a:effectRef>
+          <a:fontRef idx="minor">
+            <a:schemeClr val="lt1"/>
+          </a:fontRef>
+        </p:style>
+        <p:txBody>
+          <a:bodyPr rtlCol="0" anchor="t" wrap="square" lIns="100584" rIns="100584" tIns="73152" bIns="73152"/>
+          <a:lstStyle/>
+          <a:p>
+            <a:pPr algn="l">
+              <a:spcAft>
+                <a:spcPts val="300"/>
+              </a:spcAft>
+            </a:pPr>
+            <a:r>
+              <a:rPr sz="1700" b="1">
+                <a:solidFill>
+                  <a:srgbClr val="4472C4"/>
+                </a:solidFill>
+                <a:latin typeface="Calibri"/>
+              </a:rPr>
+              <a:t>1830s</a:t>
+            </a:r>
+          </a:p>
+          <a:p>
+            <a:pPr algn="l"/>
+            <a:r>
+              <a:rPr sz="1050">
+                <a:solidFill>
+                  <a:srgbClr val="262626"/>
+                </a:solidFill>
+                <a:latin typeface="Calibri"/>
+              </a:rPr>
+              <a:t>Adolphe Quetelet applies the normal curve to human traits and invents “the average man.”</a:t>
+            </a:r>
+          </a:p>
+        </p:txBody>
+      </p:sp>
+      <p:sp>
+        <p:nvSpPr>
+          <p:cNvPr id="20" name="Rectangle 19"/>
+          <p:cNvSpPr/>
+          <p:nvPr/>
+        </p:nvSpPr>
+        <p:spPr>
+          <a:xfrm>
+            <a:off x="8012495" y="3913632"/>
+            <a:ext cx="20116" cy="384048"/>
+          </a:xfrm>
+          <a:prstGeom prst="rect">
+            <a:avLst/>
+          </a:prstGeom>
+          <a:solidFill>
+            <a:srgbClr val="4472C4"/>
+          </a:solidFill>
+          <a:ln>
+            <a:noFill/>
+          </a:ln>
+          <a:effectLst/>
+        </p:spPr>
+        <p:style>
+          <a:lnRef idx="1">
+            <a:schemeClr val="accent1"/>
+          </a:lnRef>
+          <a:fillRef idx="3">
+            <a:schemeClr val="accent1"/>
+          </a:fillRef>
+          <a:effectRef idx="2">
+            <a:schemeClr val="accent1"/>
+          </a:effectRef>
+          <a:fontRef idx="minor">
+            <a:schemeClr val="lt1"/>
+          </a:fontRef>
+        </p:style>
+        <p:txBody>
+          <a:bodyPr rtlCol="0" anchor="ctr" wrap="square"/>
+          <a:lstStyle/>
+          <a:p>
+            <a:pPr algn="ctr"/>
+          </a:p>
+        </p:txBody>
+      </p:sp>
+      <p:sp>
+        <p:nvSpPr>
+          <p:cNvPr id="21" name="Oval 20"/>
+          <p:cNvSpPr/>
+          <p:nvPr/>
+        </p:nvSpPr>
+        <p:spPr>
+          <a:xfrm>
+            <a:off x="7944829" y="3835908"/>
+            <a:ext cx="155448" cy="155448"/>
+          </a:xfrm>
+          <a:prstGeom prst="ellipse">
+            <a:avLst/>
+          </a:prstGeom>
+          <a:solidFill>
+            <a:srgbClr val="FFFFFF"/>
+          </a:solidFill>
+          <a:ln w="25400">
+            <a:solidFill>
+              <a:srgbClr val="4472C4"/>
+            </a:solidFill>
+          </a:ln>
+          <a:effectLst/>
+        </p:spPr>
+        <p:style>
+          <a:lnRef idx="1">
+            <a:schemeClr val="accent1"/>
+          </a:lnRef>
+          <a:fillRef idx="3">
+            <a:schemeClr val="accent1"/>
+          </a:fillRef>
+          <a:effectRef idx="2">
+            <a:schemeClr val="accent1"/>
+          </a:effectRef>
+          <a:fontRef idx="minor">
+            <a:schemeClr val="lt1"/>
+          </a:fontRef>
+        </p:style>
+        <p:txBody>
+          <a:bodyPr rtlCol="0" anchor="ctr" wrap="square"/>
+          <a:lstStyle/>
+          <a:p>
+            <a:pPr algn="ctr"/>
+          </a:p>
+        </p:txBody>
+      </p:sp>
+      <p:sp>
+        <p:nvSpPr>
+          <p:cNvPr id="22" name="Rectangle 21"/>
+          <p:cNvSpPr/>
+          <p:nvPr/>
+        </p:nvSpPr>
+        <p:spPr>
+          <a:xfrm>
+            <a:off x="6879553" y="4297680"/>
+            <a:ext cx="2286000" cy="1298448"/>
+          </a:xfrm>
+          <a:prstGeom prst="rect">
+            <a:avLst/>
+          </a:prstGeom>
+          <a:solidFill>
+            <a:srgbClr val="EDF2FA"/>
+          </a:solidFill>
+          <a:ln>
+            <a:noFill/>
+          </a:ln>
+          <a:effectLst/>
+        </p:spPr>
+        <p:style>
+          <a:lnRef idx="1">
+            <a:schemeClr val="accent1"/>
+          </a:lnRef>
+          <a:fillRef idx="3">
+            <a:schemeClr val="accent1"/>
+          </a:fillRef>
+          <a:effectRef idx="2">
+            <a:schemeClr val="accent1"/>
+          </a:effectRef>
+          <a:fontRef idx="minor">
+            <a:schemeClr val="lt1"/>
+          </a:fontRef>
+        </p:style>
+        <p:txBody>
+          <a:bodyPr rtlCol="0" anchor="t" wrap="square" lIns="100584" rIns="100584" tIns="73152" bIns="73152"/>
+          <a:lstStyle/>
+          <a:p>
+            <a:pPr algn="l">
+              <a:spcAft>
+                <a:spcPts val="300"/>
+              </a:spcAft>
+            </a:pPr>
+            <a:r>
+              <a:rPr sz="1700" b="1">
+                <a:solidFill>
+                  <a:srgbClr val="4472C4"/>
+                </a:solidFill>
+                <a:latin typeface="Calibri"/>
+              </a:rPr>
+              <a:t>1900</a:t>
+            </a:r>
+          </a:p>
+          <a:p>
+            <a:pPr algn="l"/>
+            <a:r>
+              <a:rPr sz="1050">
+                <a:solidFill>
+                  <a:srgbClr val="262626"/>
+                </a:solidFill>
+                <a:latin typeface="Calibri"/>
+              </a:rPr>
+              <a:t>Galton and Pearson develop correlation, regression, and the chi-square test.</a:t>
+            </a:r>
+          </a:p>
+        </p:txBody>
+      </p:sp>
+      <p:sp>
+        <p:nvSpPr>
+          <p:cNvPr id="23" name="Rectangle 22"/>
+          <p:cNvSpPr/>
+          <p:nvPr/>
+        </p:nvSpPr>
+        <p:spPr>
+          <a:xfrm>
+            <a:off x="9296966" y="3529584"/>
+            <a:ext cx="20116" cy="384048"/>
+          </a:xfrm>
+          <a:prstGeom prst="rect">
+            <a:avLst/>
+          </a:prstGeom>
+          <a:solidFill>
+            <a:srgbClr val="4472C4"/>
+          </a:solidFill>
+          <a:ln>
+            <a:noFill/>
+          </a:ln>
+          <a:effectLst/>
+        </p:spPr>
+        <p:style>
+          <a:lnRef idx="1">
+            <a:schemeClr val="accent1"/>
+          </a:lnRef>
+          <a:fillRef idx="3">
+            <a:schemeClr val="accent1"/>
+          </a:fillRef>
+          <a:effectRef idx="2">
+            <a:schemeClr val="accent1"/>
+          </a:effectRef>
+          <a:fontRef idx="minor">
+            <a:schemeClr val="lt1"/>
+          </a:fontRef>
+        </p:style>
+        <p:txBody>
+          <a:bodyPr rtlCol="0" anchor="ctr" wrap="square"/>
+          <a:lstStyle/>
+          <a:p>
+            <a:pPr algn="ctr"/>
+          </a:p>
+        </p:txBody>
+      </p:sp>
+      <p:sp>
+        <p:nvSpPr>
+          <p:cNvPr id="24" name="Oval 23"/>
+          <p:cNvSpPr/>
+          <p:nvPr/>
+        </p:nvSpPr>
+        <p:spPr>
+          <a:xfrm>
+            <a:off x="9229300" y="3835908"/>
+            <a:ext cx="155448" cy="155448"/>
+          </a:xfrm>
+          <a:prstGeom prst="ellipse">
+            <a:avLst/>
+          </a:prstGeom>
+          <a:solidFill>
+            <a:srgbClr val="FFFFFF"/>
+          </a:solidFill>
+          <a:ln w="25400">
+            <a:solidFill>
+              <a:srgbClr val="4472C4"/>
+            </a:solidFill>
+          </a:ln>
+          <a:effectLst/>
+        </p:spPr>
+        <p:style>
+          <a:lnRef idx="1">
+            <a:schemeClr val="accent1"/>
+          </a:lnRef>
+          <a:fillRef idx="3">
+            <a:schemeClr val="accent1"/>
+          </a:fillRef>
+          <a:effectRef idx="2">
+            <a:schemeClr val="accent1"/>
+          </a:effectRef>
+          <a:fontRef idx="minor">
+            <a:schemeClr val="lt1"/>
+          </a:fontRef>
+        </p:style>
+        <p:txBody>
+          <a:bodyPr rtlCol="0" anchor="ctr" wrap="square"/>
+          <a:lstStyle/>
+          <a:p>
+            <a:pPr algn="ctr"/>
+          </a:p>
+        </p:txBody>
+      </p:sp>
+      <p:sp>
+        <p:nvSpPr>
+          <p:cNvPr id="25" name="Rectangle 24"/>
+          <p:cNvSpPr/>
+          <p:nvPr/>
+        </p:nvSpPr>
+        <p:spPr>
+          <a:xfrm>
+            <a:off x="8164024" y="2231136"/>
+            <a:ext cx="2286000" cy="1298448"/>
+          </a:xfrm>
+          <a:prstGeom prst="rect">
+            <a:avLst/>
+          </a:prstGeom>
+          <a:solidFill>
+            <a:srgbClr val="EDF2FA"/>
+          </a:solidFill>
+          <a:ln>
+            <a:noFill/>
+          </a:ln>
+          <a:effectLst/>
+        </p:spPr>
+        <p:style>
+          <a:lnRef idx="1">
+            <a:schemeClr val="accent1"/>
+          </a:lnRef>
+          <a:fillRef idx="3">
+            <a:schemeClr val="accent1"/>
+          </a:fillRef>
+          <a:effectRef idx="2">
+            <a:schemeClr val="accent1"/>
+          </a:effectRef>
+          <a:fontRef idx="minor">
+            <a:schemeClr val="lt1"/>
+          </a:fontRef>
+        </p:style>
+        <p:txBody>
+          <a:bodyPr rtlCol="0" anchor="t" wrap="square" lIns="100584" rIns="100584" tIns="73152" bIns="73152"/>
+          <a:lstStyle/>
+          <a:p>
+            <a:pPr algn="l">
+              <a:spcAft>
+                <a:spcPts val="300"/>
+              </a:spcAft>
+            </a:pPr>
+            <a:r>
+              <a:rPr sz="1700" b="1">
+                <a:solidFill>
+                  <a:srgbClr val="4472C4"/>
+                </a:solidFill>
+                <a:latin typeface="Calibri"/>
+              </a:rPr>
+              <a:t>1925</a:t>
+            </a:r>
+          </a:p>
+          <a:p>
+            <a:pPr algn="l"/>
+            <a:r>
+              <a:rPr sz="1050">
+                <a:solidFill>
+                  <a:srgbClr val="262626"/>
+                </a:solidFill>
+                <a:latin typeface="Calibri"/>
+              </a:rPr>
+              <a:t>R. A. Fisher formalizes experimental design, ANOVA, and significance testing.</a:t>
+            </a:r>
+          </a:p>
+        </p:txBody>
+      </p:sp>
+      <p:sp>
+        <p:nvSpPr>
+          <p:cNvPr id="26" name="Rectangle 25"/>
+          <p:cNvSpPr/>
+          <p:nvPr/>
+        </p:nvSpPr>
+        <p:spPr>
+          <a:xfrm>
+            <a:off x="10581436" y="3913632"/>
+            <a:ext cx="20116" cy="384048"/>
+          </a:xfrm>
+          <a:prstGeom prst="rect">
+            <a:avLst/>
+          </a:prstGeom>
+          <a:solidFill>
+            <a:srgbClr val="C5540F"/>
+          </a:solidFill>
+          <a:ln>
+            <a:noFill/>
+          </a:ln>
+          <a:effectLst/>
+        </p:spPr>
+        <p:style>
+          <a:lnRef idx="1">
+            <a:schemeClr val="accent1"/>
+          </a:lnRef>
+          <a:fillRef idx="3">
+            <a:schemeClr val="accent1"/>
+          </a:fillRef>
+          <a:effectRef idx="2">
+            <a:schemeClr val="accent1"/>
+          </a:effectRef>
+          <a:fontRef idx="minor">
+            <a:schemeClr val="lt1"/>
+          </a:fontRef>
+        </p:style>
+        <p:txBody>
+          <a:bodyPr rtlCol="0" anchor="ctr" wrap="square"/>
+          <a:lstStyle/>
+          <a:p>
+            <a:pPr algn="ctr"/>
+          </a:p>
+        </p:txBody>
+      </p:sp>
+      <p:sp>
+        <p:nvSpPr>
+          <p:cNvPr id="27" name="Oval 26"/>
+          <p:cNvSpPr/>
+          <p:nvPr/>
+        </p:nvSpPr>
+        <p:spPr>
+          <a:xfrm>
+            <a:off x="10513771" y="3835908"/>
+            <a:ext cx="155448" cy="155448"/>
+          </a:xfrm>
+          <a:prstGeom prst="ellipse">
+            <a:avLst/>
+          </a:prstGeom>
+          <a:solidFill>
+            <a:srgbClr val="FFFFFF"/>
+          </a:solidFill>
+          <a:ln w="25400">
+            <a:solidFill>
+              <a:srgbClr val="C5540F"/>
+            </a:solidFill>
+          </a:ln>
+          <a:effectLst/>
+        </p:spPr>
+        <p:style>
+          <a:lnRef idx="1">
+            <a:schemeClr val="accent1"/>
+          </a:lnRef>
+          <a:fillRef idx="3">
+            <a:schemeClr val="accent1"/>
+          </a:fillRef>
+          <a:effectRef idx="2">
+            <a:schemeClr val="accent1"/>
+          </a:effectRef>
+          <a:fontRef idx="minor">
+            <a:schemeClr val="lt1"/>
+          </a:fontRef>
+        </p:style>
+        <p:txBody>
+          <a:bodyPr rtlCol="0" anchor="ctr" wrap="square"/>
+          <a:lstStyle/>
+          <a:p>
+            <a:pPr algn="ctr"/>
+          </a:p>
+        </p:txBody>
+      </p:sp>
+      <p:sp>
+        <p:nvSpPr>
+          <p:cNvPr id="28" name="Rectangle 27"/>
+          <p:cNvSpPr/>
+          <p:nvPr/>
+        </p:nvSpPr>
+        <p:spPr>
+          <a:xfrm>
+            <a:off x="9448495" y="4297680"/>
+            <a:ext cx="2286000" cy="1298448"/>
+          </a:xfrm>
+          <a:prstGeom prst="rect">
+            <a:avLst/>
+          </a:prstGeom>
+          <a:solidFill>
+            <a:srgbClr val="FCE6D5"/>
+          </a:solidFill>
+          <a:ln>
+            <a:noFill/>
+          </a:ln>
+          <a:effectLst/>
+        </p:spPr>
+        <p:style>
+          <a:lnRef idx="1">
+            <a:schemeClr val="accent1"/>
+          </a:lnRef>
+          <a:fillRef idx="3">
+            <a:schemeClr val="accent1"/>
+          </a:fillRef>
+          <a:effectRef idx="2">
+            <a:schemeClr val="accent1"/>
+          </a:effectRef>
+          <a:fontRef idx="minor">
+            <a:schemeClr val="lt1"/>
+          </a:fontRef>
+        </p:style>
+        <p:txBody>
+          <a:bodyPr rtlCol="0" anchor="t" wrap="square" lIns="100584" rIns="100584" tIns="73152" bIns="73152"/>
+          <a:lstStyle/>
+          <a:p>
+            <a:pPr algn="l">
+              <a:spcAft>
+                <a:spcPts val="300"/>
+              </a:spcAft>
+            </a:pPr>
+            <a:r>
+              <a:rPr sz="1700" b="1">
+                <a:solidFill>
+                  <a:srgbClr val="C5540F"/>
+                </a:solidFill>
+                <a:latin typeface="Calibri"/>
+              </a:rPr>
+              <a:t>Today</a:t>
+            </a:r>
+          </a:p>
+          <a:p>
+            <a:pPr algn="l"/>
+            <a:r>
+              <a:rPr sz="1050">
+                <a:solidFill>
+                  <a:srgbClr val="262626"/>
+                </a:solidFill>
+                <a:latin typeface="Calibri"/>
+              </a:rPr>
+              <a:t>The same ideas, now run by computers on data far larger than Graunt could count.</a:t>
+            </a:r>
+          </a:p>
+        </p:txBody>
+      </p:sp>
+      <p:sp>
+        <p:nvSpPr>
+          <p:cNvPr id="29" name="TextBox 28"/>
+          <p:cNvSpPr txBox="1"/>
+          <p:nvPr/>
+        </p:nvSpPr>
+        <p:spPr>
+          <a:xfrm>
+            <a:off x="457200" y="6144768"/>
+            <a:ext cx="11292840" cy="566928"/>
+          </a:xfrm>
+          <a:prstGeom prst="rect">
+            <a:avLst/>
+          </a:prstGeom>
+          <a:noFill/>
+        </p:spPr>
+        <p:txBody>
+          <a:bodyPr wrap="square" lIns="0" rIns="0" tIns="0" bIns="0" anchor="t">
+            <a:spAutoFit/>
+          </a:bodyPr>
+          <a:lstStyle/>
+          <a:p>
+            <a:pPr algn="l">
+              <a:spcAft>
+                <a:spcPts val="0"/>
+              </a:spcAft>
+            </a:pPr>
+            <a:r>
+              <a:rPr sz="900" b="0">
+                <a:solidFill>
+                  <a:srgbClr val="595959"/>
+                </a:solidFill>
+                <a:latin typeface="Calibri"/>
+              </a:rPr>
+              <a:t>Sources: J. Graunt (1662), Natural and Political Observations Made upon the Bills of Mortality. E. Halley (1693), Phil. Trans. R. Soc. 17:596–610. G. Achenwall (1749), Abriss der neuesten Staatswissenschaft. A. Quetelet (1835), Sur l’homme et le développement de ses facultés. R. A. Fisher (1925), Statistical Methods for Research Workers.</a:t>
+            </a:r>
+          </a:p>
+        </p:txBody>
+      </p:sp>
+    </p:spTree>
+  </p:cSld>
+  <p:clrMapOvr>
+    <a:masterClrMapping/>
+  </p:clrMapOvr>
 </p:sld>
 </file>
 
@@ -9831,93 +11250,6 @@
           </a:p>
         </p:txBody>
       </p:sp>
-      <p:pic>
-        <p:nvPicPr>
-          <p:cNvPr id="7" name="Picture 6" descr="A group of people in white clothing holding signs&#10;&#10;Description automatically generated">
-            <a:extLst>
-              <a:ext uri="{FF2B5EF4-FFF2-40B4-BE49-F238E27FC236}">
-                <a16:creationId xmlns:a16="http://schemas.microsoft.com/office/drawing/2014/main" id="{A2EC9BD1-8260-5020-E44F-2D2BBFA27357}"/>
-              </a:ext>
-            </a:extLst>
-          </p:cNvPr>
-          <p:cNvPicPr>
-            <a:picLocks noChangeAspect="1"/>
-          </p:cNvPicPr>
-          <p:nvPr/>
-        </p:nvPicPr>
-        <p:blipFill>
-          <a:blip r:embed="rId2">
-            <a:extLst>
-              <a:ext uri="{28A0092B-C50C-407E-A947-70E740481C1C}">
-                <a14:useLocalDpi xmlns:a14="http://schemas.microsoft.com/office/drawing/2010/main" val="0"/>
-              </a:ext>
-              <a:ext uri="{837473B0-CC2E-450A-ABE3-18F120FF3D39}">
-                <a1611:picAttrSrcUrl xmlns:a1611="http://schemas.microsoft.com/office/drawing/2016/11/main" r:id="rId3"/>
-              </a:ext>
-            </a:extLst>
-          </a:blip>
-          <a:stretch>
-            <a:fillRect/>
-          </a:stretch>
-        </p:blipFill>
-        <p:spPr>
-          <a:xfrm>
-            <a:off x="251475" y="3255482"/>
-            <a:ext cx="4801104" cy="3158621"/>
-          </a:xfrm>
-          <a:prstGeom prst="rect">
-            <a:avLst/>
-          </a:prstGeom>
-        </p:spPr>
-      </p:pic>
-      <p:sp>
-        <p:nvSpPr>
-          <p:cNvPr id="8" name="TextBox 7">
-            <a:extLst>
-              <a:ext uri="{FF2B5EF4-FFF2-40B4-BE49-F238E27FC236}">
-                <a16:creationId xmlns:a16="http://schemas.microsoft.com/office/drawing/2014/main" id="{A7096998-98C8-857E-95FB-A8387761F0D2}"/>
-              </a:ext>
-            </a:extLst>
-          </p:cNvPr>
-          <p:cNvSpPr txBox="1"/>
-          <p:nvPr/>
-        </p:nvSpPr>
-        <p:spPr>
-          <a:xfrm>
-            <a:off x="490631" y="6627168"/>
-            <a:ext cx="4561948" cy="230832"/>
-          </a:xfrm>
-          <a:prstGeom prst="rect">
-            <a:avLst/>
-          </a:prstGeom>
-          <a:noFill/>
-        </p:spPr>
-        <p:txBody>
-          <a:bodyPr wrap="square" rtlCol="0">
-            <a:spAutoFit/>
-          </a:bodyPr>
-          <a:lstStyle/>
-          <a:p>
-            <a:r>
-              <a:rPr lang="en-US" sz="900">
-                <a:hlinkClick r:id="rId3" tooltip="https://fiftyfourandahalf.com/2017/09/27/i-tried-to-ignore-it/"/>
-              </a:rPr>
-              <a:t>This Photo</a:t>
-            </a:r>
-            <a:r>
-              <a:rPr lang="en-US" sz="900"/>
-              <a:t> by Unknown Author is licensed under </a:t>
-            </a:r>
-            <a:r>
-              <a:rPr lang="en-US" sz="900">
-                <a:hlinkClick r:id="rId4" tooltip="https://creativecommons.org/licenses/by-nc-nd/3.0/"/>
-              </a:rPr>
-              <a:t>CC BY-NC-ND</a:t>
-            </a:r>
-            <a:endParaRPr lang="en-US" sz="900"/>
-          </a:p>
-        </p:txBody>
-      </p:sp>
       <p:sp>
         <p:nvSpPr>
           <p:cNvPr id="9" name="Content Placeholder 2">
@@ -9936,8 +11268,8 @@
         </p:nvSpPr>
         <p:spPr>
           <a:xfrm>
-            <a:off x="251475" y="1668463"/>
-            <a:ext cx="4874707" cy="1444192"/>
+            <a:off x="274320" y="1481328"/>
+            <a:ext cx="4709160" cy="1600200"/>
           </a:xfrm>
         </p:spPr>
         <p:txBody>
@@ -9951,32 +11283,14 @@
             </a:pPr>
             <a:r>
               <a:rPr lang="en-US" sz="2000" dirty="0"/>
-              <a:t>The following table contains fictional data consisting of 20 observations of storm troopers who have just graduated from the Empire’s Imperial Academy. The height, age, blaster accuracy, and future duty posting are recorded for each storm trooper</a:t>
-            </a:r>
-          </a:p>
-          <a:p>
-            <a:pPr marL="0" indent="0">
-              <a:buNone/>
-            </a:pPr>
-            <a:endParaRPr lang="en-US" sz="1700" dirty="0"/>
-          </a:p>
-          <a:p>
-            <a:pPr marL="0" indent="0">
-              <a:buNone/>
-            </a:pPr>
-            <a:endParaRPr lang="en-US" sz="1700" dirty="0"/>
+              <a:t>The following table contains data on 20 clients contacted during a bank’s direct marketing campaign for a term deposit account. For each client, the job, education level, age, account balance, length of the marketing call, and whether they subscribed are recorded</a:t>
+            </a:r>
           </a:p>
         </p:txBody>
       </p:sp>
       <p:pic>
         <p:nvPicPr>
-          <p:cNvPr id="6" name="Picture 5">
-            <a:extLst>
-              <a:ext uri="{FF2B5EF4-FFF2-40B4-BE49-F238E27FC236}">
-                <a16:creationId xmlns:a16="http://schemas.microsoft.com/office/drawing/2014/main" id="{1ECB865F-D03E-CA2D-A9BA-F83432805318}"/>
-              </a:ext>
-            </a:extLst>
-          </p:cNvPr>
+          <p:cNvPr id="10" name="Picture 9" descr="image.png"/>
           <p:cNvPicPr>
             <a:picLocks noChangeAspect="1"/>
           </p:cNvPicPr>
@@ -9990,14 +11304,1545 @@
         </p:blipFill>
         <p:spPr>
           <a:xfrm>
-            <a:off x="5248970" y="1569639"/>
-            <a:ext cx="6943030" cy="4838700"/>
+            <a:off x="5138928" y="1389888"/>
+            <a:ext cx="6812280" cy="4293155"/>
           </a:xfrm>
           <a:prstGeom prst="rect">
             <a:avLst/>
           </a:prstGeom>
         </p:spPr>
       </p:pic>
+      <p:sp>
+        <p:nvSpPr>
+          <p:cNvPr id="11" name="TextBox 10"/>
+          <p:cNvSpPr txBox="1"/>
+          <p:nvPr/>
+        </p:nvSpPr>
+        <p:spPr>
+          <a:xfrm>
+            <a:off x="365760" y="3218688"/>
+            <a:ext cx="4663440" cy="274320"/>
+          </a:xfrm>
+          <a:prstGeom prst="rect">
+            <a:avLst/>
+          </a:prstGeom>
+          <a:noFill/>
+        </p:spPr>
+        <p:txBody>
+          <a:bodyPr wrap="square" lIns="0" rIns="0" tIns="0" bIns="0" anchor="t">
+            <a:spAutoFit/>
+          </a:bodyPr>
+          <a:lstStyle/>
+          <a:p>
+            <a:pPr algn="l">
+              <a:spcAft>
+                <a:spcPts val="0"/>
+              </a:spcAft>
+            </a:pPr>
+            <a:r>
+              <a:rPr sz="1500" b="1">
+                <a:solidFill>
+                  <a:srgbClr val="000000"/>
+                </a:solidFill>
+                <a:latin typeface="Calibri"/>
+              </a:rPr>
+              <a:t>Reading a data table</a:t>
+            </a:r>
+          </a:p>
+        </p:txBody>
+      </p:sp>
+      <p:sp>
+        <p:nvSpPr>
+          <p:cNvPr id="12" name="TextBox 11"/>
+          <p:cNvSpPr txBox="1"/>
+          <p:nvPr/>
+        </p:nvSpPr>
+        <p:spPr>
+          <a:xfrm>
+            <a:off x="365760" y="3584448"/>
+            <a:ext cx="4663440" cy="237744"/>
+          </a:xfrm>
+          <a:prstGeom prst="rect">
+            <a:avLst/>
+          </a:prstGeom>
+          <a:noFill/>
+        </p:spPr>
+        <p:txBody>
+          <a:bodyPr wrap="square" lIns="0" rIns="0" tIns="0" bIns="0" anchor="t">
+            <a:spAutoFit/>
+          </a:bodyPr>
+          <a:lstStyle/>
+          <a:p>
+            <a:pPr algn="l">
+              <a:spcAft>
+                <a:spcPts val="0"/>
+              </a:spcAft>
+            </a:pPr>
+            <a:r>
+              <a:rPr sz="1150" b="1">
+                <a:solidFill>
+                  <a:srgbClr val="C5540F"/>
+                </a:solidFill>
+                <a:latin typeface="Calibri"/>
+              </a:rPr>
+              <a:t>Each column is a variable</a:t>
+            </a:r>
+          </a:p>
+        </p:txBody>
+      </p:sp>
+      <p:sp>
+        <p:nvSpPr>
+          <p:cNvPr id="13" name="Rectangle 12"/>
+          <p:cNvSpPr/>
+          <p:nvPr/>
+        </p:nvSpPr>
+        <p:spPr>
+          <a:xfrm>
+            <a:off x="365760" y="3950208"/>
+            <a:ext cx="896112" cy="256032"/>
+          </a:xfrm>
+          <a:prstGeom prst="rect">
+            <a:avLst/>
+          </a:prstGeom>
+          <a:solidFill>
+            <a:srgbClr val="EFEFEF"/>
+          </a:solidFill>
+          <a:ln w="9525">
+            <a:solidFill>
+              <a:srgbClr val="BFBFBF"/>
+            </a:solidFill>
+          </a:ln>
+          <a:effectLst/>
+        </p:spPr>
+        <p:style>
+          <a:lnRef idx="1">
+            <a:schemeClr val="accent1"/>
+          </a:lnRef>
+          <a:fillRef idx="3">
+            <a:schemeClr val="accent1"/>
+          </a:fillRef>
+          <a:effectRef idx="2">
+            <a:schemeClr val="accent1"/>
+          </a:effectRef>
+          <a:fontRef idx="minor">
+            <a:schemeClr val="lt1"/>
+          </a:fontRef>
+        </p:style>
+        <p:txBody>
+          <a:bodyPr rtlCol="0" anchor="ctr" wrap="square" lIns="27432" rIns="27432" tIns="0" bIns="0"/>
+          <a:lstStyle/>
+          <a:p>
+            <a:pPr algn="ctr"/>
+            <a:r>
+              <a:rPr sz="850" b="1">
+                <a:solidFill>
+                  <a:srgbClr val="404040"/>
+                </a:solidFill>
+                <a:latin typeface="Calibri"/>
+              </a:rPr>
+              <a:t>Client ID</a:t>
+            </a:r>
+          </a:p>
+        </p:txBody>
+      </p:sp>
+      <p:sp>
+        <p:nvSpPr>
+          <p:cNvPr id="14" name="Rectangle 13"/>
+          <p:cNvSpPr/>
+          <p:nvPr/>
+        </p:nvSpPr>
+        <p:spPr>
+          <a:xfrm>
+            <a:off x="1261872" y="3950208"/>
+            <a:ext cx="896112" cy="256032"/>
+          </a:xfrm>
+          <a:prstGeom prst="rect">
+            <a:avLst/>
+          </a:prstGeom>
+          <a:solidFill>
+            <a:srgbClr val="EFEFEF"/>
+          </a:solidFill>
+          <a:ln w="9525">
+            <a:solidFill>
+              <a:srgbClr val="BFBFBF"/>
+            </a:solidFill>
+          </a:ln>
+          <a:effectLst/>
+        </p:spPr>
+        <p:style>
+          <a:lnRef idx="1">
+            <a:schemeClr val="accent1"/>
+          </a:lnRef>
+          <a:fillRef idx="3">
+            <a:schemeClr val="accent1"/>
+          </a:fillRef>
+          <a:effectRef idx="2">
+            <a:schemeClr val="accent1"/>
+          </a:effectRef>
+          <a:fontRef idx="minor">
+            <a:schemeClr val="lt1"/>
+          </a:fontRef>
+        </p:style>
+        <p:txBody>
+          <a:bodyPr rtlCol="0" anchor="ctr" wrap="square" lIns="27432" rIns="27432" tIns="0" bIns="0"/>
+          <a:lstStyle/>
+          <a:p>
+            <a:pPr algn="ctr"/>
+            <a:r>
+              <a:rPr sz="850" b="1">
+                <a:solidFill>
+                  <a:srgbClr val="404040"/>
+                </a:solidFill>
+                <a:latin typeface="Calibri"/>
+              </a:rPr>
+              <a:t>Job</a:t>
+            </a:r>
+          </a:p>
+        </p:txBody>
+      </p:sp>
+      <p:sp>
+        <p:nvSpPr>
+          <p:cNvPr id="15" name="Rectangle 14"/>
+          <p:cNvSpPr/>
+          <p:nvPr/>
+        </p:nvSpPr>
+        <p:spPr>
+          <a:xfrm>
+            <a:off x="2157984" y="3950208"/>
+            <a:ext cx="896112" cy="256032"/>
+          </a:xfrm>
+          <a:prstGeom prst="rect">
+            <a:avLst/>
+          </a:prstGeom>
+          <a:solidFill>
+            <a:srgbClr val="FCE6D5"/>
+          </a:solidFill>
+          <a:ln w="9525">
+            <a:solidFill>
+              <a:srgbClr val="BFBFBF"/>
+            </a:solidFill>
+          </a:ln>
+          <a:effectLst/>
+        </p:spPr>
+        <p:style>
+          <a:lnRef idx="1">
+            <a:schemeClr val="accent1"/>
+          </a:lnRef>
+          <a:fillRef idx="3">
+            <a:schemeClr val="accent1"/>
+          </a:fillRef>
+          <a:effectRef idx="2">
+            <a:schemeClr val="accent1"/>
+          </a:effectRef>
+          <a:fontRef idx="minor">
+            <a:schemeClr val="lt1"/>
+          </a:fontRef>
+        </p:style>
+        <p:txBody>
+          <a:bodyPr rtlCol="0" anchor="ctr" wrap="square" lIns="27432" rIns="27432" tIns="0" bIns="0"/>
+          <a:lstStyle/>
+          <a:p>
+            <a:pPr algn="ctr"/>
+            <a:r>
+              <a:rPr sz="850" b="1">
+                <a:solidFill>
+                  <a:srgbClr val="C5540F"/>
+                </a:solidFill>
+                <a:latin typeface="Calibri"/>
+              </a:rPr>
+              <a:t>Age</a:t>
+            </a:r>
+          </a:p>
+        </p:txBody>
+      </p:sp>
+      <p:sp>
+        <p:nvSpPr>
+          <p:cNvPr id="16" name="Rectangle 15"/>
+          <p:cNvSpPr/>
+          <p:nvPr/>
+        </p:nvSpPr>
+        <p:spPr>
+          <a:xfrm>
+            <a:off x="3054096" y="3950208"/>
+            <a:ext cx="896112" cy="256032"/>
+          </a:xfrm>
+          <a:prstGeom prst="rect">
+            <a:avLst/>
+          </a:prstGeom>
+          <a:solidFill>
+            <a:srgbClr val="EFEFEF"/>
+          </a:solidFill>
+          <a:ln w="9525">
+            <a:solidFill>
+              <a:srgbClr val="BFBFBF"/>
+            </a:solidFill>
+          </a:ln>
+          <a:effectLst/>
+        </p:spPr>
+        <p:style>
+          <a:lnRef idx="1">
+            <a:schemeClr val="accent1"/>
+          </a:lnRef>
+          <a:fillRef idx="3">
+            <a:schemeClr val="accent1"/>
+          </a:fillRef>
+          <a:effectRef idx="2">
+            <a:schemeClr val="accent1"/>
+          </a:effectRef>
+          <a:fontRef idx="minor">
+            <a:schemeClr val="lt1"/>
+          </a:fontRef>
+        </p:style>
+        <p:txBody>
+          <a:bodyPr rtlCol="0" anchor="ctr" wrap="square" lIns="27432" rIns="27432" tIns="0" bIns="0"/>
+          <a:lstStyle/>
+          <a:p>
+            <a:pPr algn="ctr"/>
+            <a:r>
+              <a:rPr sz="850" b="1">
+                <a:solidFill>
+                  <a:srgbClr val="404040"/>
+                </a:solidFill>
+                <a:latin typeface="Calibri"/>
+              </a:rPr>
+              <a:t>Balance</a:t>
+            </a:r>
+          </a:p>
+        </p:txBody>
+      </p:sp>
+      <p:sp>
+        <p:nvSpPr>
+          <p:cNvPr id="17" name="Rectangle 16"/>
+          <p:cNvSpPr/>
+          <p:nvPr/>
+        </p:nvSpPr>
+        <p:spPr>
+          <a:xfrm>
+            <a:off x="3950208" y="3950208"/>
+            <a:ext cx="896112" cy="256032"/>
+          </a:xfrm>
+          <a:prstGeom prst="rect">
+            <a:avLst/>
+          </a:prstGeom>
+          <a:solidFill>
+            <a:srgbClr val="EFEFEF"/>
+          </a:solidFill>
+          <a:ln w="9525">
+            <a:solidFill>
+              <a:srgbClr val="BFBFBF"/>
+            </a:solidFill>
+          </a:ln>
+          <a:effectLst/>
+        </p:spPr>
+        <p:style>
+          <a:lnRef idx="1">
+            <a:schemeClr val="accent1"/>
+          </a:lnRef>
+          <a:fillRef idx="3">
+            <a:schemeClr val="accent1"/>
+          </a:fillRef>
+          <a:effectRef idx="2">
+            <a:schemeClr val="accent1"/>
+          </a:effectRef>
+          <a:fontRef idx="minor">
+            <a:schemeClr val="lt1"/>
+          </a:fontRef>
+        </p:style>
+        <p:txBody>
+          <a:bodyPr rtlCol="0" anchor="ctr" wrap="square" lIns="27432" rIns="27432" tIns="0" bIns="0"/>
+          <a:lstStyle/>
+          <a:p>
+            <a:pPr algn="ctr"/>
+            <a:r>
+              <a:rPr sz="850" b="1">
+                <a:solidFill>
+                  <a:srgbClr val="404040"/>
+                </a:solidFill>
+                <a:latin typeface="Calibri"/>
+              </a:rPr>
+              <a:t>Subscribed</a:t>
+            </a:r>
+          </a:p>
+        </p:txBody>
+      </p:sp>
+      <p:sp>
+        <p:nvSpPr>
+          <p:cNvPr id="18" name="Rectangle 17"/>
+          <p:cNvSpPr/>
+          <p:nvPr/>
+        </p:nvSpPr>
+        <p:spPr>
+          <a:xfrm>
+            <a:off x="365760" y="4206240"/>
+            <a:ext cx="896112" cy="256032"/>
+          </a:xfrm>
+          <a:prstGeom prst="rect">
+            <a:avLst/>
+          </a:prstGeom>
+          <a:solidFill>
+            <a:srgbClr val="FFFFFF"/>
+          </a:solidFill>
+          <a:ln w="9525">
+            <a:solidFill>
+              <a:srgbClr val="BFBFBF"/>
+            </a:solidFill>
+          </a:ln>
+          <a:effectLst/>
+        </p:spPr>
+        <p:style>
+          <a:lnRef idx="1">
+            <a:schemeClr val="accent1"/>
+          </a:lnRef>
+          <a:fillRef idx="3">
+            <a:schemeClr val="accent1"/>
+          </a:fillRef>
+          <a:effectRef idx="2">
+            <a:schemeClr val="accent1"/>
+          </a:effectRef>
+          <a:fontRef idx="minor">
+            <a:schemeClr val="lt1"/>
+          </a:fontRef>
+        </p:style>
+        <p:txBody>
+          <a:bodyPr rtlCol="0" anchor="ctr" wrap="square" lIns="27432" rIns="27432" tIns="0" bIns="0"/>
+          <a:lstStyle/>
+          <a:p>
+            <a:pPr algn="ctr"/>
+            <a:r>
+              <a:rPr sz="850" b="0">
+                <a:solidFill>
+                  <a:srgbClr val="262626"/>
+                </a:solidFill>
+                <a:latin typeface="Calibri"/>
+              </a:rPr>
+              <a:t>C-1047</a:t>
+            </a:r>
+          </a:p>
+        </p:txBody>
+      </p:sp>
+      <p:sp>
+        <p:nvSpPr>
+          <p:cNvPr id="19" name="Rectangle 18"/>
+          <p:cNvSpPr/>
+          <p:nvPr/>
+        </p:nvSpPr>
+        <p:spPr>
+          <a:xfrm>
+            <a:off x="1261872" y="4206240"/>
+            <a:ext cx="896112" cy="256032"/>
+          </a:xfrm>
+          <a:prstGeom prst="rect">
+            <a:avLst/>
+          </a:prstGeom>
+          <a:solidFill>
+            <a:srgbClr val="FFFFFF"/>
+          </a:solidFill>
+          <a:ln w="9525">
+            <a:solidFill>
+              <a:srgbClr val="BFBFBF"/>
+            </a:solidFill>
+          </a:ln>
+          <a:effectLst/>
+        </p:spPr>
+        <p:style>
+          <a:lnRef idx="1">
+            <a:schemeClr val="accent1"/>
+          </a:lnRef>
+          <a:fillRef idx="3">
+            <a:schemeClr val="accent1"/>
+          </a:fillRef>
+          <a:effectRef idx="2">
+            <a:schemeClr val="accent1"/>
+          </a:effectRef>
+          <a:fontRef idx="minor">
+            <a:schemeClr val="lt1"/>
+          </a:fontRef>
+        </p:style>
+        <p:txBody>
+          <a:bodyPr rtlCol="0" anchor="ctr" wrap="square" lIns="27432" rIns="27432" tIns="0" bIns="0"/>
+          <a:lstStyle/>
+          <a:p>
+            <a:pPr algn="ctr"/>
+            <a:r>
+              <a:rPr sz="850" b="0">
+                <a:solidFill>
+                  <a:srgbClr val="262626"/>
+                </a:solidFill>
+                <a:latin typeface="Calibri"/>
+              </a:rPr>
+              <a:t>mgmt</a:t>
+            </a:r>
+          </a:p>
+        </p:txBody>
+      </p:sp>
+      <p:sp>
+        <p:nvSpPr>
+          <p:cNvPr id="20" name="Rectangle 19"/>
+          <p:cNvSpPr/>
+          <p:nvPr/>
+        </p:nvSpPr>
+        <p:spPr>
+          <a:xfrm>
+            <a:off x="2157984" y="4206240"/>
+            <a:ext cx="896112" cy="256032"/>
+          </a:xfrm>
+          <a:prstGeom prst="rect">
+            <a:avLst/>
+          </a:prstGeom>
+          <a:solidFill>
+            <a:srgbClr val="FCE6D5"/>
+          </a:solidFill>
+          <a:ln w="9525">
+            <a:solidFill>
+              <a:srgbClr val="BFBFBF"/>
+            </a:solidFill>
+          </a:ln>
+          <a:effectLst/>
+        </p:spPr>
+        <p:style>
+          <a:lnRef idx="1">
+            <a:schemeClr val="accent1"/>
+          </a:lnRef>
+          <a:fillRef idx="3">
+            <a:schemeClr val="accent1"/>
+          </a:fillRef>
+          <a:effectRef idx="2">
+            <a:schemeClr val="accent1"/>
+          </a:effectRef>
+          <a:fontRef idx="minor">
+            <a:schemeClr val="lt1"/>
+          </a:fontRef>
+        </p:style>
+        <p:txBody>
+          <a:bodyPr rtlCol="0" anchor="ctr" wrap="square" lIns="27432" rIns="27432" tIns="0" bIns="0"/>
+          <a:lstStyle/>
+          <a:p>
+            <a:pPr algn="ctr"/>
+            <a:r>
+              <a:rPr sz="850" b="0">
+                <a:solidFill>
+                  <a:srgbClr val="262626"/>
+                </a:solidFill>
+                <a:latin typeface="Calibri"/>
+              </a:rPr>
+              <a:t>42</a:t>
+            </a:r>
+          </a:p>
+        </p:txBody>
+      </p:sp>
+      <p:sp>
+        <p:nvSpPr>
+          <p:cNvPr id="21" name="Rectangle 20"/>
+          <p:cNvSpPr/>
+          <p:nvPr/>
+        </p:nvSpPr>
+        <p:spPr>
+          <a:xfrm>
+            <a:off x="3054096" y="4206240"/>
+            <a:ext cx="896112" cy="256032"/>
+          </a:xfrm>
+          <a:prstGeom prst="rect">
+            <a:avLst/>
+          </a:prstGeom>
+          <a:solidFill>
+            <a:srgbClr val="FFFFFF"/>
+          </a:solidFill>
+          <a:ln w="9525">
+            <a:solidFill>
+              <a:srgbClr val="BFBFBF"/>
+            </a:solidFill>
+          </a:ln>
+          <a:effectLst/>
+        </p:spPr>
+        <p:style>
+          <a:lnRef idx="1">
+            <a:schemeClr val="accent1"/>
+          </a:lnRef>
+          <a:fillRef idx="3">
+            <a:schemeClr val="accent1"/>
+          </a:fillRef>
+          <a:effectRef idx="2">
+            <a:schemeClr val="accent1"/>
+          </a:effectRef>
+          <a:fontRef idx="minor">
+            <a:schemeClr val="lt1"/>
+          </a:fontRef>
+        </p:style>
+        <p:txBody>
+          <a:bodyPr rtlCol="0" anchor="ctr" wrap="square" lIns="27432" rIns="27432" tIns="0" bIns="0"/>
+          <a:lstStyle/>
+          <a:p>
+            <a:pPr algn="ctr"/>
+            <a:r>
+              <a:rPr sz="850" b="0">
+                <a:solidFill>
+                  <a:srgbClr val="262626"/>
+                </a:solidFill>
+                <a:latin typeface="Calibri"/>
+              </a:rPr>
+              <a:t>2,143</a:t>
+            </a:r>
+          </a:p>
+        </p:txBody>
+      </p:sp>
+      <p:sp>
+        <p:nvSpPr>
+          <p:cNvPr id="22" name="Rectangle 21"/>
+          <p:cNvSpPr/>
+          <p:nvPr/>
+        </p:nvSpPr>
+        <p:spPr>
+          <a:xfrm>
+            <a:off x="3950208" y="4206240"/>
+            <a:ext cx="896112" cy="256032"/>
+          </a:xfrm>
+          <a:prstGeom prst="rect">
+            <a:avLst/>
+          </a:prstGeom>
+          <a:solidFill>
+            <a:srgbClr val="FFFFFF"/>
+          </a:solidFill>
+          <a:ln w="9525">
+            <a:solidFill>
+              <a:srgbClr val="BFBFBF"/>
+            </a:solidFill>
+          </a:ln>
+          <a:effectLst/>
+        </p:spPr>
+        <p:style>
+          <a:lnRef idx="1">
+            <a:schemeClr val="accent1"/>
+          </a:lnRef>
+          <a:fillRef idx="3">
+            <a:schemeClr val="accent1"/>
+          </a:fillRef>
+          <a:effectRef idx="2">
+            <a:schemeClr val="accent1"/>
+          </a:effectRef>
+          <a:fontRef idx="minor">
+            <a:schemeClr val="lt1"/>
+          </a:fontRef>
+        </p:style>
+        <p:txBody>
+          <a:bodyPr rtlCol="0" anchor="ctr" wrap="square" lIns="27432" rIns="27432" tIns="0" bIns="0"/>
+          <a:lstStyle/>
+          <a:p>
+            <a:pPr algn="ctr"/>
+            <a:r>
+              <a:rPr sz="850" b="0">
+                <a:solidFill>
+                  <a:srgbClr val="262626"/>
+                </a:solidFill>
+                <a:latin typeface="Calibri"/>
+              </a:rPr>
+              <a:t>no</a:t>
+            </a:r>
+          </a:p>
+        </p:txBody>
+      </p:sp>
+      <p:sp>
+        <p:nvSpPr>
+          <p:cNvPr id="23" name="Rectangle 22"/>
+          <p:cNvSpPr/>
+          <p:nvPr/>
+        </p:nvSpPr>
+        <p:spPr>
+          <a:xfrm>
+            <a:off x="365760" y="4462272"/>
+            <a:ext cx="896112" cy="256032"/>
+          </a:xfrm>
+          <a:prstGeom prst="rect">
+            <a:avLst/>
+          </a:prstGeom>
+          <a:solidFill>
+            <a:srgbClr val="FFFFFF"/>
+          </a:solidFill>
+          <a:ln w="9525">
+            <a:solidFill>
+              <a:srgbClr val="BFBFBF"/>
+            </a:solidFill>
+          </a:ln>
+          <a:effectLst/>
+        </p:spPr>
+        <p:style>
+          <a:lnRef idx="1">
+            <a:schemeClr val="accent1"/>
+          </a:lnRef>
+          <a:fillRef idx="3">
+            <a:schemeClr val="accent1"/>
+          </a:fillRef>
+          <a:effectRef idx="2">
+            <a:schemeClr val="accent1"/>
+          </a:effectRef>
+          <a:fontRef idx="minor">
+            <a:schemeClr val="lt1"/>
+          </a:fontRef>
+        </p:style>
+        <p:txBody>
+          <a:bodyPr rtlCol="0" anchor="ctr" wrap="square" lIns="27432" rIns="27432" tIns="0" bIns="0"/>
+          <a:lstStyle/>
+          <a:p>
+            <a:pPr algn="ctr"/>
+            <a:r>
+              <a:rPr sz="850" b="0">
+                <a:solidFill>
+                  <a:srgbClr val="262626"/>
+                </a:solidFill>
+                <a:latin typeface="Calibri"/>
+              </a:rPr>
+              <a:t>C-1052</a:t>
+            </a:r>
+          </a:p>
+        </p:txBody>
+      </p:sp>
+      <p:sp>
+        <p:nvSpPr>
+          <p:cNvPr id="24" name="Rectangle 23"/>
+          <p:cNvSpPr/>
+          <p:nvPr/>
+        </p:nvSpPr>
+        <p:spPr>
+          <a:xfrm>
+            <a:off x="1261872" y="4462272"/>
+            <a:ext cx="896112" cy="256032"/>
+          </a:xfrm>
+          <a:prstGeom prst="rect">
+            <a:avLst/>
+          </a:prstGeom>
+          <a:solidFill>
+            <a:srgbClr val="FFFFFF"/>
+          </a:solidFill>
+          <a:ln w="9525">
+            <a:solidFill>
+              <a:srgbClr val="BFBFBF"/>
+            </a:solidFill>
+          </a:ln>
+          <a:effectLst/>
+        </p:spPr>
+        <p:style>
+          <a:lnRef idx="1">
+            <a:schemeClr val="accent1"/>
+          </a:lnRef>
+          <a:fillRef idx="3">
+            <a:schemeClr val="accent1"/>
+          </a:fillRef>
+          <a:effectRef idx="2">
+            <a:schemeClr val="accent1"/>
+          </a:effectRef>
+          <a:fontRef idx="minor">
+            <a:schemeClr val="lt1"/>
+          </a:fontRef>
+        </p:style>
+        <p:txBody>
+          <a:bodyPr rtlCol="0" anchor="ctr" wrap="square" lIns="27432" rIns="27432" tIns="0" bIns="0"/>
+          <a:lstStyle/>
+          <a:p>
+            <a:pPr algn="ctr"/>
+            <a:r>
+              <a:rPr sz="850" b="0">
+                <a:solidFill>
+                  <a:srgbClr val="262626"/>
+                </a:solidFill>
+                <a:latin typeface="Calibri"/>
+              </a:rPr>
+              <a:t>blue</a:t>
+            </a:r>
+          </a:p>
+        </p:txBody>
+      </p:sp>
+      <p:sp>
+        <p:nvSpPr>
+          <p:cNvPr id="25" name="Rectangle 24"/>
+          <p:cNvSpPr/>
+          <p:nvPr/>
+        </p:nvSpPr>
+        <p:spPr>
+          <a:xfrm>
+            <a:off x="2157984" y="4462272"/>
+            <a:ext cx="896112" cy="256032"/>
+          </a:xfrm>
+          <a:prstGeom prst="rect">
+            <a:avLst/>
+          </a:prstGeom>
+          <a:solidFill>
+            <a:srgbClr val="FCE6D5"/>
+          </a:solidFill>
+          <a:ln w="9525">
+            <a:solidFill>
+              <a:srgbClr val="BFBFBF"/>
+            </a:solidFill>
+          </a:ln>
+          <a:effectLst/>
+        </p:spPr>
+        <p:style>
+          <a:lnRef idx="1">
+            <a:schemeClr val="accent1"/>
+          </a:lnRef>
+          <a:fillRef idx="3">
+            <a:schemeClr val="accent1"/>
+          </a:fillRef>
+          <a:effectRef idx="2">
+            <a:schemeClr val="accent1"/>
+          </a:effectRef>
+          <a:fontRef idx="minor">
+            <a:schemeClr val="lt1"/>
+          </a:fontRef>
+        </p:style>
+        <p:txBody>
+          <a:bodyPr rtlCol="0" anchor="ctr" wrap="square" lIns="27432" rIns="27432" tIns="0" bIns="0"/>
+          <a:lstStyle/>
+          <a:p>
+            <a:pPr algn="ctr"/>
+            <a:r>
+              <a:rPr sz="850" b="0">
+                <a:solidFill>
+                  <a:srgbClr val="262626"/>
+                </a:solidFill>
+                <a:latin typeface="Calibri"/>
+              </a:rPr>
+              <a:t>35</a:t>
+            </a:r>
+          </a:p>
+        </p:txBody>
+      </p:sp>
+      <p:sp>
+        <p:nvSpPr>
+          <p:cNvPr id="26" name="Rectangle 25"/>
+          <p:cNvSpPr/>
+          <p:nvPr/>
+        </p:nvSpPr>
+        <p:spPr>
+          <a:xfrm>
+            <a:off x="3054096" y="4462272"/>
+            <a:ext cx="896112" cy="256032"/>
+          </a:xfrm>
+          <a:prstGeom prst="rect">
+            <a:avLst/>
+          </a:prstGeom>
+          <a:solidFill>
+            <a:srgbClr val="FFFFFF"/>
+          </a:solidFill>
+          <a:ln w="9525">
+            <a:solidFill>
+              <a:srgbClr val="BFBFBF"/>
+            </a:solidFill>
+          </a:ln>
+          <a:effectLst/>
+        </p:spPr>
+        <p:style>
+          <a:lnRef idx="1">
+            <a:schemeClr val="accent1"/>
+          </a:lnRef>
+          <a:fillRef idx="3">
+            <a:schemeClr val="accent1"/>
+          </a:fillRef>
+          <a:effectRef idx="2">
+            <a:schemeClr val="accent1"/>
+          </a:effectRef>
+          <a:fontRef idx="minor">
+            <a:schemeClr val="lt1"/>
+          </a:fontRef>
+        </p:style>
+        <p:txBody>
+          <a:bodyPr rtlCol="0" anchor="ctr" wrap="square" lIns="27432" rIns="27432" tIns="0" bIns="0"/>
+          <a:lstStyle/>
+          <a:p>
+            <a:pPr algn="ctr"/>
+            <a:r>
+              <a:rPr sz="850" b="0">
+                <a:solidFill>
+                  <a:srgbClr val="262626"/>
+                </a:solidFill>
+                <a:latin typeface="Calibri"/>
+              </a:rPr>
+              <a:t>413</a:t>
+            </a:r>
+          </a:p>
+        </p:txBody>
+      </p:sp>
+      <p:sp>
+        <p:nvSpPr>
+          <p:cNvPr id="27" name="Rectangle 26"/>
+          <p:cNvSpPr/>
+          <p:nvPr/>
+        </p:nvSpPr>
+        <p:spPr>
+          <a:xfrm>
+            <a:off x="3950208" y="4462272"/>
+            <a:ext cx="896112" cy="256032"/>
+          </a:xfrm>
+          <a:prstGeom prst="rect">
+            <a:avLst/>
+          </a:prstGeom>
+          <a:solidFill>
+            <a:srgbClr val="FFFFFF"/>
+          </a:solidFill>
+          <a:ln w="9525">
+            <a:solidFill>
+              <a:srgbClr val="BFBFBF"/>
+            </a:solidFill>
+          </a:ln>
+          <a:effectLst/>
+        </p:spPr>
+        <p:style>
+          <a:lnRef idx="1">
+            <a:schemeClr val="accent1"/>
+          </a:lnRef>
+          <a:fillRef idx="3">
+            <a:schemeClr val="accent1"/>
+          </a:fillRef>
+          <a:effectRef idx="2">
+            <a:schemeClr val="accent1"/>
+          </a:effectRef>
+          <a:fontRef idx="minor">
+            <a:schemeClr val="lt1"/>
+          </a:fontRef>
+        </p:style>
+        <p:txBody>
+          <a:bodyPr rtlCol="0" anchor="ctr" wrap="square" lIns="27432" rIns="27432" tIns="0" bIns="0"/>
+          <a:lstStyle/>
+          <a:p>
+            <a:pPr algn="ctr"/>
+            <a:r>
+              <a:rPr sz="850" b="0">
+                <a:solidFill>
+                  <a:srgbClr val="262626"/>
+                </a:solidFill>
+                <a:latin typeface="Calibri"/>
+              </a:rPr>
+              <a:t>no</a:t>
+            </a:r>
+          </a:p>
+        </p:txBody>
+      </p:sp>
+      <p:sp>
+        <p:nvSpPr>
+          <p:cNvPr id="28" name="Rectangle 27"/>
+          <p:cNvSpPr/>
+          <p:nvPr/>
+        </p:nvSpPr>
+        <p:spPr>
+          <a:xfrm>
+            <a:off x="365760" y="4718304"/>
+            <a:ext cx="896112" cy="256032"/>
+          </a:xfrm>
+          <a:prstGeom prst="rect">
+            <a:avLst/>
+          </a:prstGeom>
+          <a:solidFill>
+            <a:srgbClr val="DCE6F5"/>
+          </a:solidFill>
+          <a:ln w="9525">
+            <a:solidFill>
+              <a:srgbClr val="BFBFBF"/>
+            </a:solidFill>
+          </a:ln>
+          <a:effectLst/>
+        </p:spPr>
+        <p:style>
+          <a:lnRef idx="1">
+            <a:schemeClr val="accent1"/>
+          </a:lnRef>
+          <a:fillRef idx="3">
+            <a:schemeClr val="accent1"/>
+          </a:fillRef>
+          <a:effectRef idx="2">
+            <a:schemeClr val="accent1"/>
+          </a:effectRef>
+          <a:fontRef idx="minor">
+            <a:schemeClr val="lt1"/>
+          </a:fontRef>
+        </p:style>
+        <p:txBody>
+          <a:bodyPr rtlCol="0" anchor="ctr" wrap="square" lIns="27432" rIns="27432" tIns="0" bIns="0"/>
+          <a:lstStyle/>
+          <a:p>
+            <a:pPr algn="ctr"/>
+            <a:r>
+              <a:rPr sz="850" b="0">
+                <a:solidFill>
+                  <a:srgbClr val="262626"/>
+                </a:solidFill>
+                <a:latin typeface="Calibri"/>
+              </a:rPr>
+              <a:t>C-1068</a:t>
+            </a:r>
+          </a:p>
+        </p:txBody>
+      </p:sp>
+      <p:sp>
+        <p:nvSpPr>
+          <p:cNvPr id="29" name="Rectangle 28"/>
+          <p:cNvSpPr/>
+          <p:nvPr/>
+        </p:nvSpPr>
+        <p:spPr>
+          <a:xfrm>
+            <a:off x="1261872" y="4718304"/>
+            <a:ext cx="896112" cy="256032"/>
+          </a:xfrm>
+          <a:prstGeom prst="rect">
+            <a:avLst/>
+          </a:prstGeom>
+          <a:solidFill>
+            <a:srgbClr val="DCE6F5"/>
+          </a:solidFill>
+          <a:ln w="9525">
+            <a:solidFill>
+              <a:srgbClr val="BFBFBF"/>
+            </a:solidFill>
+          </a:ln>
+          <a:effectLst/>
+        </p:spPr>
+        <p:style>
+          <a:lnRef idx="1">
+            <a:schemeClr val="accent1"/>
+          </a:lnRef>
+          <a:fillRef idx="3">
+            <a:schemeClr val="accent1"/>
+          </a:fillRef>
+          <a:effectRef idx="2">
+            <a:schemeClr val="accent1"/>
+          </a:effectRef>
+          <a:fontRef idx="minor">
+            <a:schemeClr val="lt1"/>
+          </a:fontRef>
+        </p:style>
+        <p:txBody>
+          <a:bodyPr rtlCol="0" anchor="ctr" wrap="square" lIns="27432" rIns="27432" tIns="0" bIns="0"/>
+          <a:lstStyle/>
+          <a:p>
+            <a:pPr algn="ctr"/>
+            <a:r>
+              <a:rPr sz="850" b="0">
+                <a:solidFill>
+                  <a:srgbClr val="262626"/>
+                </a:solidFill>
+                <a:latin typeface="Calibri"/>
+              </a:rPr>
+              <a:t>tech</a:t>
+            </a:r>
+          </a:p>
+        </p:txBody>
+      </p:sp>
+      <p:sp>
+        <p:nvSpPr>
+          <p:cNvPr id="30" name="Rectangle 29"/>
+          <p:cNvSpPr/>
+          <p:nvPr/>
+        </p:nvSpPr>
+        <p:spPr>
+          <a:xfrm>
+            <a:off x="2157984" y="4718304"/>
+            <a:ext cx="896112" cy="256032"/>
+          </a:xfrm>
+          <a:prstGeom prst="rect">
+            <a:avLst/>
+          </a:prstGeom>
+          <a:solidFill>
+            <a:srgbClr val="DCE6F5"/>
+          </a:solidFill>
+          <a:ln w="9525">
+            <a:solidFill>
+              <a:srgbClr val="BFBFBF"/>
+            </a:solidFill>
+          </a:ln>
+          <a:effectLst/>
+        </p:spPr>
+        <p:style>
+          <a:lnRef idx="1">
+            <a:schemeClr val="accent1"/>
+          </a:lnRef>
+          <a:fillRef idx="3">
+            <a:schemeClr val="accent1"/>
+          </a:fillRef>
+          <a:effectRef idx="2">
+            <a:schemeClr val="accent1"/>
+          </a:effectRef>
+          <a:fontRef idx="minor">
+            <a:schemeClr val="lt1"/>
+          </a:fontRef>
+        </p:style>
+        <p:txBody>
+          <a:bodyPr rtlCol="0" anchor="ctr" wrap="square" lIns="27432" rIns="27432" tIns="0" bIns="0"/>
+          <a:lstStyle/>
+          <a:p>
+            <a:pPr algn="ctr"/>
+            <a:r>
+              <a:rPr sz="850" b="0">
+                <a:solidFill>
+                  <a:srgbClr val="262626"/>
+                </a:solidFill>
+                <a:latin typeface="Calibri"/>
+              </a:rPr>
+              <a:t>29</a:t>
+            </a:r>
+          </a:p>
+        </p:txBody>
+      </p:sp>
+      <p:sp>
+        <p:nvSpPr>
+          <p:cNvPr id="31" name="Rectangle 30"/>
+          <p:cNvSpPr/>
+          <p:nvPr/>
+        </p:nvSpPr>
+        <p:spPr>
+          <a:xfrm>
+            <a:off x="3054096" y="4718304"/>
+            <a:ext cx="896112" cy="256032"/>
+          </a:xfrm>
+          <a:prstGeom prst="rect">
+            <a:avLst/>
+          </a:prstGeom>
+          <a:solidFill>
+            <a:srgbClr val="DCE6F5"/>
+          </a:solidFill>
+          <a:ln w="9525">
+            <a:solidFill>
+              <a:srgbClr val="BFBFBF"/>
+            </a:solidFill>
+          </a:ln>
+          <a:effectLst/>
+        </p:spPr>
+        <p:style>
+          <a:lnRef idx="1">
+            <a:schemeClr val="accent1"/>
+          </a:lnRef>
+          <a:fillRef idx="3">
+            <a:schemeClr val="accent1"/>
+          </a:fillRef>
+          <a:effectRef idx="2">
+            <a:schemeClr val="accent1"/>
+          </a:effectRef>
+          <a:fontRef idx="minor">
+            <a:schemeClr val="lt1"/>
+          </a:fontRef>
+        </p:style>
+        <p:txBody>
+          <a:bodyPr rtlCol="0" anchor="ctr" wrap="square" lIns="27432" rIns="27432" tIns="0" bIns="0"/>
+          <a:lstStyle/>
+          <a:p>
+            <a:pPr algn="ctr"/>
+            <a:r>
+              <a:rPr sz="850" b="0">
+                <a:solidFill>
+                  <a:srgbClr val="262626"/>
+                </a:solidFill>
+                <a:latin typeface="Calibri"/>
+              </a:rPr>
+              <a:t>876</a:t>
+            </a:r>
+          </a:p>
+        </p:txBody>
+      </p:sp>
+      <p:sp>
+        <p:nvSpPr>
+          <p:cNvPr id="32" name="Rectangle 31"/>
+          <p:cNvSpPr/>
+          <p:nvPr/>
+        </p:nvSpPr>
+        <p:spPr>
+          <a:xfrm>
+            <a:off x="3950208" y="4718304"/>
+            <a:ext cx="896112" cy="256032"/>
+          </a:xfrm>
+          <a:prstGeom prst="rect">
+            <a:avLst/>
+          </a:prstGeom>
+          <a:solidFill>
+            <a:srgbClr val="DCE6F5"/>
+          </a:solidFill>
+          <a:ln w="9525">
+            <a:solidFill>
+              <a:srgbClr val="BFBFBF"/>
+            </a:solidFill>
+          </a:ln>
+          <a:effectLst/>
+        </p:spPr>
+        <p:style>
+          <a:lnRef idx="1">
+            <a:schemeClr val="accent1"/>
+          </a:lnRef>
+          <a:fillRef idx="3">
+            <a:schemeClr val="accent1"/>
+          </a:fillRef>
+          <a:effectRef idx="2">
+            <a:schemeClr val="accent1"/>
+          </a:effectRef>
+          <a:fontRef idx="minor">
+            <a:schemeClr val="lt1"/>
+          </a:fontRef>
+        </p:style>
+        <p:txBody>
+          <a:bodyPr rtlCol="0" anchor="ctr" wrap="square" lIns="27432" rIns="27432" tIns="0" bIns="0"/>
+          <a:lstStyle/>
+          <a:p>
+            <a:pPr algn="ctr"/>
+            <a:r>
+              <a:rPr sz="850" b="0">
+                <a:solidFill>
+                  <a:srgbClr val="262626"/>
+                </a:solidFill>
+                <a:latin typeface="Calibri"/>
+              </a:rPr>
+              <a:t>no</a:t>
+            </a:r>
+          </a:p>
+        </p:txBody>
+      </p:sp>
+      <p:sp>
+        <p:nvSpPr>
+          <p:cNvPr id="33" name="Rectangle 32"/>
+          <p:cNvSpPr/>
+          <p:nvPr/>
+        </p:nvSpPr>
+        <p:spPr>
+          <a:xfrm>
+            <a:off x="365760" y="4974336"/>
+            <a:ext cx="896112" cy="256032"/>
+          </a:xfrm>
+          <a:prstGeom prst="rect">
+            <a:avLst/>
+          </a:prstGeom>
+          <a:solidFill>
+            <a:srgbClr val="FFFFFF"/>
+          </a:solidFill>
+          <a:ln w="9525">
+            <a:solidFill>
+              <a:srgbClr val="BFBFBF"/>
+            </a:solidFill>
+          </a:ln>
+          <a:effectLst/>
+        </p:spPr>
+        <p:style>
+          <a:lnRef idx="1">
+            <a:schemeClr val="accent1"/>
+          </a:lnRef>
+          <a:fillRef idx="3">
+            <a:schemeClr val="accent1"/>
+          </a:fillRef>
+          <a:effectRef idx="2">
+            <a:schemeClr val="accent1"/>
+          </a:effectRef>
+          <a:fontRef idx="minor">
+            <a:schemeClr val="lt1"/>
+          </a:fontRef>
+        </p:style>
+        <p:txBody>
+          <a:bodyPr rtlCol="0" anchor="ctr" wrap="square" lIns="27432" rIns="27432" tIns="0" bIns="0"/>
+          <a:lstStyle/>
+          <a:p>
+            <a:pPr algn="ctr"/>
+            <a:r>
+              <a:rPr sz="850" b="0">
+                <a:solidFill>
+                  <a:srgbClr val="262626"/>
+                </a:solidFill>
+                <a:latin typeface="Calibri"/>
+              </a:rPr>
+              <a:t>C-1073</a:t>
+            </a:r>
+          </a:p>
+        </p:txBody>
+      </p:sp>
+      <p:sp>
+        <p:nvSpPr>
+          <p:cNvPr id="34" name="Rectangle 33"/>
+          <p:cNvSpPr/>
+          <p:nvPr/>
+        </p:nvSpPr>
+        <p:spPr>
+          <a:xfrm>
+            <a:off x="1261872" y="4974336"/>
+            <a:ext cx="896112" cy="256032"/>
+          </a:xfrm>
+          <a:prstGeom prst="rect">
+            <a:avLst/>
+          </a:prstGeom>
+          <a:solidFill>
+            <a:srgbClr val="FFFFFF"/>
+          </a:solidFill>
+          <a:ln w="9525">
+            <a:solidFill>
+              <a:srgbClr val="BFBFBF"/>
+            </a:solidFill>
+          </a:ln>
+          <a:effectLst/>
+        </p:spPr>
+        <p:style>
+          <a:lnRef idx="1">
+            <a:schemeClr val="accent1"/>
+          </a:lnRef>
+          <a:fillRef idx="3">
+            <a:schemeClr val="accent1"/>
+          </a:fillRef>
+          <a:effectRef idx="2">
+            <a:schemeClr val="accent1"/>
+          </a:effectRef>
+          <a:fontRef idx="minor">
+            <a:schemeClr val="lt1"/>
+          </a:fontRef>
+        </p:style>
+        <p:txBody>
+          <a:bodyPr rtlCol="0" anchor="ctr" wrap="square" lIns="27432" rIns="27432" tIns="0" bIns="0"/>
+          <a:lstStyle/>
+          <a:p>
+            <a:pPr algn="ctr"/>
+            <a:r>
+              <a:rPr sz="850" b="0">
+                <a:solidFill>
+                  <a:srgbClr val="262626"/>
+                </a:solidFill>
+                <a:latin typeface="Calibri"/>
+              </a:rPr>
+              <a:t>admin</a:t>
+            </a:r>
+          </a:p>
+        </p:txBody>
+      </p:sp>
+      <p:sp>
+        <p:nvSpPr>
+          <p:cNvPr id="35" name="Rectangle 34"/>
+          <p:cNvSpPr/>
+          <p:nvPr/>
+        </p:nvSpPr>
+        <p:spPr>
+          <a:xfrm>
+            <a:off x="2157984" y="4974336"/>
+            <a:ext cx="896112" cy="256032"/>
+          </a:xfrm>
+          <a:prstGeom prst="rect">
+            <a:avLst/>
+          </a:prstGeom>
+          <a:solidFill>
+            <a:srgbClr val="FCE6D5"/>
+          </a:solidFill>
+          <a:ln w="9525">
+            <a:solidFill>
+              <a:srgbClr val="BFBFBF"/>
+            </a:solidFill>
+          </a:ln>
+          <a:effectLst/>
+        </p:spPr>
+        <p:style>
+          <a:lnRef idx="1">
+            <a:schemeClr val="accent1"/>
+          </a:lnRef>
+          <a:fillRef idx="3">
+            <a:schemeClr val="accent1"/>
+          </a:fillRef>
+          <a:effectRef idx="2">
+            <a:schemeClr val="accent1"/>
+          </a:effectRef>
+          <a:fontRef idx="minor">
+            <a:schemeClr val="lt1"/>
+          </a:fontRef>
+        </p:style>
+        <p:txBody>
+          <a:bodyPr rtlCol="0" anchor="ctr" wrap="square" lIns="27432" rIns="27432" tIns="0" bIns="0"/>
+          <a:lstStyle/>
+          <a:p>
+            <a:pPr algn="ctr"/>
+            <a:r>
+              <a:rPr sz="850" b="0">
+                <a:solidFill>
+                  <a:srgbClr val="262626"/>
+                </a:solidFill>
+                <a:latin typeface="Calibri"/>
+              </a:rPr>
+              <a:t>47</a:t>
+            </a:r>
+          </a:p>
+        </p:txBody>
+      </p:sp>
+      <p:sp>
+        <p:nvSpPr>
+          <p:cNvPr id="36" name="Rectangle 35"/>
+          <p:cNvSpPr/>
+          <p:nvPr/>
+        </p:nvSpPr>
+        <p:spPr>
+          <a:xfrm>
+            <a:off x="3054096" y="4974336"/>
+            <a:ext cx="896112" cy="256032"/>
+          </a:xfrm>
+          <a:prstGeom prst="rect">
+            <a:avLst/>
+          </a:prstGeom>
+          <a:solidFill>
+            <a:srgbClr val="FFFFFF"/>
+          </a:solidFill>
+          <a:ln w="9525">
+            <a:solidFill>
+              <a:srgbClr val="BFBFBF"/>
+            </a:solidFill>
+          </a:ln>
+          <a:effectLst/>
+        </p:spPr>
+        <p:style>
+          <a:lnRef idx="1">
+            <a:schemeClr val="accent1"/>
+          </a:lnRef>
+          <a:fillRef idx="3">
+            <a:schemeClr val="accent1"/>
+          </a:fillRef>
+          <a:effectRef idx="2">
+            <a:schemeClr val="accent1"/>
+          </a:effectRef>
+          <a:fontRef idx="minor">
+            <a:schemeClr val="lt1"/>
+          </a:fontRef>
+        </p:style>
+        <p:txBody>
+          <a:bodyPr rtlCol="0" anchor="ctr" wrap="square" lIns="27432" rIns="27432" tIns="0" bIns="0"/>
+          <a:lstStyle/>
+          <a:p>
+            <a:pPr algn="ctr"/>
+            <a:r>
+              <a:rPr sz="850" b="0">
+                <a:solidFill>
+                  <a:srgbClr val="262626"/>
+                </a:solidFill>
+                <a:latin typeface="Calibri"/>
+              </a:rPr>
+              <a:t>1,584</a:t>
+            </a:r>
+          </a:p>
+        </p:txBody>
+      </p:sp>
+      <p:sp>
+        <p:nvSpPr>
+          <p:cNvPr id="37" name="Rectangle 36"/>
+          <p:cNvSpPr/>
+          <p:nvPr/>
+        </p:nvSpPr>
+        <p:spPr>
+          <a:xfrm>
+            <a:off x="3950208" y="4974336"/>
+            <a:ext cx="896112" cy="256032"/>
+          </a:xfrm>
+          <a:prstGeom prst="rect">
+            <a:avLst/>
+          </a:prstGeom>
+          <a:solidFill>
+            <a:srgbClr val="FFFFFF"/>
+          </a:solidFill>
+          <a:ln w="9525">
+            <a:solidFill>
+              <a:srgbClr val="BFBFBF"/>
+            </a:solidFill>
+          </a:ln>
+          <a:effectLst/>
+        </p:spPr>
+        <p:style>
+          <a:lnRef idx="1">
+            <a:schemeClr val="accent1"/>
+          </a:lnRef>
+          <a:fillRef idx="3">
+            <a:schemeClr val="accent1"/>
+          </a:fillRef>
+          <a:effectRef idx="2">
+            <a:schemeClr val="accent1"/>
+          </a:effectRef>
+          <a:fontRef idx="minor">
+            <a:schemeClr val="lt1"/>
+          </a:fontRef>
+        </p:style>
+        <p:txBody>
+          <a:bodyPr rtlCol="0" anchor="ctr" wrap="square" lIns="27432" rIns="27432" tIns="0" bIns="0"/>
+          <a:lstStyle/>
+          <a:p>
+            <a:pPr algn="ctr"/>
+            <a:r>
+              <a:rPr sz="850" b="0">
+                <a:solidFill>
+                  <a:srgbClr val="262626"/>
+                </a:solidFill>
+                <a:latin typeface="Calibri"/>
+              </a:rPr>
+              <a:t>no</a:t>
+            </a:r>
+          </a:p>
+        </p:txBody>
+      </p:sp>
+      <p:sp>
+        <p:nvSpPr>
+          <p:cNvPr id="38" name="TextBox 37"/>
+          <p:cNvSpPr txBox="1"/>
+          <p:nvPr/>
+        </p:nvSpPr>
+        <p:spPr>
+          <a:xfrm>
+            <a:off x="365760" y="5321808"/>
+            <a:ext cx="4663440" cy="237744"/>
+          </a:xfrm>
+          <a:prstGeom prst="rect">
+            <a:avLst/>
+          </a:prstGeom>
+          <a:noFill/>
+        </p:spPr>
+        <p:txBody>
+          <a:bodyPr wrap="square" lIns="0" rIns="0" tIns="0" bIns="0" anchor="t">
+            <a:spAutoFit/>
+          </a:bodyPr>
+          <a:lstStyle/>
+          <a:p>
+            <a:pPr algn="l">
+              <a:spcAft>
+                <a:spcPts val="0"/>
+              </a:spcAft>
+            </a:pPr>
+            <a:r>
+              <a:rPr sz="1150" b="1">
+                <a:solidFill>
+                  <a:srgbClr val="1F3864"/>
+                </a:solidFill>
+                <a:latin typeface="Calibri"/>
+              </a:rPr>
+              <a:t>Each row is one observation — one client</a:t>
+            </a:r>
+          </a:p>
+        </p:txBody>
+      </p:sp>
+      <p:sp>
+        <p:nvSpPr>
+          <p:cNvPr id="39" name="TextBox 38"/>
+          <p:cNvSpPr txBox="1"/>
+          <p:nvPr/>
+        </p:nvSpPr>
+        <p:spPr>
+          <a:xfrm>
+            <a:off x="365760" y="5989320"/>
+            <a:ext cx="11475720" cy="640080"/>
+          </a:xfrm>
+          <a:prstGeom prst="rect">
+            <a:avLst/>
+          </a:prstGeom>
+          <a:noFill/>
+        </p:spPr>
+        <p:txBody>
+          <a:bodyPr wrap="square" lIns="0" rIns="0" tIns="0" bIns="0" anchor="t">
+            <a:spAutoFit/>
+          </a:bodyPr>
+          <a:lstStyle/>
+          <a:p>
+            <a:pPr algn="l">
+              <a:spcAft>
+                <a:spcPts val="0"/>
+              </a:spcAft>
+            </a:pPr>
+            <a:r>
+              <a:rPr sz="1100" b="0">
+                <a:solidFill>
+                  <a:srgbClr val="595959"/>
+                </a:solidFill>
+                <a:latin typeface="Calibri"/>
+              </a:rPr>
+              <a:t>Source: Variable structure adapted from Moro, S., Rita, P., and Cortez, P. (2014). Bank Marketing [Dataset]. UCI Machine Learning Repository. https://doi.org/10.24432/C5K306. The 20 client records shown here are simulated for illustration; the real data set contains 45,211 clients.</a:t>
+            </a:r>
+          </a:p>
+        </p:txBody>
+      </p:sp>
     </p:spTree>
     <p:extLst>
       <p:ext uri="{BB962C8B-B14F-4D97-AF65-F5344CB8AC3E}">

</xml_diff>

<commit_message>
Update lecture slides and menu PDFs
Refreshes the Week 1 Lecture 1 PowerPoint deck and updates the generated lecture menu PDFs (lecturemenu13–16). The changeset also includes a new temporary PowerPoint lock file (`~$Week1_Lecture1_Slides_1_10_2024.pptx`) created by Office during editing.
</commit_message>
<xml_diff>
--- a/docs/lecture_slides/Week 1/Week1_Lecture1_Slides_1_10_2024.pptx
+++ b/docs/lecture_slides/Week 1/Week1_Lecture1_Slides_1_10_2024.pptx
@@ -6,9 +6,9 @@
   </p:sldMasterIdLst>
   <p:sldIdLst>
     <p:sldId id="258" r:id="rId2"/>
-    <p:sldId id="286" r:id="rId3"/>
-    <p:sldId id="285" r:id="rId4"/>
-    <p:sldId id="257" r:id="rId5"/>
+    <p:sldId id="285" r:id="rId3"/>
+    <p:sldId id="257" r:id="rId4"/>
+    <p:sldId id="286" r:id="rId5"/>
     <p:sldId id="293" r:id="rId6"/>
     <p:sldId id="259" r:id="rId7"/>
     <p:sldId id="261" r:id="rId8"/>
@@ -127,7 +127,7 @@
 </file>
 
 <file path=ppt/diagrams/colors1.xml><?xml version="1.0" encoding="utf-8"?>
-<dgm:colorsDef xmlns:dgm="http://schemas.openxmlformats.org/drawingml/2006/diagram" xmlns:a="http://schemas.openxmlformats.org/drawingml/2006/main" uniqueId="urn:microsoft.com/office/officeart/2005/8/colors/accent1_2">
+<dgm:colorsDef xmlns:dgm="http://schemas.openxmlformats.org/drawingml/2006/diagram" xmlns:a="http://schemas.openxmlformats.org/drawingml/2006/main" uniqueId="urn:microsoft.com/office/officeart/2005/8/colors/accent1_2#1">
   <dgm:title val=""/>
   <dgm:desc val=""/>
   <dgm:catLst>
@@ -877,7 +877,7 @@
 <dgm:dataModel xmlns:dgm="http://schemas.openxmlformats.org/drawingml/2006/diagram" xmlns:a="http://schemas.openxmlformats.org/drawingml/2006/main">
   <dgm:ptLst>
     <dgm:pt modelId="{28C7EA2F-9E63-4866-8ADB-4C7590AC9890}" type="doc">
-      <dgm:prSet loTypeId="urn:microsoft.com/office/officeart/2018/2/layout/IconVerticalSolidList" loCatId="icon" qsTypeId="urn:microsoft.com/office/officeart/2005/8/quickstyle/simple1" qsCatId="simple" csTypeId="urn:microsoft.com/office/officeart/2005/8/colors/accent1_2" csCatId="accent1" phldr="1"/>
+      <dgm:prSet loTypeId="urn:microsoft.com/office/officeart/2018/2/layout/IconVerticalSolidList" loCatId="icon" qsTypeId="urn:microsoft.com/office/officeart/2005/8/quickstyle/simple1#1" qsCatId="simple" csTypeId="urn:microsoft.com/office/officeart/2005/8/colors/accent1_2#1" csCatId="accent1" phldr="1"/>
       <dgm:spPr/>
       <dgm:t>
         <a:bodyPr/>
@@ -2010,7 +2010,7 @@
 </file>
 
 <file path=ppt/diagrams/quickStyle1.xml><?xml version="1.0" encoding="utf-8"?>
-<dgm:styleDef xmlns:dgm="http://schemas.openxmlformats.org/drawingml/2006/diagram" xmlns:a="http://schemas.openxmlformats.org/drawingml/2006/main" uniqueId="urn:microsoft.com/office/officeart/2005/8/quickstyle/simple1">
+<dgm:styleDef xmlns:dgm="http://schemas.openxmlformats.org/drawingml/2006/diagram" xmlns:a="http://schemas.openxmlformats.org/drawingml/2006/main" uniqueId="urn:microsoft.com/office/officeart/2005/8/quickstyle/simple1#1">
   <dgm:title val=""/>
   <dgm:desc val=""/>
   <dgm:catLst>
@@ -3190,7 +3190,7 @@
           <a:p>
             <a:fld id="{D808A37A-4640-4712-9D8F-F69B6FC23B38}" type="datetimeFigureOut">
               <a:rPr lang="en-US" smtClean="0"/>
-              <a:t>8/18/2026</a:t>
+              <a:t>8/26/2026</a:t>
             </a:fld>
             <a:endParaRPr lang="en-US"/>
           </a:p>
@@ -3388,7 +3388,7 @@
           <a:p>
             <a:fld id="{D808A37A-4640-4712-9D8F-F69B6FC23B38}" type="datetimeFigureOut">
               <a:rPr lang="en-US" smtClean="0"/>
-              <a:t>8/18/2026</a:t>
+              <a:t>8/26/2026</a:t>
             </a:fld>
             <a:endParaRPr lang="en-US"/>
           </a:p>
@@ -3596,7 +3596,7 @@
           <a:p>
             <a:fld id="{D808A37A-4640-4712-9D8F-F69B6FC23B38}" type="datetimeFigureOut">
               <a:rPr lang="en-US" smtClean="0"/>
-              <a:t>8/18/2026</a:t>
+              <a:t>8/26/2026</a:t>
             </a:fld>
             <a:endParaRPr lang="en-US"/>
           </a:p>
@@ -3794,7 +3794,7 @@
           <a:p>
             <a:fld id="{D808A37A-4640-4712-9D8F-F69B6FC23B38}" type="datetimeFigureOut">
               <a:rPr lang="en-US" smtClean="0"/>
-              <a:t>8/18/2026</a:t>
+              <a:t>8/26/2026</a:t>
             </a:fld>
             <a:endParaRPr lang="en-US"/>
           </a:p>
@@ -4069,7 +4069,7 @@
           <a:p>
             <a:fld id="{D808A37A-4640-4712-9D8F-F69B6FC23B38}" type="datetimeFigureOut">
               <a:rPr lang="en-US" smtClean="0"/>
-              <a:t>8/18/2026</a:t>
+              <a:t>8/26/2026</a:t>
             </a:fld>
             <a:endParaRPr lang="en-US"/>
           </a:p>
@@ -4334,7 +4334,7 @@
           <a:p>
             <a:fld id="{D808A37A-4640-4712-9D8F-F69B6FC23B38}" type="datetimeFigureOut">
               <a:rPr lang="en-US" smtClean="0"/>
-              <a:t>8/18/2026</a:t>
+              <a:t>8/26/2026</a:t>
             </a:fld>
             <a:endParaRPr lang="en-US"/>
           </a:p>
@@ -4746,7 +4746,7 @@
           <a:p>
             <a:fld id="{D808A37A-4640-4712-9D8F-F69B6FC23B38}" type="datetimeFigureOut">
               <a:rPr lang="en-US" smtClean="0"/>
-              <a:t>8/18/2026</a:t>
+              <a:t>8/26/2026</a:t>
             </a:fld>
             <a:endParaRPr lang="en-US"/>
           </a:p>
@@ -4887,7 +4887,7 @@
           <a:p>
             <a:fld id="{D808A37A-4640-4712-9D8F-F69B6FC23B38}" type="datetimeFigureOut">
               <a:rPr lang="en-US" smtClean="0"/>
-              <a:t>8/18/2026</a:t>
+              <a:t>8/26/2026</a:t>
             </a:fld>
             <a:endParaRPr lang="en-US"/>
           </a:p>
@@ -5000,7 +5000,7 @@
           <a:p>
             <a:fld id="{D808A37A-4640-4712-9D8F-F69B6FC23B38}" type="datetimeFigureOut">
               <a:rPr lang="en-US" smtClean="0"/>
-              <a:t>8/18/2026</a:t>
+              <a:t>8/26/2026</a:t>
             </a:fld>
             <a:endParaRPr lang="en-US"/>
           </a:p>
@@ -5311,7 +5311,7 @@
           <a:p>
             <a:fld id="{D808A37A-4640-4712-9D8F-F69B6FC23B38}" type="datetimeFigureOut">
               <a:rPr lang="en-US" smtClean="0"/>
-              <a:t>8/18/2026</a:t>
+              <a:t>8/26/2026</a:t>
             </a:fld>
             <a:endParaRPr lang="en-US"/>
           </a:p>
@@ -5599,7 +5599,7 @@
           <a:p>
             <a:fld id="{D808A37A-4640-4712-9D8F-F69B6FC23B38}" type="datetimeFigureOut">
               <a:rPr lang="en-US" smtClean="0"/>
-              <a:t>8/18/2026</a:t>
+              <a:t>8/26/2026</a:t>
             </a:fld>
             <a:endParaRPr lang="en-US"/>
           </a:p>
@@ -5840,7 +5840,7 @@
           <a:p>
             <a:fld id="{D808A37A-4640-4712-9D8F-F69B6FC23B38}" type="datetimeFigureOut">
               <a:rPr lang="en-US" smtClean="0"/>
-              <a:t>8/18/2026</a:t>
+              <a:t>8/26/2026</a:t>
             </a:fld>
             <a:endParaRPr lang="en-US"/>
           </a:p>
@@ -9336,1474 +9336,6 @@
       </p:grpSpPr>
       <p:sp>
         <p:nvSpPr>
-          <p:cNvPr id="2" name="Title 1"/>
-          <p:cNvSpPr>
-            <a:spLocks noGrp="1"/>
-          </p:cNvSpPr>
-          <p:nvPr>
-            <p:ph type="title"/>
-          </p:nvPr>
-        </p:nvSpPr>
-        <p:spPr>
-          <a:xfrm>
-            <a:off x="457200" y="182880"/>
-            <a:ext cx="11338560" cy="914400"/>
-          </a:xfrm>
-        </p:spPr>
-        <p:txBody>
-          <a:bodyPr/>
-          <a:lstStyle/>
-          <a:p>
-            <a:r>
-              <a:rPr sz="4000">
-                <a:solidFill>
-                  <a:srgbClr val="000000"/>
-                </a:solidFill>
-                <a:latin typeface="Calibri Light"/>
-              </a:rPr>
-              <a:t>Where does statistics come from?</a:t>
-            </a:r>
-          </a:p>
-        </p:txBody>
-      </p:sp>
-      <p:sp>
-        <p:nvSpPr>
-          <p:cNvPr id="3" name="TextBox 2"/>
-          <p:cNvSpPr txBox="1"/>
-          <p:nvPr/>
-        </p:nvSpPr>
-        <p:spPr>
-          <a:xfrm>
-            <a:off x="457200" y="1170432"/>
-            <a:ext cx="11292840" cy="411480"/>
-          </a:xfrm>
-          <a:prstGeom prst="rect">
-            <a:avLst/>
-          </a:prstGeom>
-          <a:noFill/>
-        </p:spPr>
-        <p:txBody>
-          <a:bodyPr wrap="square" lIns="0" tIns="0" rIns="0" bIns="0" anchor="t">
-            <a:spAutoFit/>
-          </a:bodyPr>
-          <a:lstStyle/>
-          <a:p>
-            <a:pPr algn="l">
-              <a:spcAft>
-                <a:spcPts val="0"/>
-              </a:spcAft>
-            </a:pPr>
-            <a:r>
-              <a:rPr sz="1600" b="0">
-                <a:solidFill>
-                  <a:srgbClr val="333333"/>
-                </a:solidFill>
-                <a:latin typeface="Calibri"/>
-              </a:rPr>
-              <a:t>Statistics began as bookkeeping about people — counting births, deaths, and taxpayers so that a state could describe itself.</a:t>
-            </a:r>
-          </a:p>
-        </p:txBody>
-      </p:sp>
-      <p:sp>
-        <p:nvSpPr>
-          <p:cNvPr id="4" name="Rectangle 3"/>
-          <p:cNvSpPr/>
-          <p:nvPr/>
-        </p:nvSpPr>
-        <p:spPr>
-          <a:xfrm>
-            <a:off x="457200" y="3893515"/>
-            <a:ext cx="11277295" cy="40233"/>
-          </a:xfrm>
-          <a:prstGeom prst="rect">
-            <a:avLst/>
-          </a:prstGeom>
-          <a:solidFill>
-            <a:srgbClr val="4472C4"/>
-          </a:solidFill>
-          <a:ln>
-            <a:noFill/>
-          </a:ln>
-          <a:effectLst/>
-        </p:spPr>
-        <p:style>
-          <a:lnRef idx="1">
-            <a:schemeClr val="accent1"/>
-          </a:lnRef>
-          <a:fillRef idx="3">
-            <a:schemeClr val="accent1"/>
-          </a:fillRef>
-          <a:effectRef idx="2">
-            <a:schemeClr val="accent1"/>
-          </a:effectRef>
-          <a:fontRef idx="minor">
-            <a:schemeClr val="lt1"/>
-          </a:fontRef>
-        </p:style>
-        <p:txBody>
-          <a:bodyPr wrap="square" rtlCol="0" anchor="ctr"/>
-          <a:lstStyle/>
-          <a:p>
-            <a:pPr algn="ctr"/>
-            <a:endParaRPr/>
-          </a:p>
-        </p:txBody>
-      </p:sp>
-      <p:sp>
-        <p:nvSpPr>
-          <p:cNvPr id="5" name="Rectangle 4"/>
-          <p:cNvSpPr/>
-          <p:nvPr/>
-        </p:nvSpPr>
-        <p:spPr>
-          <a:xfrm>
-            <a:off x="1590141" y="3529584"/>
-            <a:ext cx="20116" cy="384048"/>
-          </a:xfrm>
-          <a:prstGeom prst="rect">
-            <a:avLst/>
-          </a:prstGeom>
-          <a:solidFill>
-            <a:srgbClr val="4472C4"/>
-          </a:solidFill>
-          <a:ln>
-            <a:noFill/>
-          </a:ln>
-          <a:effectLst/>
-        </p:spPr>
-        <p:style>
-          <a:lnRef idx="1">
-            <a:schemeClr val="accent1"/>
-          </a:lnRef>
-          <a:fillRef idx="3">
-            <a:schemeClr val="accent1"/>
-          </a:fillRef>
-          <a:effectRef idx="2">
-            <a:schemeClr val="accent1"/>
-          </a:effectRef>
-          <a:fontRef idx="minor">
-            <a:schemeClr val="lt1"/>
-          </a:fontRef>
-        </p:style>
-        <p:txBody>
-          <a:bodyPr wrap="square" rtlCol="0" anchor="ctr"/>
-          <a:lstStyle/>
-          <a:p>
-            <a:pPr algn="ctr"/>
-            <a:endParaRPr/>
-          </a:p>
-        </p:txBody>
-      </p:sp>
-      <p:sp>
-        <p:nvSpPr>
-          <p:cNvPr id="6" name="Oval 5"/>
-          <p:cNvSpPr/>
-          <p:nvPr/>
-        </p:nvSpPr>
-        <p:spPr>
-          <a:xfrm>
-            <a:off x="1522476" y="3835908"/>
-            <a:ext cx="155448" cy="155448"/>
-          </a:xfrm>
-          <a:prstGeom prst="ellipse">
-            <a:avLst/>
-          </a:prstGeom>
-          <a:solidFill>
-            <a:srgbClr val="FFFFFF"/>
-          </a:solidFill>
-          <a:ln w="25400">
-            <a:solidFill>
-              <a:srgbClr val="4472C4"/>
-            </a:solidFill>
-          </a:ln>
-          <a:effectLst/>
-        </p:spPr>
-        <p:style>
-          <a:lnRef idx="1">
-            <a:schemeClr val="accent1"/>
-          </a:lnRef>
-          <a:fillRef idx="3">
-            <a:schemeClr val="accent1"/>
-          </a:fillRef>
-          <a:effectRef idx="2">
-            <a:schemeClr val="accent1"/>
-          </a:effectRef>
-          <a:fontRef idx="minor">
-            <a:schemeClr val="lt1"/>
-          </a:fontRef>
-        </p:style>
-        <p:txBody>
-          <a:bodyPr wrap="square" rtlCol="0" anchor="ctr"/>
-          <a:lstStyle/>
-          <a:p>
-            <a:pPr algn="ctr"/>
-            <a:endParaRPr/>
-          </a:p>
-        </p:txBody>
-      </p:sp>
-      <p:sp>
-        <p:nvSpPr>
-          <p:cNvPr id="7" name="Rectangle 6"/>
-          <p:cNvSpPr/>
-          <p:nvPr/>
-        </p:nvSpPr>
-        <p:spPr>
-          <a:xfrm>
-            <a:off x="457200" y="2231136"/>
-            <a:ext cx="2286000" cy="1298448"/>
-          </a:xfrm>
-          <a:prstGeom prst="rect">
-            <a:avLst/>
-          </a:prstGeom>
-          <a:solidFill>
-            <a:srgbClr val="EDF2FA"/>
-          </a:solidFill>
-          <a:ln>
-            <a:noFill/>
-          </a:ln>
-          <a:effectLst/>
-        </p:spPr>
-        <p:style>
-          <a:lnRef idx="1">
-            <a:schemeClr val="accent1"/>
-          </a:lnRef>
-          <a:fillRef idx="3">
-            <a:schemeClr val="accent1"/>
-          </a:fillRef>
-          <a:effectRef idx="2">
-            <a:schemeClr val="accent1"/>
-          </a:effectRef>
-          <a:fontRef idx="minor">
-            <a:schemeClr val="lt1"/>
-          </a:fontRef>
-        </p:style>
-        <p:txBody>
-          <a:bodyPr wrap="square" lIns="100584" tIns="73152" rIns="100584" bIns="73152" rtlCol="0" anchor="t"/>
-          <a:lstStyle/>
-          <a:p>
-            <a:pPr algn="l">
-              <a:spcAft>
-                <a:spcPts val="300"/>
-              </a:spcAft>
-            </a:pPr>
-            <a:r>
-              <a:rPr sz="1700" b="1">
-                <a:solidFill>
-                  <a:srgbClr val="4472C4"/>
-                </a:solidFill>
-                <a:latin typeface="Calibri"/>
-              </a:rPr>
-              <a:t>1662</a:t>
-            </a:r>
-          </a:p>
-          <a:p>
-            <a:pPr algn="l"/>
-            <a:r>
-              <a:rPr sz="1050">
-                <a:solidFill>
-                  <a:srgbClr val="262626"/>
-                </a:solidFill>
-                <a:latin typeface="Calibri"/>
-              </a:rPr>
-              <a:t>John Graunt studies London's Bills of Mortality — the first life table built from real data.</a:t>
-            </a:r>
-          </a:p>
-        </p:txBody>
-      </p:sp>
-      <p:sp>
-        <p:nvSpPr>
-          <p:cNvPr id="8" name="Rectangle 7"/>
-          <p:cNvSpPr/>
-          <p:nvPr/>
-        </p:nvSpPr>
-        <p:spPr>
-          <a:xfrm>
-            <a:off x="2874612" y="3913632"/>
-            <a:ext cx="20116" cy="384048"/>
-          </a:xfrm>
-          <a:prstGeom prst="rect">
-            <a:avLst/>
-          </a:prstGeom>
-          <a:solidFill>
-            <a:srgbClr val="4472C4"/>
-          </a:solidFill>
-          <a:ln>
-            <a:noFill/>
-          </a:ln>
-          <a:effectLst/>
-        </p:spPr>
-        <p:style>
-          <a:lnRef idx="1">
-            <a:schemeClr val="accent1"/>
-          </a:lnRef>
-          <a:fillRef idx="3">
-            <a:schemeClr val="accent1"/>
-          </a:fillRef>
-          <a:effectRef idx="2">
-            <a:schemeClr val="accent1"/>
-          </a:effectRef>
-          <a:fontRef idx="minor">
-            <a:schemeClr val="lt1"/>
-          </a:fontRef>
-        </p:style>
-        <p:txBody>
-          <a:bodyPr wrap="square" rtlCol="0" anchor="ctr"/>
-          <a:lstStyle/>
-          <a:p>
-            <a:pPr algn="ctr"/>
-            <a:endParaRPr/>
-          </a:p>
-        </p:txBody>
-      </p:sp>
-      <p:sp>
-        <p:nvSpPr>
-          <p:cNvPr id="9" name="Oval 8"/>
-          <p:cNvSpPr/>
-          <p:nvPr/>
-        </p:nvSpPr>
-        <p:spPr>
-          <a:xfrm>
-            <a:off x="2806946" y="3835908"/>
-            <a:ext cx="155448" cy="155448"/>
-          </a:xfrm>
-          <a:prstGeom prst="ellipse">
-            <a:avLst/>
-          </a:prstGeom>
-          <a:solidFill>
-            <a:srgbClr val="FFFFFF"/>
-          </a:solidFill>
-          <a:ln w="25400">
-            <a:solidFill>
-              <a:srgbClr val="4472C4"/>
-            </a:solidFill>
-          </a:ln>
-          <a:effectLst/>
-        </p:spPr>
-        <p:style>
-          <a:lnRef idx="1">
-            <a:schemeClr val="accent1"/>
-          </a:lnRef>
-          <a:fillRef idx="3">
-            <a:schemeClr val="accent1"/>
-          </a:fillRef>
-          <a:effectRef idx="2">
-            <a:schemeClr val="accent1"/>
-          </a:effectRef>
-          <a:fontRef idx="minor">
-            <a:schemeClr val="lt1"/>
-          </a:fontRef>
-        </p:style>
-        <p:txBody>
-          <a:bodyPr wrap="square" rtlCol="0" anchor="ctr"/>
-          <a:lstStyle/>
-          <a:p>
-            <a:pPr algn="ctr"/>
-            <a:endParaRPr/>
-          </a:p>
-        </p:txBody>
-      </p:sp>
-      <p:sp>
-        <p:nvSpPr>
-          <p:cNvPr id="10" name="Rectangle 9"/>
-          <p:cNvSpPr/>
-          <p:nvPr/>
-        </p:nvSpPr>
-        <p:spPr>
-          <a:xfrm>
-            <a:off x="1741670" y="4297680"/>
-            <a:ext cx="2286000" cy="1298448"/>
-          </a:xfrm>
-          <a:prstGeom prst="rect">
-            <a:avLst/>
-          </a:prstGeom>
-          <a:solidFill>
-            <a:srgbClr val="EDF2FA"/>
-          </a:solidFill>
-          <a:ln>
-            <a:noFill/>
-          </a:ln>
-          <a:effectLst/>
-        </p:spPr>
-        <p:style>
-          <a:lnRef idx="1">
-            <a:schemeClr val="accent1"/>
-          </a:lnRef>
-          <a:fillRef idx="3">
-            <a:schemeClr val="accent1"/>
-          </a:fillRef>
-          <a:effectRef idx="2">
-            <a:schemeClr val="accent1"/>
-          </a:effectRef>
-          <a:fontRef idx="minor">
-            <a:schemeClr val="lt1"/>
-          </a:fontRef>
-        </p:style>
-        <p:txBody>
-          <a:bodyPr wrap="square" lIns="100584" tIns="73152" rIns="100584" bIns="73152" rtlCol="0" anchor="t"/>
-          <a:lstStyle/>
-          <a:p>
-            <a:pPr algn="l">
-              <a:spcAft>
-                <a:spcPts val="300"/>
-              </a:spcAft>
-            </a:pPr>
-            <a:r>
-              <a:rPr sz="1700" b="1">
-                <a:solidFill>
-                  <a:srgbClr val="4472C4"/>
-                </a:solidFill>
-                <a:latin typeface="Calibri"/>
-              </a:rPr>
-              <a:t>1693</a:t>
-            </a:r>
-          </a:p>
-          <a:p>
-            <a:pPr algn="l"/>
-            <a:r>
-              <a:rPr sz="1050">
-                <a:solidFill>
-                  <a:srgbClr val="262626"/>
-                </a:solidFill>
-                <a:latin typeface="Calibri"/>
-              </a:rPr>
-              <a:t>Edmond Halley's Breslau life table makes it possible to price life annuities.</a:t>
-            </a:r>
-          </a:p>
-        </p:txBody>
-      </p:sp>
-      <p:sp>
-        <p:nvSpPr>
-          <p:cNvPr id="11" name="Rectangle 10"/>
-          <p:cNvSpPr/>
-          <p:nvPr/>
-        </p:nvSpPr>
-        <p:spPr>
-          <a:xfrm>
-            <a:off x="4159083" y="3529584"/>
-            <a:ext cx="20116" cy="384048"/>
-          </a:xfrm>
-          <a:prstGeom prst="rect">
-            <a:avLst/>
-          </a:prstGeom>
-          <a:solidFill>
-            <a:srgbClr val="4472C4"/>
-          </a:solidFill>
-          <a:ln>
-            <a:noFill/>
-          </a:ln>
-          <a:effectLst/>
-        </p:spPr>
-        <p:style>
-          <a:lnRef idx="1">
-            <a:schemeClr val="accent1"/>
-          </a:lnRef>
-          <a:fillRef idx="3">
-            <a:schemeClr val="accent1"/>
-          </a:fillRef>
-          <a:effectRef idx="2">
-            <a:schemeClr val="accent1"/>
-          </a:effectRef>
-          <a:fontRef idx="minor">
-            <a:schemeClr val="lt1"/>
-          </a:fontRef>
-        </p:style>
-        <p:txBody>
-          <a:bodyPr wrap="square" rtlCol="0" anchor="ctr"/>
-          <a:lstStyle/>
-          <a:p>
-            <a:pPr algn="ctr"/>
-            <a:endParaRPr/>
-          </a:p>
-        </p:txBody>
-      </p:sp>
-      <p:sp>
-        <p:nvSpPr>
-          <p:cNvPr id="12" name="Oval 11"/>
-          <p:cNvSpPr/>
-          <p:nvPr/>
-        </p:nvSpPr>
-        <p:spPr>
-          <a:xfrm>
-            <a:off x="4091417" y="3835908"/>
-            <a:ext cx="155448" cy="155448"/>
-          </a:xfrm>
-          <a:prstGeom prst="ellipse">
-            <a:avLst/>
-          </a:prstGeom>
-          <a:solidFill>
-            <a:srgbClr val="FFFFFF"/>
-          </a:solidFill>
-          <a:ln w="25400">
-            <a:solidFill>
-              <a:srgbClr val="4472C4"/>
-            </a:solidFill>
-          </a:ln>
-          <a:effectLst/>
-        </p:spPr>
-        <p:style>
-          <a:lnRef idx="1">
-            <a:schemeClr val="accent1"/>
-          </a:lnRef>
-          <a:fillRef idx="3">
-            <a:schemeClr val="accent1"/>
-          </a:fillRef>
-          <a:effectRef idx="2">
-            <a:schemeClr val="accent1"/>
-          </a:effectRef>
-          <a:fontRef idx="minor">
-            <a:schemeClr val="lt1"/>
-          </a:fontRef>
-        </p:style>
-        <p:txBody>
-          <a:bodyPr wrap="square" rtlCol="0" anchor="ctr"/>
-          <a:lstStyle/>
-          <a:p>
-            <a:pPr algn="ctr"/>
-            <a:endParaRPr/>
-          </a:p>
-        </p:txBody>
-      </p:sp>
-      <p:sp>
-        <p:nvSpPr>
-          <p:cNvPr id="13" name="Rectangle 12"/>
-          <p:cNvSpPr/>
-          <p:nvPr/>
-        </p:nvSpPr>
-        <p:spPr>
-          <a:xfrm>
-            <a:off x="3026141" y="2231136"/>
-            <a:ext cx="2286000" cy="1298448"/>
-          </a:xfrm>
-          <a:prstGeom prst="rect">
-            <a:avLst/>
-          </a:prstGeom>
-          <a:solidFill>
-            <a:srgbClr val="EDF2FA"/>
-          </a:solidFill>
-          <a:ln>
-            <a:noFill/>
-          </a:ln>
-          <a:effectLst/>
-        </p:spPr>
-        <p:style>
-          <a:lnRef idx="1">
-            <a:schemeClr val="accent1"/>
-          </a:lnRef>
-          <a:fillRef idx="3">
-            <a:schemeClr val="accent1"/>
-          </a:fillRef>
-          <a:effectRef idx="2">
-            <a:schemeClr val="accent1"/>
-          </a:effectRef>
-          <a:fontRef idx="minor">
-            <a:schemeClr val="lt1"/>
-          </a:fontRef>
-        </p:style>
-        <p:txBody>
-          <a:bodyPr wrap="square" lIns="100584" tIns="73152" rIns="100584" bIns="73152" rtlCol="0" anchor="t"/>
-          <a:lstStyle/>
-          <a:p>
-            <a:pPr algn="l">
-              <a:spcAft>
-                <a:spcPts val="300"/>
-              </a:spcAft>
-            </a:pPr>
-            <a:r>
-              <a:rPr sz="1700" b="1">
-                <a:solidFill>
-                  <a:srgbClr val="4472C4"/>
-                </a:solidFill>
-                <a:latin typeface="Calibri"/>
-              </a:rPr>
-              <a:t>1749</a:t>
-            </a:r>
-          </a:p>
-          <a:p>
-            <a:pPr algn="l"/>
-            <a:r>
-              <a:rPr sz="1050">
-                <a:solidFill>
-                  <a:srgbClr val="262626"/>
-                </a:solidFill>
-                <a:latin typeface="Calibri"/>
-              </a:rPr>
-              <a:t>Gottfried Achenwall coins “Statistik” — literally the science of the state.</a:t>
-            </a:r>
-          </a:p>
-        </p:txBody>
-      </p:sp>
-      <p:sp>
-        <p:nvSpPr>
-          <p:cNvPr id="14" name="Rectangle 13"/>
-          <p:cNvSpPr/>
-          <p:nvPr/>
-        </p:nvSpPr>
-        <p:spPr>
-          <a:xfrm>
-            <a:off x="5443553" y="3913632"/>
-            <a:ext cx="20116" cy="384048"/>
-          </a:xfrm>
-          <a:prstGeom prst="rect">
-            <a:avLst/>
-          </a:prstGeom>
-          <a:solidFill>
-            <a:srgbClr val="4472C4"/>
-          </a:solidFill>
-          <a:ln>
-            <a:noFill/>
-          </a:ln>
-          <a:effectLst/>
-        </p:spPr>
-        <p:style>
-          <a:lnRef idx="1">
-            <a:schemeClr val="accent1"/>
-          </a:lnRef>
-          <a:fillRef idx="3">
-            <a:schemeClr val="accent1"/>
-          </a:fillRef>
-          <a:effectRef idx="2">
-            <a:schemeClr val="accent1"/>
-          </a:effectRef>
-          <a:fontRef idx="minor">
-            <a:schemeClr val="lt1"/>
-          </a:fontRef>
-        </p:style>
-        <p:txBody>
-          <a:bodyPr wrap="square" rtlCol="0" anchor="ctr"/>
-          <a:lstStyle/>
-          <a:p>
-            <a:pPr algn="ctr"/>
-            <a:endParaRPr/>
-          </a:p>
-        </p:txBody>
-      </p:sp>
-      <p:sp>
-        <p:nvSpPr>
-          <p:cNvPr id="15" name="Oval 14"/>
-          <p:cNvSpPr/>
-          <p:nvPr/>
-        </p:nvSpPr>
-        <p:spPr>
-          <a:xfrm>
-            <a:off x="5375888" y="3835908"/>
-            <a:ext cx="155448" cy="155448"/>
-          </a:xfrm>
-          <a:prstGeom prst="ellipse">
-            <a:avLst/>
-          </a:prstGeom>
-          <a:solidFill>
-            <a:srgbClr val="FFFFFF"/>
-          </a:solidFill>
-          <a:ln w="25400">
-            <a:solidFill>
-              <a:srgbClr val="4472C4"/>
-            </a:solidFill>
-          </a:ln>
-          <a:effectLst/>
-        </p:spPr>
-        <p:style>
-          <a:lnRef idx="1">
-            <a:schemeClr val="accent1"/>
-          </a:lnRef>
-          <a:fillRef idx="3">
-            <a:schemeClr val="accent1"/>
-          </a:fillRef>
-          <a:effectRef idx="2">
-            <a:schemeClr val="accent1"/>
-          </a:effectRef>
-          <a:fontRef idx="minor">
-            <a:schemeClr val="lt1"/>
-          </a:fontRef>
-        </p:style>
-        <p:txBody>
-          <a:bodyPr wrap="square" rtlCol="0" anchor="ctr"/>
-          <a:lstStyle/>
-          <a:p>
-            <a:pPr algn="ctr"/>
-            <a:endParaRPr/>
-          </a:p>
-        </p:txBody>
-      </p:sp>
-      <p:sp>
-        <p:nvSpPr>
-          <p:cNvPr id="16" name="Rectangle 15"/>
-          <p:cNvSpPr/>
-          <p:nvPr/>
-        </p:nvSpPr>
-        <p:spPr>
-          <a:xfrm>
-            <a:off x="4310612" y="4297680"/>
-            <a:ext cx="2286000" cy="1298448"/>
-          </a:xfrm>
-          <a:prstGeom prst="rect">
-            <a:avLst/>
-          </a:prstGeom>
-          <a:solidFill>
-            <a:srgbClr val="EDF2FA"/>
-          </a:solidFill>
-          <a:ln>
-            <a:noFill/>
-          </a:ln>
-          <a:effectLst/>
-        </p:spPr>
-        <p:style>
-          <a:lnRef idx="1">
-            <a:schemeClr val="accent1"/>
-          </a:lnRef>
-          <a:fillRef idx="3">
-            <a:schemeClr val="accent1"/>
-          </a:fillRef>
-          <a:effectRef idx="2">
-            <a:schemeClr val="accent1"/>
-          </a:effectRef>
-          <a:fontRef idx="minor">
-            <a:schemeClr val="lt1"/>
-          </a:fontRef>
-        </p:style>
-        <p:txBody>
-          <a:bodyPr wrap="square" lIns="100584" tIns="73152" rIns="100584" bIns="73152" rtlCol="0" anchor="t"/>
-          <a:lstStyle/>
-          <a:p>
-            <a:pPr algn="l">
-              <a:spcAft>
-                <a:spcPts val="300"/>
-              </a:spcAft>
-            </a:pPr>
-            <a:r>
-              <a:rPr sz="1700" b="1">
-                <a:solidFill>
-                  <a:srgbClr val="4472C4"/>
-                </a:solidFill>
-                <a:latin typeface="Calibri"/>
-              </a:rPr>
-              <a:t>1790</a:t>
-            </a:r>
-          </a:p>
-          <a:p>
-            <a:pPr algn="l"/>
-            <a:r>
-              <a:rPr sz="1050">
-                <a:solidFill>
-                  <a:srgbClr val="262626"/>
-                </a:solidFill>
-                <a:latin typeface="Calibri"/>
-              </a:rPr>
-              <a:t>The first U.S. census counts the population. Great Britain follows in 1801.</a:t>
-            </a:r>
-          </a:p>
-        </p:txBody>
-      </p:sp>
-      <p:sp>
-        <p:nvSpPr>
-          <p:cNvPr id="17" name="Rectangle 16"/>
-          <p:cNvSpPr/>
-          <p:nvPr/>
-        </p:nvSpPr>
-        <p:spPr>
-          <a:xfrm>
-            <a:off x="6728024" y="3529584"/>
-            <a:ext cx="20116" cy="384048"/>
-          </a:xfrm>
-          <a:prstGeom prst="rect">
-            <a:avLst/>
-          </a:prstGeom>
-          <a:solidFill>
-            <a:srgbClr val="4472C4"/>
-          </a:solidFill>
-          <a:ln>
-            <a:noFill/>
-          </a:ln>
-          <a:effectLst/>
-        </p:spPr>
-        <p:style>
-          <a:lnRef idx="1">
-            <a:schemeClr val="accent1"/>
-          </a:lnRef>
-          <a:fillRef idx="3">
-            <a:schemeClr val="accent1"/>
-          </a:fillRef>
-          <a:effectRef idx="2">
-            <a:schemeClr val="accent1"/>
-          </a:effectRef>
-          <a:fontRef idx="minor">
-            <a:schemeClr val="lt1"/>
-          </a:fontRef>
-        </p:style>
-        <p:txBody>
-          <a:bodyPr wrap="square" rtlCol="0" anchor="ctr"/>
-          <a:lstStyle/>
-          <a:p>
-            <a:pPr algn="ctr"/>
-            <a:endParaRPr/>
-          </a:p>
-        </p:txBody>
-      </p:sp>
-      <p:sp>
-        <p:nvSpPr>
-          <p:cNvPr id="18" name="Oval 17"/>
-          <p:cNvSpPr/>
-          <p:nvPr/>
-        </p:nvSpPr>
-        <p:spPr>
-          <a:xfrm>
-            <a:off x="6660358" y="3835908"/>
-            <a:ext cx="155448" cy="155448"/>
-          </a:xfrm>
-          <a:prstGeom prst="ellipse">
-            <a:avLst/>
-          </a:prstGeom>
-          <a:solidFill>
-            <a:srgbClr val="FFFFFF"/>
-          </a:solidFill>
-          <a:ln w="25400">
-            <a:solidFill>
-              <a:srgbClr val="4472C4"/>
-            </a:solidFill>
-          </a:ln>
-          <a:effectLst/>
-        </p:spPr>
-        <p:style>
-          <a:lnRef idx="1">
-            <a:schemeClr val="accent1"/>
-          </a:lnRef>
-          <a:fillRef idx="3">
-            <a:schemeClr val="accent1"/>
-          </a:fillRef>
-          <a:effectRef idx="2">
-            <a:schemeClr val="accent1"/>
-          </a:effectRef>
-          <a:fontRef idx="minor">
-            <a:schemeClr val="lt1"/>
-          </a:fontRef>
-        </p:style>
-        <p:txBody>
-          <a:bodyPr wrap="square" rtlCol="0" anchor="ctr"/>
-          <a:lstStyle/>
-          <a:p>
-            <a:pPr algn="ctr"/>
-            <a:endParaRPr/>
-          </a:p>
-        </p:txBody>
-      </p:sp>
-      <p:sp>
-        <p:nvSpPr>
-          <p:cNvPr id="19" name="Rectangle 18"/>
-          <p:cNvSpPr/>
-          <p:nvPr/>
-        </p:nvSpPr>
-        <p:spPr>
-          <a:xfrm>
-            <a:off x="5595082" y="2231136"/>
-            <a:ext cx="2286000" cy="1298448"/>
-          </a:xfrm>
-          <a:prstGeom prst="rect">
-            <a:avLst/>
-          </a:prstGeom>
-          <a:solidFill>
-            <a:srgbClr val="EDF2FA"/>
-          </a:solidFill>
-          <a:ln>
-            <a:noFill/>
-          </a:ln>
-          <a:effectLst/>
-        </p:spPr>
-        <p:style>
-          <a:lnRef idx="1">
-            <a:schemeClr val="accent1"/>
-          </a:lnRef>
-          <a:fillRef idx="3">
-            <a:schemeClr val="accent1"/>
-          </a:fillRef>
-          <a:effectRef idx="2">
-            <a:schemeClr val="accent1"/>
-          </a:effectRef>
-          <a:fontRef idx="minor">
-            <a:schemeClr val="lt1"/>
-          </a:fontRef>
-        </p:style>
-        <p:txBody>
-          <a:bodyPr wrap="square" lIns="100584" tIns="73152" rIns="100584" bIns="73152" rtlCol="0" anchor="t"/>
-          <a:lstStyle/>
-          <a:p>
-            <a:pPr algn="l">
-              <a:spcAft>
-                <a:spcPts val="300"/>
-              </a:spcAft>
-            </a:pPr>
-            <a:r>
-              <a:rPr sz="1700" b="1">
-                <a:solidFill>
-                  <a:srgbClr val="4472C4"/>
-                </a:solidFill>
-                <a:latin typeface="Calibri"/>
-              </a:rPr>
-              <a:t>1830s</a:t>
-            </a:r>
-          </a:p>
-          <a:p>
-            <a:pPr algn="l"/>
-            <a:r>
-              <a:rPr sz="1050">
-                <a:solidFill>
-                  <a:srgbClr val="262626"/>
-                </a:solidFill>
-                <a:latin typeface="Calibri"/>
-              </a:rPr>
-              <a:t>Adolphe Quetelet applies the normal curve to human traits and invents “the average man.”</a:t>
-            </a:r>
-          </a:p>
-        </p:txBody>
-      </p:sp>
-      <p:sp>
-        <p:nvSpPr>
-          <p:cNvPr id="20" name="Rectangle 19"/>
-          <p:cNvSpPr/>
-          <p:nvPr/>
-        </p:nvSpPr>
-        <p:spPr>
-          <a:xfrm>
-            <a:off x="8012495" y="3913632"/>
-            <a:ext cx="20116" cy="384048"/>
-          </a:xfrm>
-          <a:prstGeom prst="rect">
-            <a:avLst/>
-          </a:prstGeom>
-          <a:solidFill>
-            <a:srgbClr val="4472C4"/>
-          </a:solidFill>
-          <a:ln>
-            <a:noFill/>
-          </a:ln>
-          <a:effectLst/>
-        </p:spPr>
-        <p:style>
-          <a:lnRef idx="1">
-            <a:schemeClr val="accent1"/>
-          </a:lnRef>
-          <a:fillRef idx="3">
-            <a:schemeClr val="accent1"/>
-          </a:fillRef>
-          <a:effectRef idx="2">
-            <a:schemeClr val="accent1"/>
-          </a:effectRef>
-          <a:fontRef idx="minor">
-            <a:schemeClr val="lt1"/>
-          </a:fontRef>
-        </p:style>
-        <p:txBody>
-          <a:bodyPr wrap="square" rtlCol="0" anchor="ctr"/>
-          <a:lstStyle/>
-          <a:p>
-            <a:pPr algn="ctr"/>
-            <a:endParaRPr/>
-          </a:p>
-        </p:txBody>
-      </p:sp>
-      <p:sp>
-        <p:nvSpPr>
-          <p:cNvPr id="21" name="Oval 20"/>
-          <p:cNvSpPr/>
-          <p:nvPr/>
-        </p:nvSpPr>
-        <p:spPr>
-          <a:xfrm>
-            <a:off x="7944829" y="3835908"/>
-            <a:ext cx="155448" cy="155448"/>
-          </a:xfrm>
-          <a:prstGeom prst="ellipse">
-            <a:avLst/>
-          </a:prstGeom>
-          <a:solidFill>
-            <a:srgbClr val="FFFFFF"/>
-          </a:solidFill>
-          <a:ln w="25400">
-            <a:solidFill>
-              <a:srgbClr val="4472C4"/>
-            </a:solidFill>
-          </a:ln>
-          <a:effectLst/>
-        </p:spPr>
-        <p:style>
-          <a:lnRef idx="1">
-            <a:schemeClr val="accent1"/>
-          </a:lnRef>
-          <a:fillRef idx="3">
-            <a:schemeClr val="accent1"/>
-          </a:fillRef>
-          <a:effectRef idx="2">
-            <a:schemeClr val="accent1"/>
-          </a:effectRef>
-          <a:fontRef idx="minor">
-            <a:schemeClr val="lt1"/>
-          </a:fontRef>
-        </p:style>
-        <p:txBody>
-          <a:bodyPr wrap="square" rtlCol="0" anchor="ctr"/>
-          <a:lstStyle/>
-          <a:p>
-            <a:pPr algn="ctr"/>
-            <a:endParaRPr/>
-          </a:p>
-        </p:txBody>
-      </p:sp>
-      <p:sp>
-        <p:nvSpPr>
-          <p:cNvPr id="22" name="Rectangle 21"/>
-          <p:cNvSpPr/>
-          <p:nvPr/>
-        </p:nvSpPr>
-        <p:spPr>
-          <a:xfrm>
-            <a:off x="6879553" y="4297680"/>
-            <a:ext cx="2286000" cy="1298448"/>
-          </a:xfrm>
-          <a:prstGeom prst="rect">
-            <a:avLst/>
-          </a:prstGeom>
-          <a:solidFill>
-            <a:srgbClr val="EDF2FA"/>
-          </a:solidFill>
-          <a:ln>
-            <a:noFill/>
-          </a:ln>
-          <a:effectLst/>
-        </p:spPr>
-        <p:style>
-          <a:lnRef idx="1">
-            <a:schemeClr val="accent1"/>
-          </a:lnRef>
-          <a:fillRef idx="3">
-            <a:schemeClr val="accent1"/>
-          </a:fillRef>
-          <a:effectRef idx="2">
-            <a:schemeClr val="accent1"/>
-          </a:effectRef>
-          <a:fontRef idx="minor">
-            <a:schemeClr val="lt1"/>
-          </a:fontRef>
-        </p:style>
-        <p:txBody>
-          <a:bodyPr wrap="square" lIns="100584" tIns="73152" rIns="100584" bIns="73152" rtlCol="0" anchor="t"/>
-          <a:lstStyle/>
-          <a:p>
-            <a:pPr algn="l">
-              <a:spcAft>
-                <a:spcPts val="300"/>
-              </a:spcAft>
-            </a:pPr>
-            <a:r>
-              <a:rPr sz="1700" b="1">
-                <a:solidFill>
-                  <a:srgbClr val="4472C4"/>
-                </a:solidFill>
-                <a:latin typeface="Calibri"/>
-              </a:rPr>
-              <a:t>1900</a:t>
-            </a:r>
-          </a:p>
-          <a:p>
-            <a:pPr algn="l"/>
-            <a:r>
-              <a:rPr sz="1050">
-                <a:solidFill>
-                  <a:srgbClr val="262626"/>
-                </a:solidFill>
-                <a:latin typeface="Calibri"/>
-              </a:rPr>
-              <a:t>Galton and Pearson develop correlation, regression, and the chi-square test.</a:t>
-            </a:r>
-          </a:p>
-        </p:txBody>
-      </p:sp>
-      <p:sp>
-        <p:nvSpPr>
-          <p:cNvPr id="23" name="Rectangle 22"/>
-          <p:cNvSpPr/>
-          <p:nvPr/>
-        </p:nvSpPr>
-        <p:spPr>
-          <a:xfrm>
-            <a:off x="9296966" y="3529584"/>
-            <a:ext cx="20116" cy="384048"/>
-          </a:xfrm>
-          <a:prstGeom prst="rect">
-            <a:avLst/>
-          </a:prstGeom>
-          <a:solidFill>
-            <a:srgbClr val="4472C4"/>
-          </a:solidFill>
-          <a:ln>
-            <a:noFill/>
-          </a:ln>
-          <a:effectLst/>
-        </p:spPr>
-        <p:style>
-          <a:lnRef idx="1">
-            <a:schemeClr val="accent1"/>
-          </a:lnRef>
-          <a:fillRef idx="3">
-            <a:schemeClr val="accent1"/>
-          </a:fillRef>
-          <a:effectRef idx="2">
-            <a:schemeClr val="accent1"/>
-          </a:effectRef>
-          <a:fontRef idx="minor">
-            <a:schemeClr val="lt1"/>
-          </a:fontRef>
-        </p:style>
-        <p:txBody>
-          <a:bodyPr wrap="square" rtlCol="0" anchor="ctr"/>
-          <a:lstStyle/>
-          <a:p>
-            <a:pPr algn="ctr"/>
-            <a:endParaRPr/>
-          </a:p>
-        </p:txBody>
-      </p:sp>
-      <p:sp>
-        <p:nvSpPr>
-          <p:cNvPr id="24" name="Oval 23"/>
-          <p:cNvSpPr/>
-          <p:nvPr/>
-        </p:nvSpPr>
-        <p:spPr>
-          <a:xfrm>
-            <a:off x="9229300" y="3835908"/>
-            <a:ext cx="155448" cy="155448"/>
-          </a:xfrm>
-          <a:prstGeom prst="ellipse">
-            <a:avLst/>
-          </a:prstGeom>
-          <a:solidFill>
-            <a:srgbClr val="FFFFFF"/>
-          </a:solidFill>
-          <a:ln w="25400">
-            <a:solidFill>
-              <a:srgbClr val="4472C4"/>
-            </a:solidFill>
-          </a:ln>
-          <a:effectLst/>
-        </p:spPr>
-        <p:style>
-          <a:lnRef idx="1">
-            <a:schemeClr val="accent1"/>
-          </a:lnRef>
-          <a:fillRef idx="3">
-            <a:schemeClr val="accent1"/>
-          </a:fillRef>
-          <a:effectRef idx="2">
-            <a:schemeClr val="accent1"/>
-          </a:effectRef>
-          <a:fontRef idx="minor">
-            <a:schemeClr val="lt1"/>
-          </a:fontRef>
-        </p:style>
-        <p:txBody>
-          <a:bodyPr wrap="square" rtlCol="0" anchor="ctr"/>
-          <a:lstStyle/>
-          <a:p>
-            <a:pPr algn="ctr"/>
-            <a:endParaRPr/>
-          </a:p>
-        </p:txBody>
-      </p:sp>
-      <p:sp>
-        <p:nvSpPr>
-          <p:cNvPr id="25" name="Rectangle 24"/>
-          <p:cNvSpPr/>
-          <p:nvPr/>
-        </p:nvSpPr>
-        <p:spPr>
-          <a:xfrm>
-            <a:off x="8164024" y="2231136"/>
-            <a:ext cx="2286000" cy="1298448"/>
-          </a:xfrm>
-          <a:prstGeom prst="rect">
-            <a:avLst/>
-          </a:prstGeom>
-          <a:solidFill>
-            <a:srgbClr val="EDF2FA"/>
-          </a:solidFill>
-          <a:ln>
-            <a:noFill/>
-          </a:ln>
-          <a:effectLst/>
-        </p:spPr>
-        <p:style>
-          <a:lnRef idx="1">
-            <a:schemeClr val="accent1"/>
-          </a:lnRef>
-          <a:fillRef idx="3">
-            <a:schemeClr val="accent1"/>
-          </a:fillRef>
-          <a:effectRef idx="2">
-            <a:schemeClr val="accent1"/>
-          </a:effectRef>
-          <a:fontRef idx="minor">
-            <a:schemeClr val="lt1"/>
-          </a:fontRef>
-        </p:style>
-        <p:txBody>
-          <a:bodyPr wrap="square" lIns="100584" tIns="73152" rIns="100584" bIns="73152" rtlCol="0" anchor="t"/>
-          <a:lstStyle/>
-          <a:p>
-            <a:pPr algn="l">
-              <a:spcAft>
-                <a:spcPts val="300"/>
-              </a:spcAft>
-            </a:pPr>
-            <a:r>
-              <a:rPr sz="1700" b="1">
-                <a:solidFill>
-                  <a:srgbClr val="4472C4"/>
-                </a:solidFill>
-                <a:latin typeface="Calibri"/>
-              </a:rPr>
-              <a:t>1925</a:t>
-            </a:r>
-          </a:p>
-          <a:p>
-            <a:pPr algn="l"/>
-            <a:r>
-              <a:rPr sz="1050">
-                <a:solidFill>
-                  <a:srgbClr val="262626"/>
-                </a:solidFill>
-                <a:latin typeface="Calibri"/>
-              </a:rPr>
-              <a:t>R. A. Fisher formalizes experimental design, ANOVA, and significance testing.</a:t>
-            </a:r>
-          </a:p>
-        </p:txBody>
-      </p:sp>
-      <p:sp>
-        <p:nvSpPr>
-          <p:cNvPr id="26" name="Rectangle 25"/>
-          <p:cNvSpPr/>
-          <p:nvPr/>
-        </p:nvSpPr>
-        <p:spPr>
-          <a:xfrm>
-            <a:off x="10581436" y="3913632"/>
-            <a:ext cx="20116" cy="384048"/>
-          </a:xfrm>
-          <a:prstGeom prst="rect">
-            <a:avLst/>
-          </a:prstGeom>
-          <a:solidFill>
-            <a:srgbClr val="C5540F"/>
-          </a:solidFill>
-          <a:ln>
-            <a:noFill/>
-          </a:ln>
-          <a:effectLst/>
-        </p:spPr>
-        <p:style>
-          <a:lnRef idx="1">
-            <a:schemeClr val="accent1"/>
-          </a:lnRef>
-          <a:fillRef idx="3">
-            <a:schemeClr val="accent1"/>
-          </a:fillRef>
-          <a:effectRef idx="2">
-            <a:schemeClr val="accent1"/>
-          </a:effectRef>
-          <a:fontRef idx="minor">
-            <a:schemeClr val="lt1"/>
-          </a:fontRef>
-        </p:style>
-        <p:txBody>
-          <a:bodyPr wrap="square" rtlCol="0" anchor="ctr"/>
-          <a:lstStyle/>
-          <a:p>
-            <a:pPr algn="ctr"/>
-            <a:endParaRPr/>
-          </a:p>
-        </p:txBody>
-      </p:sp>
-      <p:sp>
-        <p:nvSpPr>
-          <p:cNvPr id="27" name="Oval 26"/>
-          <p:cNvSpPr/>
-          <p:nvPr/>
-        </p:nvSpPr>
-        <p:spPr>
-          <a:xfrm>
-            <a:off x="10513771" y="3835908"/>
-            <a:ext cx="155448" cy="155448"/>
-          </a:xfrm>
-          <a:prstGeom prst="ellipse">
-            <a:avLst/>
-          </a:prstGeom>
-          <a:solidFill>
-            <a:srgbClr val="FFFFFF"/>
-          </a:solidFill>
-          <a:ln w="25400">
-            <a:solidFill>
-              <a:srgbClr val="C5540F"/>
-            </a:solidFill>
-          </a:ln>
-          <a:effectLst/>
-        </p:spPr>
-        <p:style>
-          <a:lnRef idx="1">
-            <a:schemeClr val="accent1"/>
-          </a:lnRef>
-          <a:fillRef idx="3">
-            <a:schemeClr val="accent1"/>
-          </a:fillRef>
-          <a:effectRef idx="2">
-            <a:schemeClr val="accent1"/>
-          </a:effectRef>
-          <a:fontRef idx="minor">
-            <a:schemeClr val="lt1"/>
-          </a:fontRef>
-        </p:style>
-        <p:txBody>
-          <a:bodyPr wrap="square" rtlCol="0" anchor="ctr"/>
-          <a:lstStyle/>
-          <a:p>
-            <a:pPr algn="ctr"/>
-            <a:endParaRPr/>
-          </a:p>
-        </p:txBody>
-      </p:sp>
-      <p:sp>
-        <p:nvSpPr>
-          <p:cNvPr id="28" name="Rectangle 27"/>
-          <p:cNvSpPr/>
-          <p:nvPr/>
-        </p:nvSpPr>
-        <p:spPr>
-          <a:xfrm>
-            <a:off x="9448495" y="4297680"/>
-            <a:ext cx="2286000" cy="1298448"/>
-          </a:xfrm>
-          <a:prstGeom prst="rect">
-            <a:avLst/>
-          </a:prstGeom>
-          <a:solidFill>
-            <a:srgbClr val="FCE6D5"/>
-          </a:solidFill>
-          <a:ln>
-            <a:noFill/>
-          </a:ln>
-          <a:effectLst/>
-        </p:spPr>
-        <p:style>
-          <a:lnRef idx="1">
-            <a:schemeClr val="accent1"/>
-          </a:lnRef>
-          <a:fillRef idx="3">
-            <a:schemeClr val="accent1"/>
-          </a:fillRef>
-          <a:effectRef idx="2">
-            <a:schemeClr val="accent1"/>
-          </a:effectRef>
-          <a:fontRef idx="minor">
-            <a:schemeClr val="lt1"/>
-          </a:fontRef>
-        </p:style>
-        <p:txBody>
-          <a:bodyPr wrap="square" lIns="100584" tIns="73152" rIns="100584" bIns="73152" rtlCol="0" anchor="t"/>
-          <a:lstStyle/>
-          <a:p>
-            <a:pPr algn="l">
-              <a:spcAft>
-                <a:spcPts val="300"/>
-              </a:spcAft>
-            </a:pPr>
-            <a:r>
-              <a:rPr sz="1700" b="1">
-                <a:solidFill>
-                  <a:srgbClr val="C5540F"/>
-                </a:solidFill>
-                <a:latin typeface="Calibri"/>
-              </a:rPr>
-              <a:t>Today</a:t>
-            </a:r>
-          </a:p>
-          <a:p>
-            <a:pPr algn="l"/>
-            <a:r>
-              <a:rPr sz="1050">
-                <a:solidFill>
-                  <a:srgbClr val="262626"/>
-                </a:solidFill>
-                <a:latin typeface="Calibri"/>
-              </a:rPr>
-              <a:t>The same ideas, now run by computers on data far larger than Graunt could count.</a:t>
-            </a:r>
-          </a:p>
-        </p:txBody>
-      </p:sp>
-      <p:sp>
-        <p:nvSpPr>
-          <p:cNvPr id="29" name="TextBox 28"/>
-          <p:cNvSpPr txBox="1"/>
-          <p:nvPr/>
-        </p:nvSpPr>
-        <p:spPr>
-          <a:xfrm>
-            <a:off x="457200" y="6144768"/>
-            <a:ext cx="11292840" cy="566928"/>
-          </a:xfrm>
-          <a:prstGeom prst="rect">
-            <a:avLst/>
-          </a:prstGeom>
-          <a:noFill/>
-        </p:spPr>
-        <p:txBody>
-          <a:bodyPr wrap="square" lIns="0" tIns="0" rIns="0" bIns="0" anchor="t">
-            <a:spAutoFit/>
-          </a:bodyPr>
-          <a:lstStyle/>
-          <a:p>
-            <a:pPr algn="l">
-              <a:spcAft>
-                <a:spcPts val="0"/>
-              </a:spcAft>
-            </a:pPr>
-            <a:r>
-              <a:rPr sz="900" b="0">
-                <a:solidFill>
-                  <a:srgbClr val="595959"/>
-                </a:solidFill>
-                <a:latin typeface="Calibri"/>
-              </a:rPr>
-              <a:t>Sources: J. Graunt (1662), Natural and Political Observations Made upon the Bills of Mortality. E. Halley (1693), Phil. Trans. R. Soc. 17:596–610. G. Achenwall (1749), Abriss der neuesten Staatswissenschaft. A. Quetelet (1835), Sur l’homme et le développement de ses facultés. R. A. Fisher (1925), Statistical Methods for Research Workers.</a:t>
-            </a:r>
-          </a:p>
-        </p:txBody>
-      </p:sp>
-    </p:spTree>
-  </p:cSld>
-  <p:clrMapOvr>
-    <a:masterClrMapping/>
-  </p:clrMapOvr>
-</p:sld>
-</file>
-
-<file path=ppt/slides/slide3.xml><?xml version="1.0" encoding="utf-8"?>
-<p:sld xmlns:a="http://schemas.openxmlformats.org/drawingml/2006/main" xmlns:r="http://schemas.openxmlformats.org/officeDocument/2006/relationships" xmlns:p="http://schemas.openxmlformats.org/presentationml/2006/main">
-  <p:cSld>
-    <p:spTree>
-      <p:nvGrpSpPr>
-        <p:cNvPr id="1" name=""/>
-        <p:cNvGrpSpPr/>
-        <p:nvPr/>
-      </p:nvGrpSpPr>
-      <p:grpSpPr>
-        <a:xfrm>
-          <a:off x="0" y="0"/>
-          <a:ext cx="0" cy="0"/>
-          <a:chOff x="0" y="0"/>
-          <a:chExt cx="0" cy="0"/>
-        </a:xfrm>
-      </p:grpSpPr>
-      <p:sp>
-        <p:nvSpPr>
           <p:cNvPr id="2" name="Title 1">
             <a:extLst>
               <a:ext uri="{FF2B5EF4-FFF2-40B4-BE49-F238E27FC236}">
@@ -10949,7 +9481,7 @@
 </p:sld>
 </file>
 
-<file path=ppt/slides/slide4.xml><?xml version="1.0" encoding="utf-8"?>
+<file path=ppt/slides/slide3.xml><?xml version="1.0" encoding="utf-8"?>
 <p:sld xmlns:a="http://schemas.openxmlformats.org/drawingml/2006/main" xmlns:r="http://schemas.openxmlformats.org/officeDocument/2006/relationships" xmlns:p="http://schemas.openxmlformats.org/presentationml/2006/main">
   <p:cSld>
     <p:bg>
@@ -11662,6 +10194,1474 @@
         <p14:creationId xmlns:p14="http://schemas.microsoft.com/office/powerpoint/2010/main" val="1912649442"/>
       </p:ext>
     </p:extLst>
+  </p:cSld>
+  <p:clrMapOvr>
+    <a:masterClrMapping/>
+  </p:clrMapOvr>
+</p:sld>
+</file>
+
+<file path=ppt/slides/slide4.xml><?xml version="1.0" encoding="utf-8"?>
+<p:sld xmlns:a="http://schemas.openxmlformats.org/drawingml/2006/main" xmlns:r="http://schemas.openxmlformats.org/officeDocument/2006/relationships" xmlns:p="http://schemas.openxmlformats.org/presentationml/2006/main">
+  <p:cSld>
+    <p:spTree>
+      <p:nvGrpSpPr>
+        <p:cNvPr id="1" name=""/>
+        <p:cNvGrpSpPr/>
+        <p:nvPr/>
+      </p:nvGrpSpPr>
+      <p:grpSpPr>
+        <a:xfrm>
+          <a:off x="0" y="0"/>
+          <a:ext cx="0" cy="0"/>
+          <a:chOff x="0" y="0"/>
+          <a:chExt cx="0" cy="0"/>
+        </a:xfrm>
+      </p:grpSpPr>
+      <p:sp>
+        <p:nvSpPr>
+          <p:cNvPr id="2" name="Title 1"/>
+          <p:cNvSpPr>
+            <a:spLocks noGrp="1"/>
+          </p:cNvSpPr>
+          <p:nvPr>
+            <p:ph type="title"/>
+          </p:nvPr>
+        </p:nvSpPr>
+        <p:spPr>
+          <a:xfrm>
+            <a:off x="457200" y="182880"/>
+            <a:ext cx="11338560" cy="914400"/>
+          </a:xfrm>
+        </p:spPr>
+        <p:txBody>
+          <a:bodyPr/>
+          <a:lstStyle/>
+          <a:p>
+            <a:r>
+              <a:rPr sz="4000">
+                <a:solidFill>
+                  <a:srgbClr val="000000"/>
+                </a:solidFill>
+                <a:latin typeface="Calibri Light"/>
+              </a:rPr>
+              <a:t>Where does statistics come from?</a:t>
+            </a:r>
+          </a:p>
+        </p:txBody>
+      </p:sp>
+      <p:sp>
+        <p:nvSpPr>
+          <p:cNvPr id="3" name="TextBox 2"/>
+          <p:cNvSpPr txBox="1"/>
+          <p:nvPr/>
+        </p:nvSpPr>
+        <p:spPr>
+          <a:xfrm>
+            <a:off x="457200" y="1170432"/>
+            <a:ext cx="11292840" cy="411480"/>
+          </a:xfrm>
+          <a:prstGeom prst="rect">
+            <a:avLst/>
+          </a:prstGeom>
+          <a:noFill/>
+        </p:spPr>
+        <p:txBody>
+          <a:bodyPr wrap="square" lIns="0" tIns="0" rIns="0" bIns="0" anchor="t">
+            <a:spAutoFit/>
+          </a:bodyPr>
+          <a:lstStyle/>
+          <a:p>
+            <a:pPr algn="l">
+              <a:spcAft>
+                <a:spcPts val="0"/>
+              </a:spcAft>
+            </a:pPr>
+            <a:r>
+              <a:rPr sz="1600" b="0">
+                <a:solidFill>
+                  <a:srgbClr val="333333"/>
+                </a:solidFill>
+                <a:latin typeface="Calibri"/>
+              </a:rPr>
+              <a:t>Statistics began as bookkeeping about people — counting births, deaths, and taxpayers so that a state could describe itself.</a:t>
+            </a:r>
+          </a:p>
+        </p:txBody>
+      </p:sp>
+      <p:sp>
+        <p:nvSpPr>
+          <p:cNvPr id="4" name="Rectangle 3"/>
+          <p:cNvSpPr/>
+          <p:nvPr/>
+        </p:nvSpPr>
+        <p:spPr>
+          <a:xfrm>
+            <a:off x="457200" y="3893515"/>
+            <a:ext cx="11277295" cy="40233"/>
+          </a:xfrm>
+          <a:prstGeom prst="rect">
+            <a:avLst/>
+          </a:prstGeom>
+          <a:solidFill>
+            <a:srgbClr val="4472C4"/>
+          </a:solidFill>
+          <a:ln>
+            <a:noFill/>
+          </a:ln>
+          <a:effectLst/>
+        </p:spPr>
+        <p:style>
+          <a:lnRef idx="1">
+            <a:schemeClr val="accent1"/>
+          </a:lnRef>
+          <a:fillRef idx="3">
+            <a:schemeClr val="accent1"/>
+          </a:fillRef>
+          <a:effectRef idx="2">
+            <a:schemeClr val="accent1"/>
+          </a:effectRef>
+          <a:fontRef idx="minor">
+            <a:schemeClr val="lt1"/>
+          </a:fontRef>
+        </p:style>
+        <p:txBody>
+          <a:bodyPr wrap="square" rtlCol="0" anchor="ctr"/>
+          <a:lstStyle/>
+          <a:p>
+            <a:pPr algn="ctr"/>
+            <a:endParaRPr/>
+          </a:p>
+        </p:txBody>
+      </p:sp>
+      <p:sp>
+        <p:nvSpPr>
+          <p:cNvPr id="5" name="Rectangle 4"/>
+          <p:cNvSpPr/>
+          <p:nvPr/>
+        </p:nvSpPr>
+        <p:spPr>
+          <a:xfrm>
+            <a:off x="1590141" y="3529584"/>
+            <a:ext cx="20116" cy="384048"/>
+          </a:xfrm>
+          <a:prstGeom prst="rect">
+            <a:avLst/>
+          </a:prstGeom>
+          <a:solidFill>
+            <a:srgbClr val="4472C4"/>
+          </a:solidFill>
+          <a:ln>
+            <a:noFill/>
+          </a:ln>
+          <a:effectLst/>
+        </p:spPr>
+        <p:style>
+          <a:lnRef idx="1">
+            <a:schemeClr val="accent1"/>
+          </a:lnRef>
+          <a:fillRef idx="3">
+            <a:schemeClr val="accent1"/>
+          </a:fillRef>
+          <a:effectRef idx="2">
+            <a:schemeClr val="accent1"/>
+          </a:effectRef>
+          <a:fontRef idx="minor">
+            <a:schemeClr val="lt1"/>
+          </a:fontRef>
+        </p:style>
+        <p:txBody>
+          <a:bodyPr wrap="square" rtlCol="0" anchor="ctr"/>
+          <a:lstStyle/>
+          <a:p>
+            <a:pPr algn="ctr"/>
+            <a:endParaRPr/>
+          </a:p>
+        </p:txBody>
+      </p:sp>
+      <p:sp>
+        <p:nvSpPr>
+          <p:cNvPr id="6" name="Oval 5"/>
+          <p:cNvSpPr/>
+          <p:nvPr/>
+        </p:nvSpPr>
+        <p:spPr>
+          <a:xfrm>
+            <a:off x="1522476" y="3835908"/>
+            <a:ext cx="155448" cy="155448"/>
+          </a:xfrm>
+          <a:prstGeom prst="ellipse">
+            <a:avLst/>
+          </a:prstGeom>
+          <a:solidFill>
+            <a:srgbClr val="FFFFFF"/>
+          </a:solidFill>
+          <a:ln w="25400">
+            <a:solidFill>
+              <a:srgbClr val="4472C4"/>
+            </a:solidFill>
+          </a:ln>
+          <a:effectLst/>
+        </p:spPr>
+        <p:style>
+          <a:lnRef idx="1">
+            <a:schemeClr val="accent1"/>
+          </a:lnRef>
+          <a:fillRef idx="3">
+            <a:schemeClr val="accent1"/>
+          </a:fillRef>
+          <a:effectRef idx="2">
+            <a:schemeClr val="accent1"/>
+          </a:effectRef>
+          <a:fontRef idx="minor">
+            <a:schemeClr val="lt1"/>
+          </a:fontRef>
+        </p:style>
+        <p:txBody>
+          <a:bodyPr wrap="square" rtlCol="0" anchor="ctr"/>
+          <a:lstStyle/>
+          <a:p>
+            <a:pPr algn="ctr"/>
+            <a:endParaRPr/>
+          </a:p>
+        </p:txBody>
+      </p:sp>
+      <p:sp>
+        <p:nvSpPr>
+          <p:cNvPr id="7" name="Rectangle 6"/>
+          <p:cNvSpPr/>
+          <p:nvPr/>
+        </p:nvSpPr>
+        <p:spPr>
+          <a:xfrm>
+            <a:off x="457200" y="2231136"/>
+            <a:ext cx="2286000" cy="1298448"/>
+          </a:xfrm>
+          <a:prstGeom prst="rect">
+            <a:avLst/>
+          </a:prstGeom>
+          <a:solidFill>
+            <a:srgbClr val="EDF2FA"/>
+          </a:solidFill>
+          <a:ln>
+            <a:noFill/>
+          </a:ln>
+          <a:effectLst/>
+        </p:spPr>
+        <p:style>
+          <a:lnRef idx="1">
+            <a:schemeClr val="accent1"/>
+          </a:lnRef>
+          <a:fillRef idx="3">
+            <a:schemeClr val="accent1"/>
+          </a:fillRef>
+          <a:effectRef idx="2">
+            <a:schemeClr val="accent1"/>
+          </a:effectRef>
+          <a:fontRef idx="minor">
+            <a:schemeClr val="lt1"/>
+          </a:fontRef>
+        </p:style>
+        <p:txBody>
+          <a:bodyPr wrap="square" lIns="100584" tIns="73152" rIns="100584" bIns="73152" rtlCol="0" anchor="t"/>
+          <a:lstStyle/>
+          <a:p>
+            <a:pPr algn="l">
+              <a:spcAft>
+                <a:spcPts val="300"/>
+              </a:spcAft>
+            </a:pPr>
+            <a:r>
+              <a:rPr sz="1700" b="1">
+                <a:solidFill>
+                  <a:srgbClr val="4472C4"/>
+                </a:solidFill>
+                <a:latin typeface="Calibri"/>
+              </a:rPr>
+              <a:t>1662</a:t>
+            </a:r>
+          </a:p>
+          <a:p>
+            <a:pPr algn="l"/>
+            <a:r>
+              <a:rPr sz="1050">
+                <a:solidFill>
+                  <a:srgbClr val="262626"/>
+                </a:solidFill>
+                <a:latin typeface="Calibri"/>
+              </a:rPr>
+              <a:t>John Graunt studies London's Bills of Mortality — the first life table built from real data.</a:t>
+            </a:r>
+          </a:p>
+        </p:txBody>
+      </p:sp>
+      <p:sp>
+        <p:nvSpPr>
+          <p:cNvPr id="8" name="Rectangle 7"/>
+          <p:cNvSpPr/>
+          <p:nvPr/>
+        </p:nvSpPr>
+        <p:spPr>
+          <a:xfrm>
+            <a:off x="2874612" y="3913632"/>
+            <a:ext cx="20116" cy="384048"/>
+          </a:xfrm>
+          <a:prstGeom prst="rect">
+            <a:avLst/>
+          </a:prstGeom>
+          <a:solidFill>
+            <a:srgbClr val="4472C4"/>
+          </a:solidFill>
+          <a:ln>
+            <a:noFill/>
+          </a:ln>
+          <a:effectLst/>
+        </p:spPr>
+        <p:style>
+          <a:lnRef idx="1">
+            <a:schemeClr val="accent1"/>
+          </a:lnRef>
+          <a:fillRef idx="3">
+            <a:schemeClr val="accent1"/>
+          </a:fillRef>
+          <a:effectRef idx="2">
+            <a:schemeClr val="accent1"/>
+          </a:effectRef>
+          <a:fontRef idx="minor">
+            <a:schemeClr val="lt1"/>
+          </a:fontRef>
+        </p:style>
+        <p:txBody>
+          <a:bodyPr wrap="square" rtlCol="0" anchor="ctr"/>
+          <a:lstStyle/>
+          <a:p>
+            <a:pPr algn="ctr"/>
+            <a:endParaRPr/>
+          </a:p>
+        </p:txBody>
+      </p:sp>
+      <p:sp>
+        <p:nvSpPr>
+          <p:cNvPr id="9" name="Oval 8"/>
+          <p:cNvSpPr/>
+          <p:nvPr/>
+        </p:nvSpPr>
+        <p:spPr>
+          <a:xfrm>
+            <a:off x="2806946" y="3835908"/>
+            <a:ext cx="155448" cy="155448"/>
+          </a:xfrm>
+          <a:prstGeom prst="ellipse">
+            <a:avLst/>
+          </a:prstGeom>
+          <a:solidFill>
+            <a:srgbClr val="FFFFFF"/>
+          </a:solidFill>
+          <a:ln w="25400">
+            <a:solidFill>
+              <a:srgbClr val="4472C4"/>
+            </a:solidFill>
+          </a:ln>
+          <a:effectLst/>
+        </p:spPr>
+        <p:style>
+          <a:lnRef idx="1">
+            <a:schemeClr val="accent1"/>
+          </a:lnRef>
+          <a:fillRef idx="3">
+            <a:schemeClr val="accent1"/>
+          </a:fillRef>
+          <a:effectRef idx="2">
+            <a:schemeClr val="accent1"/>
+          </a:effectRef>
+          <a:fontRef idx="minor">
+            <a:schemeClr val="lt1"/>
+          </a:fontRef>
+        </p:style>
+        <p:txBody>
+          <a:bodyPr wrap="square" rtlCol="0" anchor="ctr"/>
+          <a:lstStyle/>
+          <a:p>
+            <a:pPr algn="ctr"/>
+            <a:endParaRPr/>
+          </a:p>
+        </p:txBody>
+      </p:sp>
+      <p:sp>
+        <p:nvSpPr>
+          <p:cNvPr id="10" name="Rectangle 9"/>
+          <p:cNvSpPr/>
+          <p:nvPr/>
+        </p:nvSpPr>
+        <p:spPr>
+          <a:xfrm>
+            <a:off x="1741670" y="4297680"/>
+            <a:ext cx="2286000" cy="1298448"/>
+          </a:xfrm>
+          <a:prstGeom prst="rect">
+            <a:avLst/>
+          </a:prstGeom>
+          <a:solidFill>
+            <a:srgbClr val="EDF2FA"/>
+          </a:solidFill>
+          <a:ln>
+            <a:noFill/>
+          </a:ln>
+          <a:effectLst/>
+        </p:spPr>
+        <p:style>
+          <a:lnRef idx="1">
+            <a:schemeClr val="accent1"/>
+          </a:lnRef>
+          <a:fillRef idx="3">
+            <a:schemeClr val="accent1"/>
+          </a:fillRef>
+          <a:effectRef idx="2">
+            <a:schemeClr val="accent1"/>
+          </a:effectRef>
+          <a:fontRef idx="minor">
+            <a:schemeClr val="lt1"/>
+          </a:fontRef>
+        </p:style>
+        <p:txBody>
+          <a:bodyPr wrap="square" lIns="100584" tIns="73152" rIns="100584" bIns="73152" rtlCol="0" anchor="t"/>
+          <a:lstStyle/>
+          <a:p>
+            <a:pPr algn="l">
+              <a:spcAft>
+                <a:spcPts val="300"/>
+              </a:spcAft>
+            </a:pPr>
+            <a:r>
+              <a:rPr sz="1700" b="1">
+                <a:solidFill>
+                  <a:srgbClr val="4472C4"/>
+                </a:solidFill>
+                <a:latin typeface="Calibri"/>
+              </a:rPr>
+              <a:t>1693</a:t>
+            </a:r>
+          </a:p>
+          <a:p>
+            <a:pPr algn="l"/>
+            <a:r>
+              <a:rPr sz="1050">
+                <a:solidFill>
+                  <a:srgbClr val="262626"/>
+                </a:solidFill>
+                <a:latin typeface="Calibri"/>
+              </a:rPr>
+              <a:t>Edmond Halley's Breslau life table makes it possible to price life annuities.</a:t>
+            </a:r>
+          </a:p>
+        </p:txBody>
+      </p:sp>
+      <p:sp>
+        <p:nvSpPr>
+          <p:cNvPr id="11" name="Rectangle 10"/>
+          <p:cNvSpPr/>
+          <p:nvPr/>
+        </p:nvSpPr>
+        <p:spPr>
+          <a:xfrm>
+            <a:off x="4159083" y="3529584"/>
+            <a:ext cx="20116" cy="384048"/>
+          </a:xfrm>
+          <a:prstGeom prst="rect">
+            <a:avLst/>
+          </a:prstGeom>
+          <a:solidFill>
+            <a:srgbClr val="4472C4"/>
+          </a:solidFill>
+          <a:ln>
+            <a:noFill/>
+          </a:ln>
+          <a:effectLst/>
+        </p:spPr>
+        <p:style>
+          <a:lnRef idx="1">
+            <a:schemeClr val="accent1"/>
+          </a:lnRef>
+          <a:fillRef idx="3">
+            <a:schemeClr val="accent1"/>
+          </a:fillRef>
+          <a:effectRef idx="2">
+            <a:schemeClr val="accent1"/>
+          </a:effectRef>
+          <a:fontRef idx="minor">
+            <a:schemeClr val="lt1"/>
+          </a:fontRef>
+        </p:style>
+        <p:txBody>
+          <a:bodyPr wrap="square" rtlCol="0" anchor="ctr"/>
+          <a:lstStyle/>
+          <a:p>
+            <a:pPr algn="ctr"/>
+            <a:endParaRPr/>
+          </a:p>
+        </p:txBody>
+      </p:sp>
+      <p:sp>
+        <p:nvSpPr>
+          <p:cNvPr id="12" name="Oval 11"/>
+          <p:cNvSpPr/>
+          <p:nvPr/>
+        </p:nvSpPr>
+        <p:spPr>
+          <a:xfrm>
+            <a:off x="4091417" y="3835908"/>
+            <a:ext cx="155448" cy="155448"/>
+          </a:xfrm>
+          <a:prstGeom prst="ellipse">
+            <a:avLst/>
+          </a:prstGeom>
+          <a:solidFill>
+            <a:srgbClr val="FFFFFF"/>
+          </a:solidFill>
+          <a:ln w="25400">
+            <a:solidFill>
+              <a:srgbClr val="4472C4"/>
+            </a:solidFill>
+          </a:ln>
+          <a:effectLst/>
+        </p:spPr>
+        <p:style>
+          <a:lnRef idx="1">
+            <a:schemeClr val="accent1"/>
+          </a:lnRef>
+          <a:fillRef idx="3">
+            <a:schemeClr val="accent1"/>
+          </a:fillRef>
+          <a:effectRef idx="2">
+            <a:schemeClr val="accent1"/>
+          </a:effectRef>
+          <a:fontRef idx="minor">
+            <a:schemeClr val="lt1"/>
+          </a:fontRef>
+        </p:style>
+        <p:txBody>
+          <a:bodyPr wrap="square" rtlCol="0" anchor="ctr"/>
+          <a:lstStyle/>
+          <a:p>
+            <a:pPr algn="ctr"/>
+            <a:endParaRPr/>
+          </a:p>
+        </p:txBody>
+      </p:sp>
+      <p:sp>
+        <p:nvSpPr>
+          <p:cNvPr id="13" name="Rectangle 12"/>
+          <p:cNvSpPr/>
+          <p:nvPr/>
+        </p:nvSpPr>
+        <p:spPr>
+          <a:xfrm>
+            <a:off x="3026141" y="2231136"/>
+            <a:ext cx="2286000" cy="1298448"/>
+          </a:xfrm>
+          <a:prstGeom prst="rect">
+            <a:avLst/>
+          </a:prstGeom>
+          <a:solidFill>
+            <a:srgbClr val="EDF2FA"/>
+          </a:solidFill>
+          <a:ln>
+            <a:noFill/>
+          </a:ln>
+          <a:effectLst/>
+        </p:spPr>
+        <p:style>
+          <a:lnRef idx="1">
+            <a:schemeClr val="accent1"/>
+          </a:lnRef>
+          <a:fillRef idx="3">
+            <a:schemeClr val="accent1"/>
+          </a:fillRef>
+          <a:effectRef idx="2">
+            <a:schemeClr val="accent1"/>
+          </a:effectRef>
+          <a:fontRef idx="minor">
+            <a:schemeClr val="lt1"/>
+          </a:fontRef>
+        </p:style>
+        <p:txBody>
+          <a:bodyPr wrap="square" lIns="100584" tIns="73152" rIns="100584" bIns="73152" rtlCol="0" anchor="t"/>
+          <a:lstStyle/>
+          <a:p>
+            <a:pPr algn="l">
+              <a:spcAft>
+                <a:spcPts val="300"/>
+              </a:spcAft>
+            </a:pPr>
+            <a:r>
+              <a:rPr sz="1700" b="1">
+                <a:solidFill>
+                  <a:srgbClr val="4472C4"/>
+                </a:solidFill>
+                <a:latin typeface="Calibri"/>
+              </a:rPr>
+              <a:t>1749</a:t>
+            </a:r>
+          </a:p>
+          <a:p>
+            <a:pPr algn="l"/>
+            <a:r>
+              <a:rPr sz="1050">
+                <a:solidFill>
+                  <a:srgbClr val="262626"/>
+                </a:solidFill>
+                <a:latin typeface="Calibri"/>
+              </a:rPr>
+              <a:t>Gottfried Achenwall coins “Statistik” — literally the science of the state.</a:t>
+            </a:r>
+          </a:p>
+        </p:txBody>
+      </p:sp>
+      <p:sp>
+        <p:nvSpPr>
+          <p:cNvPr id="14" name="Rectangle 13"/>
+          <p:cNvSpPr/>
+          <p:nvPr/>
+        </p:nvSpPr>
+        <p:spPr>
+          <a:xfrm>
+            <a:off x="5443553" y="3913632"/>
+            <a:ext cx="20116" cy="384048"/>
+          </a:xfrm>
+          <a:prstGeom prst="rect">
+            <a:avLst/>
+          </a:prstGeom>
+          <a:solidFill>
+            <a:srgbClr val="4472C4"/>
+          </a:solidFill>
+          <a:ln>
+            <a:noFill/>
+          </a:ln>
+          <a:effectLst/>
+        </p:spPr>
+        <p:style>
+          <a:lnRef idx="1">
+            <a:schemeClr val="accent1"/>
+          </a:lnRef>
+          <a:fillRef idx="3">
+            <a:schemeClr val="accent1"/>
+          </a:fillRef>
+          <a:effectRef idx="2">
+            <a:schemeClr val="accent1"/>
+          </a:effectRef>
+          <a:fontRef idx="minor">
+            <a:schemeClr val="lt1"/>
+          </a:fontRef>
+        </p:style>
+        <p:txBody>
+          <a:bodyPr wrap="square" rtlCol="0" anchor="ctr"/>
+          <a:lstStyle/>
+          <a:p>
+            <a:pPr algn="ctr"/>
+            <a:endParaRPr/>
+          </a:p>
+        </p:txBody>
+      </p:sp>
+      <p:sp>
+        <p:nvSpPr>
+          <p:cNvPr id="15" name="Oval 14"/>
+          <p:cNvSpPr/>
+          <p:nvPr/>
+        </p:nvSpPr>
+        <p:spPr>
+          <a:xfrm>
+            <a:off x="5375888" y="3835908"/>
+            <a:ext cx="155448" cy="155448"/>
+          </a:xfrm>
+          <a:prstGeom prst="ellipse">
+            <a:avLst/>
+          </a:prstGeom>
+          <a:solidFill>
+            <a:srgbClr val="FFFFFF"/>
+          </a:solidFill>
+          <a:ln w="25400">
+            <a:solidFill>
+              <a:srgbClr val="4472C4"/>
+            </a:solidFill>
+          </a:ln>
+          <a:effectLst/>
+        </p:spPr>
+        <p:style>
+          <a:lnRef idx="1">
+            <a:schemeClr val="accent1"/>
+          </a:lnRef>
+          <a:fillRef idx="3">
+            <a:schemeClr val="accent1"/>
+          </a:fillRef>
+          <a:effectRef idx="2">
+            <a:schemeClr val="accent1"/>
+          </a:effectRef>
+          <a:fontRef idx="minor">
+            <a:schemeClr val="lt1"/>
+          </a:fontRef>
+        </p:style>
+        <p:txBody>
+          <a:bodyPr wrap="square" rtlCol="0" anchor="ctr"/>
+          <a:lstStyle/>
+          <a:p>
+            <a:pPr algn="ctr"/>
+            <a:endParaRPr/>
+          </a:p>
+        </p:txBody>
+      </p:sp>
+      <p:sp>
+        <p:nvSpPr>
+          <p:cNvPr id="16" name="Rectangle 15"/>
+          <p:cNvSpPr/>
+          <p:nvPr/>
+        </p:nvSpPr>
+        <p:spPr>
+          <a:xfrm>
+            <a:off x="4310612" y="4297680"/>
+            <a:ext cx="2286000" cy="1298448"/>
+          </a:xfrm>
+          <a:prstGeom prst="rect">
+            <a:avLst/>
+          </a:prstGeom>
+          <a:solidFill>
+            <a:srgbClr val="EDF2FA"/>
+          </a:solidFill>
+          <a:ln>
+            <a:noFill/>
+          </a:ln>
+          <a:effectLst/>
+        </p:spPr>
+        <p:style>
+          <a:lnRef idx="1">
+            <a:schemeClr val="accent1"/>
+          </a:lnRef>
+          <a:fillRef idx="3">
+            <a:schemeClr val="accent1"/>
+          </a:fillRef>
+          <a:effectRef idx="2">
+            <a:schemeClr val="accent1"/>
+          </a:effectRef>
+          <a:fontRef idx="minor">
+            <a:schemeClr val="lt1"/>
+          </a:fontRef>
+        </p:style>
+        <p:txBody>
+          <a:bodyPr wrap="square" lIns="100584" tIns="73152" rIns="100584" bIns="73152" rtlCol="0" anchor="t"/>
+          <a:lstStyle/>
+          <a:p>
+            <a:pPr algn="l">
+              <a:spcAft>
+                <a:spcPts val="300"/>
+              </a:spcAft>
+            </a:pPr>
+            <a:r>
+              <a:rPr sz="1700" b="1">
+                <a:solidFill>
+                  <a:srgbClr val="4472C4"/>
+                </a:solidFill>
+                <a:latin typeface="Calibri"/>
+              </a:rPr>
+              <a:t>1790</a:t>
+            </a:r>
+          </a:p>
+          <a:p>
+            <a:pPr algn="l"/>
+            <a:r>
+              <a:rPr sz="1050">
+                <a:solidFill>
+                  <a:srgbClr val="262626"/>
+                </a:solidFill>
+                <a:latin typeface="Calibri"/>
+              </a:rPr>
+              <a:t>The first U.S. census counts the population. Great Britain follows in 1801.</a:t>
+            </a:r>
+          </a:p>
+        </p:txBody>
+      </p:sp>
+      <p:sp>
+        <p:nvSpPr>
+          <p:cNvPr id="17" name="Rectangle 16"/>
+          <p:cNvSpPr/>
+          <p:nvPr/>
+        </p:nvSpPr>
+        <p:spPr>
+          <a:xfrm>
+            <a:off x="6728024" y="3529584"/>
+            <a:ext cx="20116" cy="384048"/>
+          </a:xfrm>
+          <a:prstGeom prst="rect">
+            <a:avLst/>
+          </a:prstGeom>
+          <a:solidFill>
+            <a:srgbClr val="4472C4"/>
+          </a:solidFill>
+          <a:ln>
+            <a:noFill/>
+          </a:ln>
+          <a:effectLst/>
+        </p:spPr>
+        <p:style>
+          <a:lnRef idx="1">
+            <a:schemeClr val="accent1"/>
+          </a:lnRef>
+          <a:fillRef idx="3">
+            <a:schemeClr val="accent1"/>
+          </a:fillRef>
+          <a:effectRef idx="2">
+            <a:schemeClr val="accent1"/>
+          </a:effectRef>
+          <a:fontRef idx="minor">
+            <a:schemeClr val="lt1"/>
+          </a:fontRef>
+        </p:style>
+        <p:txBody>
+          <a:bodyPr wrap="square" rtlCol="0" anchor="ctr"/>
+          <a:lstStyle/>
+          <a:p>
+            <a:pPr algn="ctr"/>
+            <a:endParaRPr/>
+          </a:p>
+        </p:txBody>
+      </p:sp>
+      <p:sp>
+        <p:nvSpPr>
+          <p:cNvPr id="18" name="Oval 17"/>
+          <p:cNvSpPr/>
+          <p:nvPr/>
+        </p:nvSpPr>
+        <p:spPr>
+          <a:xfrm>
+            <a:off x="6660358" y="3835908"/>
+            <a:ext cx="155448" cy="155448"/>
+          </a:xfrm>
+          <a:prstGeom prst="ellipse">
+            <a:avLst/>
+          </a:prstGeom>
+          <a:solidFill>
+            <a:srgbClr val="FFFFFF"/>
+          </a:solidFill>
+          <a:ln w="25400">
+            <a:solidFill>
+              <a:srgbClr val="4472C4"/>
+            </a:solidFill>
+          </a:ln>
+          <a:effectLst/>
+        </p:spPr>
+        <p:style>
+          <a:lnRef idx="1">
+            <a:schemeClr val="accent1"/>
+          </a:lnRef>
+          <a:fillRef idx="3">
+            <a:schemeClr val="accent1"/>
+          </a:fillRef>
+          <a:effectRef idx="2">
+            <a:schemeClr val="accent1"/>
+          </a:effectRef>
+          <a:fontRef idx="minor">
+            <a:schemeClr val="lt1"/>
+          </a:fontRef>
+        </p:style>
+        <p:txBody>
+          <a:bodyPr wrap="square" rtlCol="0" anchor="ctr"/>
+          <a:lstStyle/>
+          <a:p>
+            <a:pPr algn="ctr"/>
+            <a:endParaRPr/>
+          </a:p>
+        </p:txBody>
+      </p:sp>
+      <p:sp>
+        <p:nvSpPr>
+          <p:cNvPr id="19" name="Rectangle 18"/>
+          <p:cNvSpPr/>
+          <p:nvPr/>
+        </p:nvSpPr>
+        <p:spPr>
+          <a:xfrm>
+            <a:off x="5595082" y="2231136"/>
+            <a:ext cx="2286000" cy="1298448"/>
+          </a:xfrm>
+          <a:prstGeom prst="rect">
+            <a:avLst/>
+          </a:prstGeom>
+          <a:solidFill>
+            <a:srgbClr val="EDF2FA"/>
+          </a:solidFill>
+          <a:ln>
+            <a:noFill/>
+          </a:ln>
+          <a:effectLst/>
+        </p:spPr>
+        <p:style>
+          <a:lnRef idx="1">
+            <a:schemeClr val="accent1"/>
+          </a:lnRef>
+          <a:fillRef idx="3">
+            <a:schemeClr val="accent1"/>
+          </a:fillRef>
+          <a:effectRef idx="2">
+            <a:schemeClr val="accent1"/>
+          </a:effectRef>
+          <a:fontRef idx="minor">
+            <a:schemeClr val="lt1"/>
+          </a:fontRef>
+        </p:style>
+        <p:txBody>
+          <a:bodyPr wrap="square" lIns="100584" tIns="73152" rIns="100584" bIns="73152" rtlCol="0" anchor="t"/>
+          <a:lstStyle/>
+          <a:p>
+            <a:pPr algn="l">
+              <a:spcAft>
+                <a:spcPts val="300"/>
+              </a:spcAft>
+            </a:pPr>
+            <a:r>
+              <a:rPr sz="1700" b="1">
+                <a:solidFill>
+                  <a:srgbClr val="4472C4"/>
+                </a:solidFill>
+                <a:latin typeface="Calibri"/>
+              </a:rPr>
+              <a:t>1830s</a:t>
+            </a:r>
+          </a:p>
+          <a:p>
+            <a:pPr algn="l"/>
+            <a:r>
+              <a:rPr sz="1050">
+                <a:solidFill>
+                  <a:srgbClr val="262626"/>
+                </a:solidFill>
+                <a:latin typeface="Calibri"/>
+              </a:rPr>
+              <a:t>Adolphe Quetelet applies the normal curve to human traits and invents “the average man.”</a:t>
+            </a:r>
+          </a:p>
+        </p:txBody>
+      </p:sp>
+      <p:sp>
+        <p:nvSpPr>
+          <p:cNvPr id="20" name="Rectangle 19"/>
+          <p:cNvSpPr/>
+          <p:nvPr/>
+        </p:nvSpPr>
+        <p:spPr>
+          <a:xfrm>
+            <a:off x="8012495" y="3913632"/>
+            <a:ext cx="20116" cy="384048"/>
+          </a:xfrm>
+          <a:prstGeom prst="rect">
+            <a:avLst/>
+          </a:prstGeom>
+          <a:solidFill>
+            <a:srgbClr val="4472C4"/>
+          </a:solidFill>
+          <a:ln>
+            <a:noFill/>
+          </a:ln>
+          <a:effectLst/>
+        </p:spPr>
+        <p:style>
+          <a:lnRef idx="1">
+            <a:schemeClr val="accent1"/>
+          </a:lnRef>
+          <a:fillRef idx="3">
+            <a:schemeClr val="accent1"/>
+          </a:fillRef>
+          <a:effectRef idx="2">
+            <a:schemeClr val="accent1"/>
+          </a:effectRef>
+          <a:fontRef idx="minor">
+            <a:schemeClr val="lt1"/>
+          </a:fontRef>
+        </p:style>
+        <p:txBody>
+          <a:bodyPr wrap="square" rtlCol="0" anchor="ctr"/>
+          <a:lstStyle/>
+          <a:p>
+            <a:pPr algn="ctr"/>
+            <a:endParaRPr/>
+          </a:p>
+        </p:txBody>
+      </p:sp>
+      <p:sp>
+        <p:nvSpPr>
+          <p:cNvPr id="21" name="Oval 20"/>
+          <p:cNvSpPr/>
+          <p:nvPr/>
+        </p:nvSpPr>
+        <p:spPr>
+          <a:xfrm>
+            <a:off x="7944829" y="3835908"/>
+            <a:ext cx="155448" cy="155448"/>
+          </a:xfrm>
+          <a:prstGeom prst="ellipse">
+            <a:avLst/>
+          </a:prstGeom>
+          <a:solidFill>
+            <a:srgbClr val="FFFFFF"/>
+          </a:solidFill>
+          <a:ln w="25400">
+            <a:solidFill>
+              <a:srgbClr val="4472C4"/>
+            </a:solidFill>
+          </a:ln>
+          <a:effectLst/>
+        </p:spPr>
+        <p:style>
+          <a:lnRef idx="1">
+            <a:schemeClr val="accent1"/>
+          </a:lnRef>
+          <a:fillRef idx="3">
+            <a:schemeClr val="accent1"/>
+          </a:fillRef>
+          <a:effectRef idx="2">
+            <a:schemeClr val="accent1"/>
+          </a:effectRef>
+          <a:fontRef idx="minor">
+            <a:schemeClr val="lt1"/>
+          </a:fontRef>
+        </p:style>
+        <p:txBody>
+          <a:bodyPr wrap="square" rtlCol="0" anchor="ctr"/>
+          <a:lstStyle/>
+          <a:p>
+            <a:pPr algn="ctr"/>
+            <a:endParaRPr/>
+          </a:p>
+        </p:txBody>
+      </p:sp>
+      <p:sp>
+        <p:nvSpPr>
+          <p:cNvPr id="22" name="Rectangle 21"/>
+          <p:cNvSpPr/>
+          <p:nvPr/>
+        </p:nvSpPr>
+        <p:spPr>
+          <a:xfrm>
+            <a:off x="6879553" y="4297680"/>
+            <a:ext cx="2286000" cy="1298448"/>
+          </a:xfrm>
+          <a:prstGeom prst="rect">
+            <a:avLst/>
+          </a:prstGeom>
+          <a:solidFill>
+            <a:srgbClr val="EDF2FA"/>
+          </a:solidFill>
+          <a:ln>
+            <a:noFill/>
+          </a:ln>
+          <a:effectLst/>
+        </p:spPr>
+        <p:style>
+          <a:lnRef idx="1">
+            <a:schemeClr val="accent1"/>
+          </a:lnRef>
+          <a:fillRef idx="3">
+            <a:schemeClr val="accent1"/>
+          </a:fillRef>
+          <a:effectRef idx="2">
+            <a:schemeClr val="accent1"/>
+          </a:effectRef>
+          <a:fontRef idx="minor">
+            <a:schemeClr val="lt1"/>
+          </a:fontRef>
+        </p:style>
+        <p:txBody>
+          <a:bodyPr wrap="square" lIns="100584" tIns="73152" rIns="100584" bIns="73152" rtlCol="0" anchor="t"/>
+          <a:lstStyle/>
+          <a:p>
+            <a:pPr algn="l">
+              <a:spcAft>
+                <a:spcPts val="300"/>
+              </a:spcAft>
+            </a:pPr>
+            <a:r>
+              <a:rPr sz="1700" b="1">
+                <a:solidFill>
+                  <a:srgbClr val="4472C4"/>
+                </a:solidFill>
+                <a:latin typeface="Calibri"/>
+              </a:rPr>
+              <a:t>1900</a:t>
+            </a:r>
+          </a:p>
+          <a:p>
+            <a:pPr algn="l"/>
+            <a:r>
+              <a:rPr sz="1050">
+                <a:solidFill>
+                  <a:srgbClr val="262626"/>
+                </a:solidFill>
+                <a:latin typeface="Calibri"/>
+              </a:rPr>
+              <a:t>Galton and Pearson develop correlation, regression, and the chi-square test.</a:t>
+            </a:r>
+          </a:p>
+        </p:txBody>
+      </p:sp>
+      <p:sp>
+        <p:nvSpPr>
+          <p:cNvPr id="23" name="Rectangle 22"/>
+          <p:cNvSpPr/>
+          <p:nvPr/>
+        </p:nvSpPr>
+        <p:spPr>
+          <a:xfrm>
+            <a:off x="9296966" y="3529584"/>
+            <a:ext cx="20116" cy="384048"/>
+          </a:xfrm>
+          <a:prstGeom prst="rect">
+            <a:avLst/>
+          </a:prstGeom>
+          <a:solidFill>
+            <a:srgbClr val="4472C4"/>
+          </a:solidFill>
+          <a:ln>
+            <a:noFill/>
+          </a:ln>
+          <a:effectLst/>
+        </p:spPr>
+        <p:style>
+          <a:lnRef idx="1">
+            <a:schemeClr val="accent1"/>
+          </a:lnRef>
+          <a:fillRef idx="3">
+            <a:schemeClr val="accent1"/>
+          </a:fillRef>
+          <a:effectRef idx="2">
+            <a:schemeClr val="accent1"/>
+          </a:effectRef>
+          <a:fontRef idx="minor">
+            <a:schemeClr val="lt1"/>
+          </a:fontRef>
+        </p:style>
+        <p:txBody>
+          <a:bodyPr wrap="square" rtlCol="0" anchor="ctr"/>
+          <a:lstStyle/>
+          <a:p>
+            <a:pPr algn="ctr"/>
+            <a:endParaRPr/>
+          </a:p>
+        </p:txBody>
+      </p:sp>
+      <p:sp>
+        <p:nvSpPr>
+          <p:cNvPr id="24" name="Oval 23"/>
+          <p:cNvSpPr/>
+          <p:nvPr/>
+        </p:nvSpPr>
+        <p:spPr>
+          <a:xfrm>
+            <a:off x="9229300" y="3835908"/>
+            <a:ext cx="155448" cy="155448"/>
+          </a:xfrm>
+          <a:prstGeom prst="ellipse">
+            <a:avLst/>
+          </a:prstGeom>
+          <a:solidFill>
+            <a:srgbClr val="FFFFFF"/>
+          </a:solidFill>
+          <a:ln w="25400">
+            <a:solidFill>
+              <a:srgbClr val="4472C4"/>
+            </a:solidFill>
+          </a:ln>
+          <a:effectLst/>
+        </p:spPr>
+        <p:style>
+          <a:lnRef idx="1">
+            <a:schemeClr val="accent1"/>
+          </a:lnRef>
+          <a:fillRef idx="3">
+            <a:schemeClr val="accent1"/>
+          </a:fillRef>
+          <a:effectRef idx="2">
+            <a:schemeClr val="accent1"/>
+          </a:effectRef>
+          <a:fontRef idx="minor">
+            <a:schemeClr val="lt1"/>
+          </a:fontRef>
+        </p:style>
+        <p:txBody>
+          <a:bodyPr wrap="square" rtlCol="0" anchor="ctr"/>
+          <a:lstStyle/>
+          <a:p>
+            <a:pPr algn="ctr"/>
+            <a:endParaRPr/>
+          </a:p>
+        </p:txBody>
+      </p:sp>
+      <p:sp>
+        <p:nvSpPr>
+          <p:cNvPr id="25" name="Rectangle 24"/>
+          <p:cNvSpPr/>
+          <p:nvPr/>
+        </p:nvSpPr>
+        <p:spPr>
+          <a:xfrm>
+            <a:off x="8164024" y="2231136"/>
+            <a:ext cx="2286000" cy="1298448"/>
+          </a:xfrm>
+          <a:prstGeom prst="rect">
+            <a:avLst/>
+          </a:prstGeom>
+          <a:solidFill>
+            <a:srgbClr val="EDF2FA"/>
+          </a:solidFill>
+          <a:ln>
+            <a:noFill/>
+          </a:ln>
+          <a:effectLst/>
+        </p:spPr>
+        <p:style>
+          <a:lnRef idx="1">
+            <a:schemeClr val="accent1"/>
+          </a:lnRef>
+          <a:fillRef idx="3">
+            <a:schemeClr val="accent1"/>
+          </a:fillRef>
+          <a:effectRef idx="2">
+            <a:schemeClr val="accent1"/>
+          </a:effectRef>
+          <a:fontRef idx="minor">
+            <a:schemeClr val="lt1"/>
+          </a:fontRef>
+        </p:style>
+        <p:txBody>
+          <a:bodyPr wrap="square" lIns="100584" tIns="73152" rIns="100584" bIns="73152" rtlCol="0" anchor="t"/>
+          <a:lstStyle/>
+          <a:p>
+            <a:pPr algn="l">
+              <a:spcAft>
+                <a:spcPts val="300"/>
+              </a:spcAft>
+            </a:pPr>
+            <a:r>
+              <a:rPr sz="1700" b="1">
+                <a:solidFill>
+                  <a:srgbClr val="4472C4"/>
+                </a:solidFill>
+                <a:latin typeface="Calibri"/>
+              </a:rPr>
+              <a:t>1925</a:t>
+            </a:r>
+          </a:p>
+          <a:p>
+            <a:pPr algn="l"/>
+            <a:r>
+              <a:rPr sz="1050">
+                <a:solidFill>
+                  <a:srgbClr val="262626"/>
+                </a:solidFill>
+                <a:latin typeface="Calibri"/>
+              </a:rPr>
+              <a:t>R. A. Fisher formalizes experimental design, ANOVA, and significance testing.</a:t>
+            </a:r>
+          </a:p>
+        </p:txBody>
+      </p:sp>
+      <p:sp>
+        <p:nvSpPr>
+          <p:cNvPr id="26" name="Rectangle 25"/>
+          <p:cNvSpPr/>
+          <p:nvPr/>
+        </p:nvSpPr>
+        <p:spPr>
+          <a:xfrm>
+            <a:off x="10581436" y="3913632"/>
+            <a:ext cx="20116" cy="384048"/>
+          </a:xfrm>
+          <a:prstGeom prst="rect">
+            <a:avLst/>
+          </a:prstGeom>
+          <a:solidFill>
+            <a:srgbClr val="C5540F"/>
+          </a:solidFill>
+          <a:ln>
+            <a:noFill/>
+          </a:ln>
+          <a:effectLst/>
+        </p:spPr>
+        <p:style>
+          <a:lnRef idx="1">
+            <a:schemeClr val="accent1"/>
+          </a:lnRef>
+          <a:fillRef idx="3">
+            <a:schemeClr val="accent1"/>
+          </a:fillRef>
+          <a:effectRef idx="2">
+            <a:schemeClr val="accent1"/>
+          </a:effectRef>
+          <a:fontRef idx="minor">
+            <a:schemeClr val="lt1"/>
+          </a:fontRef>
+        </p:style>
+        <p:txBody>
+          <a:bodyPr wrap="square" rtlCol="0" anchor="ctr"/>
+          <a:lstStyle/>
+          <a:p>
+            <a:pPr algn="ctr"/>
+            <a:endParaRPr/>
+          </a:p>
+        </p:txBody>
+      </p:sp>
+      <p:sp>
+        <p:nvSpPr>
+          <p:cNvPr id="27" name="Oval 26"/>
+          <p:cNvSpPr/>
+          <p:nvPr/>
+        </p:nvSpPr>
+        <p:spPr>
+          <a:xfrm>
+            <a:off x="10513771" y="3835908"/>
+            <a:ext cx="155448" cy="155448"/>
+          </a:xfrm>
+          <a:prstGeom prst="ellipse">
+            <a:avLst/>
+          </a:prstGeom>
+          <a:solidFill>
+            <a:srgbClr val="FFFFFF"/>
+          </a:solidFill>
+          <a:ln w="25400">
+            <a:solidFill>
+              <a:srgbClr val="C5540F"/>
+            </a:solidFill>
+          </a:ln>
+          <a:effectLst/>
+        </p:spPr>
+        <p:style>
+          <a:lnRef idx="1">
+            <a:schemeClr val="accent1"/>
+          </a:lnRef>
+          <a:fillRef idx="3">
+            <a:schemeClr val="accent1"/>
+          </a:fillRef>
+          <a:effectRef idx="2">
+            <a:schemeClr val="accent1"/>
+          </a:effectRef>
+          <a:fontRef idx="minor">
+            <a:schemeClr val="lt1"/>
+          </a:fontRef>
+        </p:style>
+        <p:txBody>
+          <a:bodyPr wrap="square" rtlCol="0" anchor="ctr"/>
+          <a:lstStyle/>
+          <a:p>
+            <a:pPr algn="ctr"/>
+            <a:endParaRPr/>
+          </a:p>
+        </p:txBody>
+      </p:sp>
+      <p:sp>
+        <p:nvSpPr>
+          <p:cNvPr id="28" name="Rectangle 27"/>
+          <p:cNvSpPr/>
+          <p:nvPr/>
+        </p:nvSpPr>
+        <p:spPr>
+          <a:xfrm>
+            <a:off x="9448495" y="4297680"/>
+            <a:ext cx="2286000" cy="1298448"/>
+          </a:xfrm>
+          <a:prstGeom prst="rect">
+            <a:avLst/>
+          </a:prstGeom>
+          <a:solidFill>
+            <a:srgbClr val="FCE6D5"/>
+          </a:solidFill>
+          <a:ln>
+            <a:noFill/>
+          </a:ln>
+          <a:effectLst/>
+        </p:spPr>
+        <p:style>
+          <a:lnRef idx="1">
+            <a:schemeClr val="accent1"/>
+          </a:lnRef>
+          <a:fillRef idx="3">
+            <a:schemeClr val="accent1"/>
+          </a:fillRef>
+          <a:effectRef idx="2">
+            <a:schemeClr val="accent1"/>
+          </a:effectRef>
+          <a:fontRef idx="minor">
+            <a:schemeClr val="lt1"/>
+          </a:fontRef>
+        </p:style>
+        <p:txBody>
+          <a:bodyPr wrap="square" lIns="100584" tIns="73152" rIns="100584" bIns="73152" rtlCol="0" anchor="t"/>
+          <a:lstStyle/>
+          <a:p>
+            <a:pPr algn="l">
+              <a:spcAft>
+                <a:spcPts val="300"/>
+              </a:spcAft>
+            </a:pPr>
+            <a:r>
+              <a:rPr sz="1700" b="1">
+                <a:solidFill>
+                  <a:srgbClr val="C5540F"/>
+                </a:solidFill>
+                <a:latin typeface="Calibri"/>
+              </a:rPr>
+              <a:t>Today</a:t>
+            </a:r>
+          </a:p>
+          <a:p>
+            <a:pPr algn="l"/>
+            <a:r>
+              <a:rPr sz="1050">
+                <a:solidFill>
+                  <a:srgbClr val="262626"/>
+                </a:solidFill>
+                <a:latin typeface="Calibri"/>
+              </a:rPr>
+              <a:t>The same ideas, now run by computers on data far larger than Graunt could count.</a:t>
+            </a:r>
+          </a:p>
+        </p:txBody>
+      </p:sp>
+      <p:sp>
+        <p:nvSpPr>
+          <p:cNvPr id="29" name="TextBox 28"/>
+          <p:cNvSpPr txBox="1"/>
+          <p:nvPr/>
+        </p:nvSpPr>
+        <p:spPr>
+          <a:xfrm>
+            <a:off x="457200" y="6144768"/>
+            <a:ext cx="11292840" cy="566928"/>
+          </a:xfrm>
+          <a:prstGeom prst="rect">
+            <a:avLst/>
+          </a:prstGeom>
+          <a:noFill/>
+        </p:spPr>
+        <p:txBody>
+          <a:bodyPr wrap="square" lIns="0" tIns="0" rIns="0" bIns="0" anchor="t">
+            <a:spAutoFit/>
+          </a:bodyPr>
+          <a:lstStyle/>
+          <a:p>
+            <a:pPr algn="l">
+              <a:spcAft>
+                <a:spcPts val="0"/>
+              </a:spcAft>
+            </a:pPr>
+            <a:r>
+              <a:rPr sz="900" b="0">
+                <a:solidFill>
+                  <a:srgbClr val="595959"/>
+                </a:solidFill>
+                <a:latin typeface="Calibri"/>
+              </a:rPr>
+              <a:t>Sources: J. Graunt (1662), Natural and Political Observations Made upon the Bills of Mortality. E. Halley (1693), Phil. Trans. R. Soc. 17:596–610. G. Achenwall (1749), Abriss der neuesten Staatswissenschaft. A. Quetelet (1835), Sur l’homme et le développement de ses facultés. R. A. Fisher (1925), Statistical Methods for Research Workers.</a:t>
+            </a:r>
+          </a:p>
+        </p:txBody>
+      </p:sp>
+    </p:spTree>
   </p:cSld>
   <p:clrMapOvr>
     <a:masterClrMapping/>

</xml_diff>